<commit_message>
Update Part 1 slides and diagram for the 70/30 live split
Figure 1 owner is now Dat 722I0004; slides carry the full speaker script
in the notes, and slide 13 shows the saved order more clearly.

Co-Authored-By: Claude Opus 5.5 <noreply@anthropic.com>
</commit_message>
<xml_diff>
--- a/docs/part1/Team02_Proposal_Slides_for_SaigonBite.pptx
+++ b/docs/part1/Team02_Proposal_Slides_for_SaigonBite.pptx
@@ -516,11 +516,9 @@
           <a:p>
             <a:r>
               <a:rPr lang="en-US" dirty="0"/>
-              <a:t>Speaker: Dat
-Time: 0:00-0:25
-- Introduce both names and the case: SaigonBite, cloud kitchens in Ho Chi Minh City.
-- The next eight minutes cover the business process, ownership, six iterations, the Iteration 1 plan and result, risks and questions.
-- Quan takes the business process and the actors.</a:t>
+              <a:t>Speaker: Dat · Time: 0:00–0:21
+Hello everyone. We are Team 02. I am Dat, and this is Quan. Our project is SaigonBite, an online food delivery hub platform for cloud kitchens in Ho Chi Minh City. Today we show the process, the plan, the result, the risks, and our questions.
+Cue: Click: slide 2.</a:t>
             </a:r>
             <a:endParaRPr lang="en-US" dirty="0"/>
           </a:p>
@@ -608,12 +606,9 @@
           <a:p>
             <a:r>
               <a:rPr lang="en-US" dirty="0"/>
-              <a:t>Speaker: Dat
-Time: 4:25-4:55
-- Six iterations; each analyses, designs, builds and tests a working increment and ends with a joint review by both of us.
-- Why iterative: capacity, fees and report definitions come from the client later; four use cases share one order; deadlines are fixed.
-- Stack decided: Python 3.12 or later (the Iteration 1 code was tested on 3.13); both strongest in Python; hand-written SQL in DAOs supports the database mapping and SQL sections; SQLite needs no server.
-- Three layers, four roles: View, Controller, Domain, DAO. One application, one database.</a:t>
+              <a:t>Speaker: Quan · Time: 5:37–6:26
+Our approach is the iterative Unified Process, with six short iterations. Each one has analysis, design, build, test and a joint review. We chose it for four reasons. Client answers arrive later. The four use cases share one Order record. The deadlines are fixed, and we are only two people. And we do the riskiest parts first: capacity in Iteration 2, payment in Iteration 3. Our stack is Python 3.12 or later, Flask, sqlite3 with hand-written SQL, SQLite, pytest and Flask-Login. We chose Python because we are both strongest in it, and SQLite needs no server. The design has three layers. Back to Dat for the plan.
+Cue: HAND-OVER 2. Say the last line, click: slide 11. Dat takes the clicker.</a:t>
             </a:r>
             <a:endParaRPr lang="en-US" dirty="0"/>
           </a:p>
@@ -701,12 +696,9 @@
           <a:p>
             <a:r>
               <a:rPr lang="en-US" dirty="0"/>
-              <a:t>Speaker: Dat
-Time: 4:55-5:45
-- One phrase per iteration: I1 persisted COD order; I2 hub CRUD, capacity rule, Kitchen board; I3 full ordering and delivery; I4 reports, integrated demo, Figma; I5 final models, tests, deployment, Part 2 report (tag v0.9-part2); I6 feedback fixes, v1.0-final, Part 3.
-- Milestones: 26/10 live Part 1; 31/10 lecturer answers L1 to L4; 12/11 feature freeze; 13/11 I5 buffer day; 15/11 and 16/11 Part 2; 29/11 and 30/11 Part 3.
-- Contingency before Part 2: if L1 is rejected the generic admin fallback (about 12 person-hours per class) is built in I3 and I4 from the I3 to I5 buffers. I6 is not a rescue buffer for Part 2 content.
-- One exit check per iteration, for example the capacity boundary test in I2. Effort: 4 hours per student per day; Dat about 61 % of the build hours, Quan about 39 %.</a:t>
+              <a:t>Speaker: Dat · Time: 6:26–6:48
+Thank you, Quan. This is our roadmap with real dates. Iteration 1 runs from 17 to 22 October. Part 2 is due on 15 November. We keep three contingency points: lecturer answers by 31 October, feature freeze on 12 November, and a buffer day on 13 November.
+Cue: Click: slide 12.</a:t>
             </a:r>
             <a:endParaRPr lang="en-US" dirty="0"/>
           </a:p>
@@ -794,13 +786,9 @@
           <a:p>
             <a:r>
               <a:rPr lang="en-US" dirty="0"/>
-              <a:t>Speaker: Dat
-Time: 5:45-6:35
-- D1 Sat 17/10: identify the problem and plan. Dat writes the vision, backlog and UC-01 stories; Quan sets up the repository, Flask skeleton, init_db.py, events and actors.
-- D2 and D3: discover, then design. Dat writes the UC-01 description, activity, SSD and Order state machine; Quan the domain model, CRUD inventory, schema, seed and UC-02 draft.
-- D4 and D5: build, test, integrate. Controller, DAOs, checkout page; pytest including invalid input and a double submit; role checks on the server.
-- D6 Thu 22/10: second-machine run on Quan's laptop and the Iteration 1 review.
-- Acceptance: a COD order saved and read back with the same total on a second machine (AC-1 to AC-9).</a:t>
+              <a:t>Speaker: Dat · Time: 6:48–7:05
+Iteration 1 runs the six core processes in six days. Each day has a task for each of us, and evidence at the end. At four hours per student per day, the plan is 48 person-hours.
+Cue: Click: slide 13.</a:t>
             </a:r>
             <a:endParaRPr lang="en-US" dirty="0"/>
           </a:p>
@@ -888,14 +876,9 @@
           <a:p>
             <a:r>
               <a:rPr lang="en-US" dirty="0"/>
-              <a:t>Speaker: Dat
-Time: 6:35-7:15
-- Real figures only. Say plainly: Iteration 1 was built early, on 19/10, with AI assistance (Claude), not over the six planned days; the team review of the code is still to do.
-- Acceptance criteria: 7 of 9 met; AC-1 (same-machine clone only) and AC-9 (no activity diagram, no review) partial, 19/10
-- pytest: 81 passed, 0 failed - 19/10/2026, commit 049673d (tag i1-evidence). The screenshot is the saved order read back: ID 1, PLACED, COD, total 160,000 VND.
-- Second-machine run on Quan's laptop: ⟦ACTUAL second_machine_result: result and problems found on Quan's laptop⟧. Person-hours of the two of us: ⟦ACTUAL hours_human: hours logged by Dat and Quan⟧.
-- Lesson that changed the plan: ⟦ACTUAL lesson_learned: lesson from Iteration 1⟧
-- Use the real hours figure to re-check the Iteration 2 load.</a:t>
+              <a:t>Speaker: Dat · Time: 7:05–7:36
+Now the result. We built Iteration 1 early, on 19 October, with AI assistance. 81 tests passed and none failed, at commit 049673d. We met 7 of 9 criteria. AC-1 and AC-9 are partial. The saved order is on the right. Hours, the second machine and the lesson are still empty. We will report on D6 on 22 October. Our review of the code is still to do.
+Cue: Click: slide 14. (Optional 30-second demo instead, see the end of this file.)</a:t>
             </a:r>
             <a:endParaRPr lang="en-US" dirty="0"/>
           </a:p>
@@ -983,13 +966,9 @@
           <a:p>
             <a:r>
               <a:rPr lang="en-US" dirty="0"/>
-              <a:t>Speaker: Dat
-Time: 7:15-7:50
-- R-03 capacity race: two orders accepted past capacity. Count and insert in one SQLite BEGIN IMMEDIATE transaction, plus a boundary test.
-- R-02 rules unconfirmed: every rule is in the Assumption Log with its question; thresholds and fees sit in configuration.
-- R-01 CRUD coverage: lecturer answers by 31/10; fallback is one generic admin pattern at about 12 person-hours per class, built in I3 and I4 from the I3 to I5 buffers.
-- R-04 integration drift: Dat is integration lead and runs the demo scenario at the end of I3 and I4; Quan keeps the shared schema and seed. R-05: Quan; cross-review, both can run the repo, freeze 12/11, buffer day 13/11.
-- US-15 quiet-hub incentive is a Must in minimal form: one configurable delivery-fee discount; advanced variants are Should.</a:t>
+              <a:t>Speaker: Dat · Time: 7:36–7:56
+Our biggest risks are unconfirmed rules and the capacity race. For the race, we count and insert in one transaction, and we test the boundary. For the rules, every rule is in the Assumption Log, with values in configuration. Every risk has an owner.
+Cue: Click: slide 15.</a:t>
             </a:r>
             <a:endParaRPr lang="en-US" dirty="0"/>
           </a:p>
@@ -1077,12 +1056,9 @@
           <a:p>
             <a:r>
               <a:rPr lang="en-US" dirty="0"/>
-              <a:t>Speaker: Dat
-Time: 7:50-8:30
-- Ten assumptions are logged with owner and status: A-01 to A-09 proposed (A-02 to A-09 each tied to a client or lecturer question); A-10, the live presentation, confirmed verbally by the lecturer.
-- Each client question asks for one decision with our default: Q1 busy at or above hub capacity, plus the quiet-hub incentive figures; Q2 straight-line km, base fee plus per km; Q3 cancel while PLACED or CONFIRMED, COD voided, online REFUND_PENDING; Q4 local e-wallet or bank QR, tourist card; Q5 delivered date.
-- Ask the lecturer L1 to L4: CRUD by analysis plus seed (and which classes if not), the payment stub, deferral of complaint, refund and rating, and Python (3.12 or later; Iteration 1 tested on 3.13). We need the answers by Saturday 31/10 so any extra build fits before the Part 2 report.
-- Close: Iteration 2 starts 27/10 with hub CRUD and the capacity rule. Thank the panel and invite questions.</a:t>
+              <a:t>Speaker: Dat · Time: 7:56–8:16
+We need decisions: five from the client, each with our default, and four from the lecturer. Please answer by 31 October. Iteration 2 starts on 27 October with hub CRUD and the capacity rule. Thank you. We are happy to take your questions.
+Cue: End. Stop on slide 15 and take questions.</a:t>
             </a:r>
             <a:endParaRPr lang="en-US" dirty="0"/>
           </a:p>
@@ -1170,13 +1146,9 @@
           <a:p>
             <a:r>
               <a:rPr lang="en-US" dirty="0"/>
-              <a:t>Speaker: Dat
-Time: 0:25-1:15
-- Lunch peak: customers wait an hour at one hub while a nearby hub is almost idle; nobody outside the kitchen can see the load.
-- Menus change but the apps do not, so staff phone customers. Cash reaches the hub at day end, sometimes with mistakes. Tourists cannot order at all.
-- Vision: one order record, visible workload, clear hand-overs, reports from the same data.
-- Say plainly that the benefits are targets; the system records timestamps from Iteration 3 so they can be measured.
-- HAND-OVER 1 (Dat to Quan): now Quan takes the business process.</a:t>
+              <a:t>Speaker: Dat · Time: 0:21–1:06
+First, the problem. Paper tickets and chat hide the queue. At lunch time, one hub has a long queue, and a hub nearby is almost empty. Nobody outside the kitchen can see this. Menus change, but the apps do not, so staff phone the customers. Cash reaches the hub late, sometimes with mistakes. Tourists cannot register or pay. Our vision is one shared platform: one order record, a visible workload for each hub, and reports from the same data. These benefits are targets. We have not measured them yet. Timestamps from Iteration 3 will let us measure them.
+Cue: Click: slide 3.</a:t>
             </a:r>
             <a:endParaRPr lang="en-US" dirty="0"/>
           </a:p>
@@ -1264,13 +1236,9 @@
           <a:p>
             <a:r>
               <a:rPr lang="en-US" dirty="0"/>
-              <a:t>Speaker: Quan
-Time: 1:15-1:35
-- Framing: orientation map; zones A to D run left to right, and the next four slides zoom into each zone.
-- Quan takes over. One order record that every role can see.
-- The whole process on one slide: five lanes, Customer, OFDH platform, Kitchen staff, Shipper, Office staff / Manager. No need to read it.
-- Four zones, A to D, each shown next for about 25 seconds. Red marks failure or exception paths; grey marks actions that are in the process but not built in this release (A-08, A-09). The small framed activity at the bottom left is the reports activity, part of zone D.
-- Caption: AI-assisted, owner Quan 523K0049 (Appendix A).</a:t>
+              <a:t>Speaker: Dat · Time: 1:06–1:32
+This is the whole business process on one page. One order crosses five roles: customer, platform, kitchen, shipper, and office staff or manager. You do not need to read it. We split it into four zones, A to D, and zoom in on each one. Red is a failure path. Grey is not built in this release.
+Cue: Click: slide 4 (zone A).</a:t>
             </a:r>
             <a:endParaRPr lang="en-US" dirty="0"/>
           </a:p>
@@ -1358,13 +1326,9 @@
           <a:p>
             <a:r>
               <a:rPr lang="en-US" dirty="0"/>
-              <a:t>Speaker: Quan
-Time: 1:35-2:00
-- Framing: Order, quote and payment: a failed online payment returns to retry or COD.
-- Customer browses, picks a hub and adds items. The first merge joins the start and the loop back from the quieter-hub suggestion.
-- If the hub is busy the platform suggests a quieter hub and the customer chooses again. Not busy: quote with delivery fee and voucher, then cash on delivery or the online stub.
-- A failed online payment returns to retry or COD, so no order is created. Otherwise the platform creates the order as PLACED and notifies the hub.
-- Quan prep, merge vs join: a merge brings alternative paths together and nothing waits; a join waits for every parallel flow. A decision node takes one incoming flow, so paths merge first. Dat backs up.</a:t>
+              <a:t>Speaker: Dat · Time: 1:32–2:06
+Zone A: order, quote and payment. The customer picks a hub and items. If the hub is busy, the platform suggests a quieter hub, and the customer chooses again. Then the customer sees the fee and the voucher, and pays cash on delivery or online. If online payment fails, the customer retries or switches to cash, and no order is created. Otherwise, the platform creates the order as PLACED and tells the hub.
+Cue: Click: slide 5 (zone B).</a:t>
             </a:r>
             <a:endParaRPr lang="en-US" dirty="0"/>
           </a:p>
@@ -1452,14 +1416,9 @@
           <a:p>
             <a:r>
               <a:rPr lang="en-US" dirty="0"/>
-              <a:t>Speaker: Quan
-Time: 2:00-2:25
-- Framing: Kitchen: out of stock means replace with consent, or reject.
-- Kitchen checks stock. An item that ran out: the kitchen offers a replacement and the customer decides, in the Customer lane. If the customer declines, the order is rejected.
-- Kitchen confirms or rejects. Both rejects merge, then Reject order: void COD, online to REFUND_PENDING (Q3). Confirmed: prepare food, mark READY.
-- Cancel order is a separate small activity (Part E, strip under the figure; proposal Figure 1e), allowed while the order is PLACED or CONFIRMED, refused once PREPARING. Analysed only, like the other supporting use cases (A-08).
-- Quan prep, cancel as a separate activity: a customer can ask at any time, so it is not a step of the main flow. The state check and the change happen in one transaction with a conditional update, so a cancel and a kitchen confirm cannot both win. Dat backs up.
-- Quan prep, Flow Final vs Activity Final: flow final ends one path while the order may still run; activity final ends the whole activity, used only where nothing else can run, such as reject before preparation.</a:t>
+              <a:t>Speaker: Dat · Time: 2:06–2:42
+Zone B: the kitchen. The kitchen confirms or rejects the order. If an item ran out, the kitchen offers a replacement, and the customer decides. If the customer says no, the order is rejected. A rejection voids a cash payment, and an online payment goes to refund pending. A confirmed order is prepared and marked READY. Cancelling is a separate short activity, Part E. A customer can cancel while the order is PLACED or CONFIRMED. We analyse it only.
+Cue: Click: slide 6 (zone C).</a:t>
             </a:r>
             <a:endParaRPr lang="en-US" dirty="0"/>
           </a:p>
@@ -1547,14 +1506,9 @@
           <a:p>
             <a:r>
               <a:rPr lang="en-US" dirty="0"/>
-              <a:t>Speaker: Quan
-Time: 2:25-2:50
-- Framing: Delivery and cash: collected at the door, reconciled at the end of the shift.
-- Shipper picks up the ready order and delivers it.
-- Success with COD: the shipper records the cash collection and the order is DELIVERED. At the end of the shift the shipper hands the cash to the hub and office staff reconcile it.
-- Success and paid online: DELIVERED and a receipt. DELIVERED is the order state; PAID is the payment state.
-- Failure: report it and return the food; the platform then marks DELIVERY_FAILED (zone D): a COD payment is voided and that path ends, nothing was paid; an online payment becomes REFUND_PENDING and reaches the refund decision.
-- Quan prep, collection vs reconciliation: collection happens at the door, one order, the shipper, payment becomes PAID. Reconciliation happens at shift end, office staff compare the handed-over cash with the per-order records. Different people, time and lane. Dat backs up.</a:t>
+              <a:t>Speaker: Dat · Time: 2:42–3:21
+Zone C: delivery and cash. The shipper picks up the ready order and delivers it. For cash on delivery, the shipper records the money at the door, and the payment becomes PAID. At the end of the shift, the shipper hands the cash to the hub, and office staff reconcile it. Delivered is not paid. If delivery fails, the shipper returns the food, and zone D marks the order delivery failed. A cash payment is voided, and nothing is refunded, because nothing was paid.
+Cue: Click: slide 7 (zone D).</a:t>
             </a:r>
             <a:endParaRPr lang="en-US" dirty="0"/>
           </a:p>
@@ -1642,13 +1596,9 @@
           <a:p>
             <a:r>
               <a:rPr lang="en-US" dirty="0"/>
-              <a:t>Speaker: Quan
-Time: 2:50-3:15
-- Framing: Complaint and refund stay in the process but are not built in this release.
-- Delivered orders: the platform marks DELIVERED and issues a receipt; the customer may rate the order, or complain about a wrong or late order. A failed delivery is marked DELIVERY_FAILED here, with COD voided.
-- Complaint and the failed online delivery meet at a merge, then office staff decide Refund approved? A COD customer after a failed delivery never reaches it: nothing was paid.
-- Say what is built: complaint, refund and rating are grey, in the process but deferred (A-09).
-- Reports are a separate activity with its own start and Activity Final, reading the same shared records.</a:t>
+              <a:t>Speaker: Dat · Time: 3:21–3:57
+Zone D: receipt, complaint and refund. After delivery, the customer gets a receipt. The customer may rate the order, or complain about a wrong or late order. Office staff then decide on the refund. A failed delivery paid online reaches the same decision. Complaint, refund and rating are grey: they are in the process, but we do not build them. Reports are a separate activity that reads the same records. Quan will now show who does what.
+Cue: HAND-OVER 1. Say the last line, look at Quan, click: slide 8. Quan takes the clicker.</a:t>
             </a:r>
             <a:endParaRPr lang="en-US" dirty="0"/>
           </a:p>
@@ -1736,14 +1686,9 @@
           <a:p>
             <a:r>
               <a:rPr lang="en-US" dirty="0"/>
-              <a:t>Speaker: Quan
-Time: 3:15-3:45
-- Customer comes in two types, local and tourist, with different online options; both can pay cash.
-- Kitchen staff are the gate: they reject when an item is gone, and marking ready makes the order visible to shippers.
-- The shipper records COD collection and hands the cash to the hub; office staff reconcile it at the end of the shift. Delivered is not paid.
-- Admin sets the capacity the busy rule reads. Manager reads the same records, not a copy. The payment provider is our stub.
-- Quan prep, answer if asked: collection vs reconciliation, merge vs join, Flow Final vs Activity Final, cancel as a separate activity (see slides 4 to 7).
-- HAND-OVER 2 (Quan to Dat): now Dat covers ownership and the plan.</a:t>
+              <a:t>Speaker: Quan · Time: 3:57–4:46
+Thank you, Dat. Here are our seven actors. Each one decides something that the order cannot move without. The customer picks the hub, the items and the payment. There are two customer types, local and tourist. Kitchen staff confirm or reject, and prepare the food. The shipper delivers and records the cash. Admin sets the hub capacity that the busy rule reads. The manager reads the reports. Office staff reconcile cash and decide refunds. The seventh actor is the payment stub, which our team builds to return the online result. Without any one of them, the order stops. All seven work on one shared order record.
+Cue: Click: slide 9.</a:t>
             </a:r>
             <a:endParaRPr lang="en-US" dirty="0"/>
           </a:p>
@@ -1831,13 +1776,9 @@
           <a:p>
             <a:r>
               <a:rPr lang="en-US" dirty="0"/>
-              <a:t>Speaker: Dat
-Time: 3:45-4:25
-- Candidates #3, #10, #13, #16; exactly two each; groups ordering, fulfilment, full CRUD and report all covered.
-- State machines: Dat Order and Hub, Quan Delivery. Part 3: Dat presents UC-01, Quan UC-02. Dat is integration lead; Quan keeps schema and seed.
-- Minimum support: Kitchen board and role-based login with seeded users, so one order can travel from placement to delivery.
-- Analysed only: the supporting use cases, including Cancel order (Figure 1e), with CRUD coverage by analysis and seed data, pending the lecturer (A-08, L1). Deferred core features: complaint, refund and rating stay in the process but are not built (A-09, L3).
-- The demo uses a seeded hub with a menu; Create Hub is tested separately.</a:t>
+              <a:t>Speaker: Quan · Time: 4:46–5:37
+Now, who owns what. We build four use cases, two for each of us. They cover all four required groups. Dat owns UC-01, place an order, and UC-03, manage hubs. I own UC-02, deliver an order, and UC-04, reports. Dat is the integration lead. I keep the schema and the seed data. The state machines are Order and Hub for Dat, and Delivery for me. Below the table are five scope levels. Level one is built: the four use cases. Level two is minimum support: a kitchen board and login. Level three is analysed only, including cancel order. Level four is deferred: complaint, refund and rating. Level five is future ideas.
+Cue: Click: slide 10.</a:t>
             </a:r>
             <a:endParaRPr lang="en-US" dirty="0"/>
           </a:p>
@@ -7466,7 +7407,7 @@
                           <a:ea typeface="Arial" pitchFamily="34" charset="-122"/>
                           <a:cs typeface="Arial" pitchFamily="34" charset="-120"/>
                         </a:rPr>
-                        <a:t>UC-01 description, questions</a:t>
+                        <a:t>UC-01 description, process diagram</a:t>
                       </a:r>
                       <a:endParaRPr lang="en-US" sz="1600" dirty="0">
                         <a:latin typeface="Arial" charset="0"/>
@@ -9222,16 +9163,16 @@
         </p:nvGraphicFramePr>
         <p:xfrm>
           <a:off x="457200" y="1600200"/>
-          <a:ext cx="7315200" cy="914400"/>
+          <a:ext cx="7040880" cy="914400"/>
         </p:xfrm>
         <a:graphic>
           <a:graphicData uri="http://schemas.openxmlformats.org/drawingml/2006/table">
             <a:tbl>
               <a:tblPr/>
               <a:tblGrid>
-                <a:gridCol w="1828800"/>
+                <a:gridCol w="1645920"/>
                 <a:gridCol w="1463040"/>
-                <a:gridCol w="4023360"/>
+                <a:gridCol w="3931920"/>
               </a:tblGrid>
               <a:tr h="411480">
                 <a:tc>
@@ -10642,8 +10583,8 @@
         </p:nvSpPr>
         <p:spPr>
           <a:xfrm>
-            <a:off x="7982712" y="1627632"/>
-            <a:ext cx="3770071" cy="2370011"/>
+            <a:off x="7662672" y="1627632"/>
+            <a:ext cx="4090111" cy="2230254"/>
           </a:xfrm>
           <a:prstGeom prst="rect">
             <a:avLst/>
@@ -10675,8 +10616,8 @@
         </p:blipFill>
         <p:spPr>
           <a:xfrm>
-            <a:off x="8001000" y="1645920"/>
-            <a:ext cx="3733495" cy="2333435"/>
+            <a:off x="7680960" y="1645920"/>
+            <a:ext cx="4053535" cy="2193678"/>
           </a:xfrm>
           <a:prstGeom prst="rect">
             <a:avLst/>
@@ -10691,8 +10632,8 @@
         </p:nvSpPr>
         <p:spPr>
           <a:xfrm>
-            <a:off x="8001000" y="4070794"/>
-            <a:ext cx="3733495" cy="365760"/>
+            <a:off x="7680960" y="3931038"/>
+            <a:ext cx="4053535" cy="685800"/>
           </a:xfrm>
           <a:prstGeom prst="rect">
             <a:avLst/>
@@ -10716,7 +10657,7 @@
                 <a:ea typeface="Arial" pitchFamily="34" charset="-122"/>
                 <a:cs typeface="Arial" pitchFamily="34" charset="-120"/>
               </a:rPr>
-              <a:t>Saved order: ID 1, PLACED, COD</a:t>
+              <a:t>Saved order: ID 1, PLACED, COD, total 160,000 VND</a:t>
             </a:r>
             <a:endParaRPr lang="en-US" sz="1600" dirty="0"/>
           </a:p>
@@ -10730,8 +10671,8 @@
         </p:nvSpPr>
         <p:spPr>
           <a:xfrm>
-            <a:off x="457200" y="5349240"/>
-            <a:ext cx="11277295" cy="457200"/>
+            <a:off x="457200" y="5413248"/>
+            <a:ext cx="11277295" cy="420624"/>
           </a:xfrm>
           <a:prstGeom prst="rect">
             <a:avLst/>
@@ -10750,8 +10691,8 @@
         </p:nvSpPr>
         <p:spPr>
           <a:xfrm>
-            <a:off x="585216" y="5349240"/>
-            <a:ext cx="11021263" cy="457200"/>
+            <a:off x="585216" y="5413248"/>
+            <a:ext cx="11021263" cy="420624"/>
           </a:xfrm>
           <a:prstGeom prst="rect">
             <a:avLst/>
@@ -10803,8 +10744,8 @@
         </p:nvSpPr>
         <p:spPr>
           <a:xfrm>
-            <a:off x="457200" y="5870448"/>
-            <a:ext cx="11277295" cy="457200"/>
+            <a:off x="457200" y="5888736"/>
+            <a:ext cx="11277295" cy="420624"/>
           </a:xfrm>
           <a:prstGeom prst="rect">
             <a:avLst/>
@@ -10823,8 +10764,8 @@
         </p:nvSpPr>
         <p:spPr>
           <a:xfrm>
-            <a:off x="585216" y="5870448"/>
-            <a:ext cx="11021263" cy="457200"/>
+            <a:off x="585216" y="5888736"/>
+            <a:ext cx="11021263" cy="420624"/>
           </a:xfrm>
           <a:prstGeom prst="rect">
             <a:avLst/>

</xml_diff>

<commit_message>
Update Part 1 package: team of three, consistent refund and cancel rules, I1 results as of 20/10
Co-Authored-By: Claude Opus 5.5 <noreply@anthropic.com>
</commit_message>
<xml_diff>
--- a/docs/part1/Team02_Proposal_Slides_for_SaigonBite.pptx
+++ b/docs/part1/Team02_Proposal_Slides_for_SaigonBite.pptx
@@ -516,8 +516,8 @@
           <a:p>
             <a:r>
               <a:rPr lang="en-US" dirty="0"/>
-              <a:t>Speaker: Dat · Time: 0:00–0:21
-Hello everyone. We are Team 02. I am Dat, and this is Quan. Our project is SaigonBite, an online food delivery hub platform for cloud kitchens in Ho Chi Minh City. Today we show the process, the plan, the result, the risks, and our questions.
+              <a:t>Speaker: Dat · Dat 1 of 6 (with slide 2) · Time: 0:00-0:20 (43 words)
+Good morning. We are Team 02. I am Dat, and with me are Quan L. and Quan. Our project is SaigonBite, a delivery platform for cloud kitchens. I want to start with one lunch order, because that one order explains the whole project.
 Cue: Click: slide 2.</a:t>
             </a:r>
             <a:endParaRPr lang="en-US" dirty="0"/>
@@ -606,9 +606,9 @@
           <a:p>
             <a:r>
               <a:rPr lang="en-US" dirty="0"/>
-              <a:t>Speaker: Quan · Time: 5:37–6:26
-Our approach is the iterative Unified Process, with six short iterations. Each one has analysis, design, build, test and a joint review. We chose it for four reasons. Client answers arrive later. The four use cases share one Order record. The deadlines are fixed, and we are only two people. And we do the riskiest parts first: capacity in Iteration 2, payment in Iteration 3. Our stack is Python 3.12 or later, Flask, sqlite3 with hand-written SQL, SQLite, pytest and Flask-Login. We chose Python because we are both strongest in it, and SQLite needs no server. The design has three layers. Back to Dat for the plan.
-Cue: HAND-OVER 2. Say the last line, click: slide 11. Dat takes the clicker.</a:t>
+              <a:t>Speaker: Quan · Quan 1 of 2 · Time: 5:00-5:38 (83 words)
+Thank you. The case is incomplete on purpose: capacity limits, fees and payment rules will come from the client later. So we work in short iterations. Each one analyses, designs, builds and tests a thin slice, and then we review it together. We take the riskiest rules first: capacity in Iteration 2, payment in Iteration 3. The stack is plain on purpose: Python and Flask, three layers, hand-written SQL on SQLite, and pytest, so every layer stays visible in the Part 2 report.
+Cue: Click: slide 11.</a:t>
             </a:r>
             <a:endParaRPr lang="en-US" dirty="0"/>
           </a:p>
@@ -696,9 +696,9 @@
           <a:p>
             <a:r>
               <a:rPr lang="en-US" dirty="0"/>
-              <a:t>Speaker: Dat · Time: 6:26–6:48
-Thank you, Quan. This is our roadmap with real dates. Iteration 1 runs from 17 to 22 October. Part 2 is due on 15 November. We keep three contingency points: lecturer answers by 31 October, feature freeze on 12 November, and a buffer day on 13 November.
-Cue: Click: slide 12.</a:t>
+              <a:t>Speaker: Quan · Quan 2 of 2 · Time: 5:38-6:15 (81 words)
+Here is the roadmap: six iterations. Iteration 2 builds hubs, capacity and the kitchen board. Iteration 3 completes ordering, delivery and the menu. Iteration 4 adds reports and the full demo. Iteration 5 freezes features three days before the Part 2 deadline and keeps one buffer day. Iteration 6 is only for feedback and Part 3, so nothing in Part 2 depends on it. The red marks are the points where we decide. Back to Dat for what we actually delivered.
+Cue: Point at the red diamonds. Hand-over: "Back to Dat for what we actually delivered."</a:t>
             </a:r>
             <a:endParaRPr lang="en-US" dirty="0"/>
           </a:p>
@@ -786,8 +786,8 @@
           <a:p>
             <a:r>
               <a:rPr lang="en-US" dirty="0"/>
-              <a:t>Speaker: Dat · Time: 6:48–7:05
-Iteration 1 runs the six core processes in six days. Each day has a task for each of us, and evidence at the end. At four hours per student per day, the plan is 48 person-hours.
+              <a:t>Speaker: Dat · Dat 5 of 6 (with slide 13) · Time: 6:15-6:32 (37 words)
+Thank you. Iteration 1 had six days and two people. Each day follows one of the textbook's core processes, from planning to testing. The goal was narrow on purpose: one cash order, at one hub, saved correctly.
 Cue: Click: slide 13.</a:t>
             </a:r>
             <a:endParaRPr lang="en-US" dirty="0"/>
@@ -876,9 +876,9 @@
           <a:p>
             <a:r>
               <a:rPr lang="en-US" dirty="0"/>
-              <a:t>Speaker: Dat · Time: 7:05–7:36
-Now the result. We built Iteration 1 early, on 19 October, with AI assistance. 81 tests passed and none failed, at commit 049673d. We met 7 of 9 criteria. AC-1 and AC-9 are partial. The saved order is on the right. Hours, the second machine and the lesson are still empty. We will report on D6 on 22 October. Our review of the code is still to do.
-Cue: Click: slide 14. (Optional 30-second demo instead, see the end of this file.)</a:t>
+              <a:t>Speaker: Dat · Dat 5 of 6 · Time: 6:32-7:16 (95 words)
+Here is what really happened. We built early, on day three, with AI assistance, and we say that openly. The order is saved in one transaction, and a double click still creates one order. Eight of nine criteria are met; the run on a second laptop is still open. Then we reviewed the code ourselves and found a bug the tests had missed: a price that changed after the quote was charged without asking. All 81 tests were green. We fixed it, we now have 90 tests, and every review finding gets its own test.
+Cue: Point at the saved order, then at the Lesson line. Click: slide 14.</a:t>
             </a:r>
             <a:endParaRPr lang="en-US" dirty="0"/>
           </a:p>
@@ -966,9 +966,9 @@
           <a:p>
             <a:r>
               <a:rPr lang="en-US" dirty="0"/>
-              <a:t>Speaker: Dat · Time: 7:36–7:56
-Our biggest risks are unconfirmed rules and the capacity race. For the race, we count and insert in one transaction, and we test the boundary. For the rules, every rule is in the Assumption Log, with values in configuration. Every risk has an owner.
-Cue: Click: slide 15.</a:t>
+              <a:t>Speaker: Dat · Dat 6 of 6 (with slide 15) · Time: 7:16-7:51 (75 words)
+Two risks matter most. First, the client may change a rule after we have coded it, so every rule lives in configuration and in the Assumption Log. Second, at the lunch peak two orders can race for the last slot, so the check and the insert run in one transaction, with a boundary test. The other risks, scope, integration and a new member getting started, each have an owner and a warning sign we watch.
+Cue: Point at R-02 and R-03. Click: slide 15.</a:t>
             </a:r>
             <a:endParaRPr lang="en-US" dirty="0"/>
           </a:p>
@@ -1056,9 +1056,9 @@
           <a:p>
             <a:r>
               <a:rPr lang="en-US" dirty="0"/>
-              <a:t>Speaker: Dat · Time: 7:56–8:16
-We need decisions: five from the client, each with our default, and four from the lecturer. Please answer by 31 October. Iteration 2 starts on 27 October with hub CRUD and the capacity rule. Thank you. We are happy to take your questions.
-Cue: End. Stop on slide 15 and take questions.</a:t>
+              <a:t>Speaker: Dat · Dat 6 of 6 · Time: 7:51-8:24 (71 words)
+To close, here is what we need. Five client questions, each with our default, so we can keep building while we wait. And five questions for you as our lecturer. The main ones: is analysis plus seed data enough for the classes we do not build, and do you accept our third member and the two new use cases? With your answers by the thirty-first, Iteration 2 starts tomorrow. Thank you.
+Cue: Stop on this slide for questions.</a:t>
             </a:r>
             <a:endParaRPr lang="en-US" dirty="0"/>
           </a:p>
@@ -1146,8 +1146,8 @@
           <a:p>
             <a:r>
               <a:rPr lang="en-US" dirty="0"/>
-              <a:t>Speaker: Dat · Time: 0:21–1:06
-First, the problem. Paper tickets and chat hide the queue. At lunch time, one hub has a long queue, and a hub nearby is almost empty. Nobody outside the kitchen can see this. Menus change, but the apps do not, so staff phone the customers. Cash reaches the hub late, sometimes with mistakes. Tourists cannot register or pay. Our vision is one shared platform: one order record, a visible workload for each hub, and reports from the same data. These benefits are targets. We have not measured them yet. Timestamps from Iteration 3 will let us measure them.
+              <a:t>Speaker: Dat · Dat 1 of 6 · Time: 0:20-1:05 (98 words)
+It is a quarter to twelve. Linh works in District 1 and orders pho. The District 1 hub has a board full of paper tickets; the Binh Thanh hub, ten minutes away, is half empty. Nobody can see that, so Linh waits an hour. Then the beef runs out, and someone has to phone her. Her cash reaches the hub at the end of the day, sometimes short. Different pains, one root cause: there is no shared order record. So our vision is one order record that the customer, the kitchen, the shipper and the manager all read.
 Cue: Click: slide 3.</a:t>
             </a:r>
             <a:endParaRPr lang="en-US" dirty="0"/>
@@ -1236,9 +1236,9 @@
           <a:p>
             <a:r>
               <a:rPr lang="en-US" dirty="0"/>
-              <a:t>Speaker: Dat · Time: 1:06–1:32
-This is the whole business process on one page. One order crosses five roles: customer, platform, kitchen, shipper, and office staff or manager. You do not need to read it. We split it into four zones, A to D, and zoom in on each one. Red is a failure path. Grey is not built in this release.
-Cue: Click: slide 4 (zone A).</a:t>
+              <a:t>Speaker: Dat · Dat 2 of 6 (with slide 4) · Time: 1:05-1:32 (59 words)
+Here is Linh's order as a business process. Five lanes: customer, platform, kitchen, shipper and office. Do not read the boxes yet; look at the shape. Blue is the normal path, red is where something goes wrong, and grey is in the process but not in this release. I will walk through it in four parts, A to D.
+Cue: Point at the five lanes, then click: slide 4.</a:t>
             </a:r>
             <a:endParaRPr lang="en-US" dirty="0"/>
           </a:p>
@@ -1326,9 +1326,9 @@
           <a:p>
             <a:r>
               <a:rPr lang="en-US" dirty="0"/>
-              <a:t>Speaker: Dat · Time: 1:32–2:06
-Zone A: order, quote and payment. The customer picks a hub and items. If the hub is busy, the platform suggests a quieter hub, and the customer chooses again. Then the customer sees the fee and the voucher, and pays cash on delivery or online. If online payment fails, the customer retries or switches to cash, and no order is created. Otherwise, the platform creates the order as PLACED and tells the hub.
-Cue: Click: slide 5 (zone B).</a:t>
+              <a:t>Speaker: Dat · Dat 2 of 6 · Time: 1:32-2:04 (69 words)
+Part A. Linh picks the District 1 hub, and the platform checks its workload first. If the hub is busy, she is offered a quieter hub before any order exists. Then she sees the full price: food, delivery fee and voucher. She pays cash on delivery, or online through our payment stub; if that fails, she retries or switches to cash. Only then is the order created, as PLACED.
+Cue: Point at "Hub busy?", then at "Create order". Click: slide 5.</a:t>
             </a:r>
             <a:endParaRPr lang="en-US" dirty="0"/>
           </a:p>
@@ -1416,9 +1416,9 @@
           <a:p>
             <a:r>
               <a:rPr lang="en-US" dirty="0"/>
-              <a:t>Speaker: Dat · Time: 2:06–2:42
-Zone B: the kitchen. The kitchen confirms or rejects the order. If an item ran out, the kitchen offers a replacement, and the customer decides. If the customer says no, the order is rejected. A rejection voids a cash payment, and an online payment goes to refund pending. A confirmed order is prepared and marked READY. Cancelling is a separate short activity, Part E. A customer can cancel while the order is PLACED or CONFIRMED. We analyse it only.
-Cue: Click: slide 6 (zone C).</a:t>
+              <a:t>Speaker: Dat · Dat 3 of 6 · Time: 2:04-2:38 (74 words)
+Part B, the kitchen. The kitchen confirms or rejects. If the beef has run out, the kitchen does not simply cancel: it offers a replacement, and Linh decides. If she says no, the order is rejected. Cash is voided, and an online payment is refunded in full, with no approval needed. Linh can also cancel on her own, but only until cooking starts. That is a separate short activity, Part E in the proposal.
+Cue: Point at "Offer item replacement", then at the Part E strip. Click: slide 6.</a:t>
             </a:r>
             <a:endParaRPr lang="en-US" dirty="0"/>
           </a:p>
@@ -1506,9 +1506,9 @@
           <a:p>
             <a:r>
               <a:rPr lang="en-US" dirty="0"/>
-              <a:t>Speaker: Dat · Time: 2:42–3:21
-Zone C: delivery and cash. The shipper picks up the ready order and delivers it. For cash on delivery, the shipper records the money at the door, and the payment becomes PAID. At the end of the shift, the shipper hands the cash to the hub, and office staff reconcile it. Delivered is not paid. If delivery fails, the shipper returns the food, and zone D marks the order delivery failed. A cash payment is voided, and nothing is refunded, because nothing was paid.
-Cue: Click: slide 7 (zone D).</a:t>
+              <a:t>Speaker: Dat · Dat 4 of 6 (with slide 7) · Time: 2:38-3:10 (70 words)
+Part C, delivery. The shipper picks up the food and delivers it. This is the point we care about most: delivered is not the same as paid. For a cash order, the shipper records the cash at the door, for that one order. At the end of the shift, office staff check the cash against those records. If the delivery fails, the shipper reports it and brings the food back.
+Cue: Point at "Collect cash", then at "Reconcile". Click: slide 7.</a:t>
             </a:r>
             <a:endParaRPr lang="en-US" dirty="0"/>
           </a:p>
@@ -1596,9 +1596,9 @@
           <a:p>
             <a:r>
               <a:rPr lang="en-US" dirty="0"/>
-              <a:t>Speaker: Dat · Time: 3:21–3:57
-Zone D: receipt, complaint and refund. After delivery, the customer gets a receipt. The customer may rate the order, or complain about a wrong or late order. Office staff then decide on the refund. A failed delivery paid online reaches the same decision. Complaint, refund and rating are grey: they are in the process, but we do not build them. Reports are a separate activity that reads the same records. Quan will now show who does what.
-Cue: HAND-OVER 1. Say the last line, look at Quan, click: slide 8. Quan takes the clicker.</a:t>
+              <a:t>Speaker: Dat · Dat 4 of 6 · Time: 3:10-3:46 (77 words)
+Part D. Linh gets a receipt, and she can rate the order or complain. A failed delivery settles itself: cash is voided, and online money goes back in full. A complaint is the only case where a person has to decide. Office staff approve a refund, or they deny it and tell Linh why. The reports sit on the side and read the same records. That is the process. Quan L. will show who owns which part.
+Cue: Point at "Refund approved?". Hand-over: "Quan L. will show who owns which part."</a:t>
             </a:r>
             <a:endParaRPr lang="en-US" dirty="0"/>
           </a:p>
@@ -1686,8 +1686,8 @@
           <a:p>
             <a:r>
               <a:rPr lang="en-US" dirty="0"/>
-              <a:t>Speaker: Quan · Time: 3:57–4:46
-Thank you, Dat. Here are our seven actors. Each one decides something that the order cannot move without. The customer picks the hub, the items and the payment. There are two customer types, local and tourist. Kitchen staff confirm or reject, and prepare the food. The shipper delivers and records the cash. Admin sets the hub capacity that the busy rule reads. The manager reads the reports. Office staff reconcile cash and decide refunds. The seventh actor is the payment stub, which our team builds to return the online result. Without any one of them, the order stops. All seven work on one shared order record.
+              <a:t>Speaker: Quan L. · Quan L. 1 of 2 · Time: 3:46-4:22 (77 words)
+Thank you, Dat. Six people and one outside system touch Linh's order. The customer orders and pays. Kitchen staff confirm, reject or replace, and then cook. The shipper delivers and records the cash. Office staff reconcile that cash and handle complaints. The admin keeps hubs, capacity and menus correct, and the manager reads the reports. The outside system is the payment provider. We simulate it with our own stub, so we can test both success and failure.
 Cue: Click: slide 9.</a:t>
             </a:r>
             <a:endParaRPr lang="en-US" dirty="0"/>
@@ -1776,9 +1776,9 @@
           <a:p>
             <a:r>
               <a:rPr lang="en-US" dirty="0"/>
-              <a:t>Speaker: Quan · Time: 4:46–5:37
-Now, who owns what. We build four use cases, two for each of us. They cover all four required groups. Dat owns UC-01, place an order, and UC-03, manage hubs. I own UC-02, deliver an order, and UC-04, reports. Dat is the integration lead. I keep the schema and the seed data. The state machines are Order and Hub for Dat, and Delivery for me. Below the table are five scope levels. Level one is built: the four use cases. Level two is minimum support: a kitchen board and login. Level three is analysed only, including cancel order. Level four is deferred: complaint, refund and rating. Level five is future ideas.
-Cue: Click: slide 10.</a:t>
+              <a:t>Speaker: Quan L. · Quan L. 2 of 2 · Time: 4:22-5:00 (83 words)
+From these actors we chose six main use cases, two per student, and they cover all four required groups. Dat owns placing an order and managing hubs. I own delivery and the reports. Quan owns the kitchen decision and the menu. To be clear about status: all six are planned for Part 2. Today one is partly built, placing a cash order. Cancelling, vouchers and accounts are analysed only. Complaints, refund payouts and ratings are deferred. Quan will explain how we build it.
+Cue: Point at the status line. Hand-over: "Quan will explain how we build it."</a:t>
             </a:r>
             <a:endParaRPr lang="en-US" dirty="0"/>
           </a:p>
@@ -2807,8 +2807,8 @@
         </p:nvSpPr>
         <p:spPr>
           <a:xfrm>
-            <a:off x="822960" y="3657600"/>
-            <a:ext cx="5029200" cy="1325880"/>
+            <a:off x="822960" y="3611880"/>
+            <a:ext cx="3429000" cy="1463040"/>
           </a:xfrm>
           <a:prstGeom prst="rect">
             <a:avLst/>
@@ -2827,8 +2827,8 @@
         </p:nvSpPr>
         <p:spPr>
           <a:xfrm>
-            <a:off x="950976" y="3657600"/>
-            <a:ext cx="4773168" cy="1325880"/>
+            <a:off x="950976" y="3611880"/>
+            <a:ext cx="3172968" cy="1463040"/>
           </a:xfrm>
           <a:prstGeom prst="rect">
             <a:avLst/>
@@ -2869,7 +2869,7 @@
                 <a:ea typeface="Arial" pitchFamily="34" charset="-122"/>
                 <a:cs typeface="Arial" pitchFamily="34" charset="-120"/>
               </a:rPr>
-              <a:t>Owns UC-01 Place an order and UC-03 Manage hubs</a:t>
+              <a:t>UC-01 Place an order, UC-03 Manage hubs</a:t>
             </a:r>
             <a:endParaRPr lang="en-US" sz="1800" dirty="0"/>
           </a:p>
@@ -2883,8 +2883,8 @@
         </p:nvSpPr>
         <p:spPr>
           <a:xfrm>
-            <a:off x="6126480" y="3657600"/>
-            <a:ext cx="5029200" cy="1325880"/>
+            <a:off x="4434840" y="3611880"/>
+            <a:ext cx="3429000" cy="1463040"/>
           </a:xfrm>
           <a:prstGeom prst="rect">
             <a:avLst/>
@@ -2903,8 +2903,8 @@
         </p:nvSpPr>
         <p:spPr>
           <a:xfrm>
-            <a:off x="6254496" y="3657600"/>
-            <a:ext cx="4773168" cy="1325880"/>
+            <a:off x="4562856" y="3611880"/>
+            <a:ext cx="3172968" cy="1463040"/>
           </a:xfrm>
           <a:prstGeom prst="rect">
             <a:avLst/>
@@ -2945,7 +2945,7 @@
                 <a:ea typeface="Arial" pitchFamily="34" charset="-122"/>
                 <a:cs typeface="Arial" pitchFamily="34" charset="-120"/>
               </a:rPr>
-              <a:t>Owns UC-02 Deliver an order and UC-04 Reports</a:t>
+              <a:t>UC-02 Deliver an order, UC-04 Reports</a:t>
             </a:r>
             <a:endParaRPr lang="en-US" sz="1800" dirty="0"/>
           </a:p>
@@ -2953,7 +2953,83 @@
       </p:sp>
       <p:sp>
         <p:nvSpPr>
-          <p:cNvPr id="9" name="Text 7"/>
+          <p:cNvPr id="9" name="Card"/>
+          <p:cNvSpPr/>
+          <p:nvPr/>
+        </p:nvSpPr>
+        <p:spPr>
+          <a:xfrm>
+            <a:off x="8046720" y="3611880"/>
+            <a:ext cx="3429000" cy="1463040"/>
+          </a:xfrm>
+          <a:prstGeom prst="rect">
+            <a:avLst/>
+          </a:prstGeom>
+          <a:solidFill>
+            <a:srgbClr val="E3ECF3"/>
+          </a:solidFill>
+          <a:ln/>
+        </p:spPr>
+      </p:sp>
+      <p:sp>
+        <p:nvSpPr>
+          <p:cNvPr id="10" name="Text 8"/>
+          <p:cNvSpPr txBox="1"/>
+          <p:nvPr/>
+        </p:nvSpPr>
+        <p:spPr>
+          <a:xfrm>
+            <a:off x="8174736" y="3611880"/>
+            <a:ext cx="3172968" cy="1463040"/>
+          </a:xfrm>
+          <a:prstGeom prst="rect">
+            <a:avLst/>
+          </a:prstGeom>
+          <a:noFill/>
+          <a:ln/>
+        </p:spPr>
+        <p:txBody>
+          <a:bodyPr wrap="square" lIns="0" tIns="0" rIns="0" bIns="0" rtlCol="0" anchor="ctr"/>
+          <a:lstStyle/>
+          <a:p>
+            <a:pPr algn="l" indent="0" marL="0">
+              <a:buNone/>
+            </a:pPr>
+            <a:r>
+              <a:rPr lang="en-US" sz="1800" b="1" dirty="0">
+                <a:solidFill>
+                  <a:srgbClr val="004387"/>
+                </a:solidFill>
+                <a:latin typeface="Arial" pitchFamily="34" charset="0"/>
+                <a:ea typeface="Arial" pitchFamily="34" charset="-122"/>
+                <a:cs typeface="Arial" pitchFamily="34" charset="-120"/>
+              </a:rPr>
+              <a:t>Quan · ⟦ACTUAL m3_id: student ID⟧</a:t>
+            </a:r>
+            <a:endParaRPr lang="en-US" sz="1800" dirty="0"/>
+          </a:p>
+          <a:p>
+            <a:pPr algn="l" indent="0" marL="0">
+              <a:buNone/>
+            </a:pPr>
+            <a:r>
+              <a:rPr lang="en-US" sz="1800" dirty="0">
+                <a:solidFill>
+                  <a:srgbClr val="1F2937"/>
+                </a:solidFill>
+                <a:latin typeface="Arial" pitchFamily="34" charset="0"/>
+                <a:ea typeface="Arial" pitchFamily="34" charset="-122"/>
+                <a:cs typeface="Arial" pitchFamily="34" charset="-120"/>
+              </a:rPr>
+              <a:t>UC-05 Confirm or reject, UC-06 Menus</a:t>
+            </a:r>
+            <a:endParaRPr lang="en-US" sz="1800" dirty="0"/>
+          </a:p>
+        </p:txBody>
+      </p:sp>
+      <p:sp>
+        <p:nvSpPr>
+          <p:cNvPr id="11" name="Text 9"/>
           <p:cNvSpPr txBox="1"/>
           <p:nvPr/>
         </p:nvSpPr>
@@ -3098,7 +3174,7 @@
                 <a:ea typeface="Arial" pitchFamily="34" charset="-122"/>
                 <a:cs typeface="Arial" pitchFamily="34" charset="-120"/>
               </a:rPr>
-              <a:t>Iterative Unified Process fits a case whose rules are still open</a:t>
+              <a:t>Short iterations, because the client’s rules are still open</a:t>
             </a:r>
             <a:endParaRPr lang="en-US" sz="2600" dirty="0"/>
           </a:p>
@@ -3137,7 +3213,7 @@
                 <a:ea typeface="Arial" pitchFamily="34" charset="-122"/>
                 <a:cs typeface="Arial" pitchFamily="34" charset="-120"/>
               </a:rPr>
-              <a:t>Six time-boxed iterations: analysis, design, build, test and a joint review.</a:t>
+              <a:t>Six iterations; each one analyses, designs, builds, tests and ends with a team review.</a:t>
             </a:r>
             <a:endParaRPr lang="en-US" sz="1800" dirty="0"/>
           </a:p>
@@ -3328,7 +3404,7 @@
                 <a:ea typeface="Arial" pitchFamily="34" charset="-122"/>
                 <a:cs typeface="Arial" pitchFamily="34" charset="-120"/>
               </a:rPr>
-              <a:t>Four use cases grow one record</a:t>
+              <a:t>Six use cases grow one record</a:t>
             </a:r>
             <a:endParaRPr lang="en-US" sz="1800" dirty="0"/>
           </a:p>
@@ -3404,7 +3480,7 @@
                 <a:ea typeface="Arial" pitchFamily="34" charset="-122"/>
                 <a:cs typeface="Arial" pitchFamily="34" charset="-120"/>
               </a:rPr>
-              <a:t>26/10, 16/11, 30/11; team of two</a:t>
+              <a:t>Three presentations; team of three</a:t>
             </a:r>
             <a:endParaRPr lang="en-US" sz="1800" dirty="0"/>
           </a:p>
@@ -3519,7 +3595,7 @@
                 <a:ea typeface="Arial" pitchFamily="34" charset="-122"/>
                 <a:cs typeface="Arial" pitchFamily="34" charset="-120"/>
               </a:rPr>
-              <a:t>Stack and three layers (decided)</a:t>
+              <a:t>Stack and three layers (team choice)</a:t>
             </a:r>
             <a:endParaRPr lang="en-US" sz="1800" dirty="0"/>
           </a:p>
@@ -3765,7 +3841,7 @@
                 <a:ea typeface="Arial" pitchFamily="34" charset="-122"/>
                 <a:cs typeface="Arial" pitchFamily="34" charset="-120"/>
               </a:rPr>
-              <a:t>Order, Hub, Payment, Delivery</a:t>
+              <a:t>Order, Hub, Payment, MenuItem</a:t>
             </a:r>
             <a:endParaRPr lang="en-US" sz="1800" dirty="0"/>
           </a:p>
@@ -3988,7 +4064,7 @@
                 <a:ea typeface="Arial" pitchFamily="34" charset="-122"/>
                 <a:cs typeface="Arial" pitchFamily="34" charset="-120"/>
               </a:rPr>
-              <a:t>Python 3.12 or later (I1 tested on 3.13)</a:t>
+              <a:t>Python 3.13 · pytest · Flask-Login</a:t>
             </a:r>
             <a:endParaRPr lang="en-US" sz="1800" dirty="0"/>
           </a:p>
@@ -4005,7 +4081,7 @@
                 <a:ea typeface="Arial" pitchFamily="34" charset="-122"/>
                 <a:cs typeface="Arial" pitchFamily="34" charset="-120"/>
               </a:rPr>
-              <a:t>pytest · Flask-Login</a:t>
+              <a:t>Lecturer asked to confirm Python</a:t>
             </a:r>
             <a:endParaRPr lang="en-US" sz="1800" dirty="0"/>
           </a:p>
@@ -4119,7 +4195,7 @@
                 <a:ea typeface="Arial" pitchFamily="34" charset="-122"/>
                 <a:cs typeface="Arial" pitchFamily="34" charset="-120"/>
               </a:rPr>
-              <a:t>Six iterations land Part 2 on 15/11, with a freeze and a buffer day</a:t>
+              <a:t>Six iterations; Part 2 never depends on the last one</a:t>
             </a:r>
             <a:endParaRPr lang="en-US" sz="2600" dirty="0"/>
           </a:p>
@@ -4158,7 +4234,7 @@
                 <a:ea typeface="Arial" pitchFamily="34" charset="-122"/>
                 <a:cs typeface="Arial" pitchFamily="34" charset="-120"/>
               </a:rPr>
-              <a:t>Real dates 17/10 to 30/11; Part 2 does not rely on I6.</a:t>
+              <a:t>Weekly view; red marks are decision points.</a:t>
             </a:r>
             <a:endParaRPr lang="en-US" sz="1800" dirty="0"/>
           </a:p>
@@ -4884,45 +4960,6 @@
         </p:nvSpPr>
         <p:spPr>
           <a:xfrm>
-            <a:off x="5516880" y="2011680"/>
-            <a:ext cx="1691640" cy="265176"/>
-          </a:xfrm>
-          <a:prstGeom prst="rect">
-            <a:avLst/>
-          </a:prstGeom>
-          <a:noFill/>
-          <a:ln/>
-        </p:spPr>
-        <p:txBody>
-          <a:bodyPr wrap="none" lIns="0" tIns="0" rIns="0" bIns="0" rtlCol="0" anchor="ctr"/>
-          <a:lstStyle/>
-          <a:p>
-            <a:pPr algn="l" indent="0" marL="0">
-              <a:buNone/>
-            </a:pPr>
-            <a:r>
-              <a:rPr lang="en-US" sz="1600" dirty="0">
-                <a:solidFill>
-                  <a:srgbClr val="1F2937"/>
-                </a:solidFill>
-                <a:latin typeface="Arial" pitchFamily="34" charset="0"/>
-                <a:ea typeface="Arial" pitchFamily="34" charset="-122"/>
-                <a:cs typeface="Arial" pitchFamily="34" charset="-120"/>
-              </a:rPr>
-              <a:t>17/10 to 22/10</a:t>
-            </a:r>
-            <a:endParaRPr lang="en-US" sz="1600" dirty="0"/>
-          </a:p>
-        </p:txBody>
-      </p:sp>
-      <p:sp>
-        <p:nvSpPr>
-          <p:cNvPr id="31" name="Text 29"/>
-          <p:cNvSpPr txBox="1"/>
-          <p:nvPr/>
-        </p:nvSpPr>
-        <p:spPr>
-          <a:xfrm>
             <a:off x="530352" y="2276856"/>
             <a:ext cx="3931920" cy="265176"/>
           </a:xfrm>
@@ -4956,7 +4993,7 @@
       </p:sp>
       <p:sp>
         <p:nvSpPr>
-          <p:cNvPr id="32" name="Bar"/>
+          <p:cNvPr id="31" name="Bar"/>
           <p:cNvSpPr/>
           <p:nvPr/>
         </p:nvSpPr>
@@ -4976,46 +5013,7 @@
       </p:sp>
       <p:sp>
         <p:nvSpPr>
-          <p:cNvPr id="33" name="Text 31"/>
-          <p:cNvSpPr txBox="1"/>
-          <p:nvPr/>
-        </p:nvSpPr>
-        <p:spPr>
-          <a:xfrm>
-            <a:off x="5998464" y="2276856"/>
-            <a:ext cx="1691640" cy="265176"/>
-          </a:xfrm>
-          <a:prstGeom prst="rect">
-            <a:avLst/>
-          </a:prstGeom>
-          <a:noFill/>
-          <a:ln/>
-        </p:spPr>
-        <p:txBody>
-          <a:bodyPr wrap="none" lIns="0" tIns="0" rIns="0" bIns="0" rtlCol="0" anchor="ctr"/>
-          <a:lstStyle/>
-          <a:p>
-            <a:pPr algn="l" indent="0" marL="0">
-              <a:buNone/>
-            </a:pPr>
-            <a:r>
-              <a:rPr lang="en-US" sz="1600" dirty="0">
-                <a:solidFill>
-                  <a:srgbClr val="1F2937"/>
-                </a:solidFill>
-                <a:latin typeface="Arial" pitchFamily="34" charset="0"/>
-                <a:ea typeface="Arial" pitchFamily="34" charset="-122"/>
-                <a:cs typeface="Arial" pitchFamily="34" charset="-120"/>
-              </a:rPr>
-              <a:t>23/10 to 25/10</a:t>
-            </a:r>
-            <a:endParaRPr lang="en-US" sz="1600" dirty="0"/>
-          </a:p>
-        </p:txBody>
-      </p:sp>
-      <p:sp>
-        <p:nvSpPr>
-          <p:cNvPr id="34" name="Text 32"/>
+          <p:cNvPr id="32" name="Text 30"/>
           <p:cNvSpPr txBox="1"/>
           <p:nvPr/>
         </p:nvSpPr>
@@ -5054,7 +5052,7 @@
       </p:sp>
       <p:sp>
         <p:nvSpPr>
-          <p:cNvPr id="35" name="Milestone"/>
+          <p:cNvPr id="33" name="Milestone"/>
           <p:cNvSpPr/>
           <p:nvPr/>
         </p:nvSpPr>
@@ -5074,7 +5072,7 @@
       </p:sp>
       <p:sp>
         <p:nvSpPr>
-          <p:cNvPr id="36" name="Text 34"/>
+          <p:cNvPr id="34" name="Text 32"/>
           <p:cNvSpPr txBox="1"/>
           <p:nvPr/>
         </p:nvSpPr>
@@ -5113,7 +5111,7 @@
       </p:sp>
       <p:sp>
         <p:nvSpPr>
-          <p:cNvPr id="37" name="Text 35"/>
+          <p:cNvPr id="35" name="Text 33"/>
           <p:cNvSpPr txBox="1"/>
           <p:nvPr/>
         </p:nvSpPr>
@@ -5144,7 +5142,7 @@
                 <a:ea typeface="Arial" pitchFamily="34" charset="-122"/>
                 <a:cs typeface="Arial" pitchFamily="34" charset="-120"/>
               </a:rPr>
-              <a:t>I2 Hub CRUD, Kitchen board</a:t>
+              <a:t>I2 Hubs, capacity, kitchen</a:t>
             </a:r>
             <a:endParaRPr lang="en-US" sz="1600" dirty="0"/>
           </a:p>
@@ -5152,7 +5150,7 @@
       </p:sp>
       <p:sp>
         <p:nvSpPr>
-          <p:cNvPr id="38" name="Bar"/>
+          <p:cNvPr id="36" name="Bar"/>
           <p:cNvSpPr/>
           <p:nvPr/>
         </p:nvSpPr>
@@ -5172,46 +5170,7 @@
       </p:sp>
       <p:sp>
         <p:nvSpPr>
-          <p:cNvPr id="39" name="Text 37"/>
-          <p:cNvSpPr txBox="1"/>
-          <p:nvPr/>
-        </p:nvSpPr>
-        <p:spPr>
-          <a:xfrm>
-            <a:off x="6961632" y="2807208"/>
-            <a:ext cx="1691640" cy="265176"/>
-          </a:xfrm>
-          <a:prstGeom prst="rect">
-            <a:avLst/>
-          </a:prstGeom>
-          <a:noFill/>
-          <a:ln/>
-        </p:spPr>
-        <p:txBody>
-          <a:bodyPr wrap="none" lIns="0" tIns="0" rIns="0" bIns="0" rtlCol="0" anchor="ctr"/>
-          <a:lstStyle/>
-          <a:p>
-            <a:pPr algn="l" indent="0" marL="0">
-              <a:buNone/>
-            </a:pPr>
-            <a:r>
-              <a:rPr lang="en-US" sz="1600" dirty="0">
-                <a:solidFill>
-                  <a:srgbClr val="1F2937"/>
-                </a:solidFill>
-                <a:latin typeface="Arial" pitchFamily="34" charset="0"/>
-                <a:ea typeface="Arial" pitchFamily="34" charset="-122"/>
-                <a:cs typeface="Arial" pitchFamily="34" charset="-120"/>
-              </a:rPr>
-              <a:t>27/10 to 31/10</a:t>
-            </a:r>
-            <a:endParaRPr lang="en-US" sz="1600" dirty="0"/>
-          </a:p>
-        </p:txBody>
-      </p:sp>
-      <p:sp>
-        <p:nvSpPr>
-          <p:cNvPr id="40" name="Text 38"/>
+          <p:cNvPr id="37" name="Text 35"/>
           <p:cNvSpPr txBox="1"/>
           <p:nvPr/>
         </p:nvSpPr>
@@ -5242,7 +5201,7 @@
                 <a:ea typeface="Arial" pitchFamily="34" charset="-122"/>
                 <a:cs typeface="Arial" pitchFamily="34" charset="-120"/>
               </a:rPr>
-              <a:t>L1 to L4 answers needed</a:t>
+              <a:t>Lecturer answers needed</a:t>
             </a:r>
             <a:endParaRPr lang="en-US" sz="1600" dirty="0"/>
           </a:p>
@@ -5250,7 +5209,7 @@
       </p:sp>
       <p:sp>
         <p:nvSpPr>
-          <p:cNvPr id="41" name="Milestone"/>
+          <p:cNvPr id="38" name="Milestone"/>
           <p:cNvSpPr/>
           <p:nvPr/>
         </p:nvSpPr>
@@ -5270,7 +5229,7 @@
       </p:sp>
       <p:sp>
         <p:nvSpPr>
-          <p:cNvPr id="42" name="Text 40"/>
+          <p:cNvPr id="39" name="Text 37"/>
           <p:cNvSpPr txBox="1"/>
           <p:nvPr/>
         </p:nvSpPr>
@@ -5309,7 +5268,7 @@
       </p:sp>
       <p:sp>
         <p:nvSpPr>
-          <p:cNvPr id="43" name="Text 41"/>
+          <p:cNvPr id="40" name="Text 38"/>
           <p:cNvSpPr txBox="1"/>
           <p:nvPr/>
         </p:nvSpPr>
@@ -5340,7 +5299,7 @@
                 <a:ea typeface="Arial" pitchFamily="34" charset="-122"/>
                 <a:cs typeface="Arial" pitchFamily="34" charset="-120"/>
               </a:rPr>
-              <a:t>I3 Full ordering, delivery</a:t>
+              <a:t>I3 Ordering, delivery, menus</a:t>
             </a:r>
             <a:endParaRPr lang="en-US" sz="1600" dirty="0"/>
           </a:p>
@@ -5348,7 +5307,7 @@
       </p:sp>
       <p:sp>
         <p:nvSpPr>
-          <p:cNvPr id="44" name="Bar"/>
+          <p:cNvPr id="41" name="Bar"/>
           <p:cNvSpPr/>
           <p:nvPr/>
         </p:nvSpPr>
@@ -5368,46 +5327,7 @@
       </p:sp>
       <p:sp>
         <p:nvSpPr>
-          <p:cNvPr id="45" name="Text 43"/>
-          <p:cNvSpPr txBox="1"/>
-          <p:nvPr/>
-        </p:nvSpPr>
-        <p:spPr>
-          <a:xfrm>
-            <a:off x="7764272" y="3337560"/>
-            <a:ext cx="1691640" cy="265176"/>
-          </a:xfrm>
-          <a:prstGeom prst="rect">
-            <a:avLst/>
-          </a:prstGeom>
-          <a:noFill/>
-          <a:ln/>
-        </p:spPr>
-        <p:txBody>
-          <a:bodyPr wrap="none" lIns="0" tIns="0" rIns="0" bIns="0" rtlCol="0" anchor="ctr"/>
-          <a:lstStyle/>
-          <a:p>
-            <a:pPr algn="l" indent="0" marL="0">
-              <a:buNone/>
-            </a:pPr>
-            <a:r>
-              <a:rPr lang="en-US" sz="1600" dirty="0">
-                <a:solidFill>
-                  <a:srgbClr val="1F2937"/>
-                </a:solidFill>
-                <a:latin typeface="Arial" pitchFamily="34" charset="0"/>
-                <a:ea typeface="Arial" pitchFamily="34" charset="-122"/>
-                <a:cs typeface="Arial" pitchFamily="34" charset="-120"/>
-              </a:rPr>
-              <a:t>01/11 to 05/11</a:t>
-            </a:r>
-            <a:endParaRPr lang="en-US" sz="1600" dirty="0"/>
-          </a:p>
-        </p:txBody>
-      </p:sp>
-      <p:sp>
-        <p:nvSpPr>
-          <p:cNvPr id="46" name="Text 44"/>
+          <p:cNvPr id="42" name="Text 40"/>
           <p:cNvSpPr txBox="1"/>
           <p:nvPr/>
         </p:nvSpPr>
@@ -5446,7 +5366,7 @@
       </p:sp>
       <p:sp>
         <p:nvSpPr>
-          <p:cNvPr id="47" name="Bar"/>
+          <p:cNvPr id="43" name="Bar"/>
           <p:cNvSpPr/>
           <p:nvPr/>
         </p:nvSpPr>
@@ -5466,46 +5386,7 @@
       </p:sp>
       <p:sp>
         <p:nvSpPr>
-          <p:cNvPr id="48" name="Text 46"/>
-          <p:cNvSpPr txBox="1"/>
-          <p:nvPr/>
-        </p:nvSpPr>
-        <p:spPr>
-          <a:xfrm>
-            <a:off x="8566912" y="3602736"/>
-            <a:ext cx="1691640" cy="265176"/>
-          </a:xfrm>
-          <a:prstGeom prst="rect">
-            <a:avLst/>
-          </a:prstGeom>
-          <a:noFill/>
-          <a:ln/>
-        </p:spPr>
-        <p:txBody>
-          <a:bodyPr wrap="none" lIns="0" tIns="0" rIns="0" bIns="0" rtlCol="0" anchor="ctr"/>
-          <a:lstStyle/>
-          <a:p>
-            <a:pPr algn="l" indent="0" marL="0">
-              <a:buNone/>
-            </a:pPr>
-            <a:r>
-              <a:rPr lang="en-US" sz="1600" dirty="0">
-                <a:solidFill>
-                  <a:srgbClr val="1F2937"/>
-                </a:solidFill>
-                <a:latin typeface="Arial" pitchFamily="34" charset="0"/>
-                <a:ea typeface="Arial" pitchFamily="34" charset="-122"/>
-                <a:cs typeface="Arial" pitchFamily="34" charset="-120"/>
-              </a:rPr>
-              <a:t>06/11 to 10/11</a:t>
-            </a:r>
-            <a:endParaRPr lang="en-US" sz="1600" dirty="0"/>
-          </a:p>
-        </p:txBody>
-      </p:sp>
-      <p:sp>
-        <p:nvSpPr>
-          <p:cNvPr id="49" name="Text 47"/>
+          <p:cNvPr id="44" name="Text 42"/>
           <p:cNvSpPr txBox="1"/>
           <p:nvPr/>
         </p:nvSpPr>
@@ -5544,7 +5425,7 @@
       </p:sp>
       <p:sp>
         <p:nvSpPr>
-          <p:cNvPr id="50" name="Bar"/>
+          <p:cNvPr id="45" name="Bar"/>
           <p:cNvSpPr/>
           <p:nvPr/>
         </p:nvSpPr>
@@ -5564,46 +5445,7 @@
       </p:sp>
       <p:sp>
         <p:nvSpPr>
-          <p:cNvPr id="51" name="Text 49"/>
-          <p:cNvSpPr txBox="1"/>
-          <p:nvPr/>
-        </p:nvSpPr>
-        <p:spPr>
-          <a:xfrm>
-            <a:off x="9369552" y="3867912"/>
-            <a:ext cx="1691640" cy="265176"/>
-          </a:xfrm>
-          <a:prstGeom prst="rect">
-            <a:avLst/>
-          </a:prstGeom>
-          <a:noFill/>
-          <a:ln/>
-        </p:spPr>
-        <p:txBody>
-          <a:bodyPr wrap="none" lIns="0" tIns="0" rIns="0" bIns="0" rtlCol="0" anchor="ctr"/>
-          <a:lstStyle/>
-          <a:p>
-            <a:pPr algn="l" indent="0" marL="0">
-              <a:buNone/>
-            </a:pPr>
-            <a:r>
-              <a:rPr lang="en-US" sz="1600" dirty="0">
-                <a:solidFill>
-                  <a:srgbClr val="1F2937"/>
-                </a:solidFill>
-                <a:latin typeface="Arial" pitchFamily="34" charset="0"/>
-                <a:ea typeface="Arial" pitchFamily="34" charset="-122"/>
-                <a:cs typeface="Arial" pitchFamily="34" charset="-120"/>
-              </a:rPr>
-              <a:t>11/11 to 15/11</a:t>
-            </a:r>
-            <a:endParaRPr lang="en-US" sz="1600" dirty="0"/>
-          </a:p>
-        </p:txBody>
-      </p:sp>
-      <p:sp>
-        <p:nvSpPr>
-          <p:cNvPr id="52" name="Text 50"/>
+          <p:cNvPr id="46" name="Text 44"/>
           <p:cNvSpPr txBox="1"/>
           <p:nvPr/>
         </p:nvSpPr>
@@ -5642,7 +5484,7 @@
       </p:sp>
       <p:sp>
         <p:nvSpPr>
-          <p:cNvPr id="53" name="Milestone"/>
+          <p:cNvPr id="47" name="Milestone"/>
           <p:cNvSpPr/>
           <p:nvPr/>
         </p:nvSpPr>
@@ -5662,7 +5504,7 @@
       </p:sp>
       <p:sp>
         <p:nvSpPr>
-          <p:cNvPr id="54" name="Text 52"/>
+          <p:cNvPr id="48" name="Text 46"/>
           <p:cNvSpPr txBox="1"/>
           <p:nvPr/>
         </p:nvSpPr>
@@ -5701,7 +5543,7 @@
       </p:sp>
       <p:sp>
         <p:nvSpPr>
-          <p:cNvPr id="55" name="Text 53"/>
+          <p:cNvPr id="49" name="Text 47"/>
           <p:cNvSpPr txBox="1"/>
           <p:nvPr/>
         </p:nvSpPr>
@@ -5740,7 +5582,7 @@
       </p:sp>
       <p:sp>
         <p:nvSpPr>
-          <p:cNvPr id="56" name="Bar"/>
+          <p:cNvPr id="50" name="Bar"/>
           <p:cNvSpPr/>
           <p:nvPr/>
         </p:nvSpPr>
@@ -5760,7 +5602,7 @@
       </p:sp>
       <p:sp>
         <p:nvSpPr>
-          <p:cNvPr id="57" name="Text 55"/>
+          <p:cNvPr id="51" name="Text 49"/>
           <p:cNvSpPr txBox="1"/>
           <p:nvPr/>
         </p:nvSpPr>
@@ -5799,7 +5641,7 @@
       </p:sp>
       <p:sp>
         <p:nvSpPr>
-          <p:cNvPr id="58" name="Text 56"/>
+          <p:cNvPr id="52" name="Text 50"/>
           <p:cNvSpPr txBox="1"/>
           <p:nvPr/>
         </p:nvSpPr>
@@ -5838,7 +5680,7 @@
       </p:sp>
       <p:sp>
         <p:nvSpPr>
-          <p:cNvPr id="59" name="Milestone"/>
+          <p:cNvPr id="53" name="Milestone"/>
           <p:cNvSpPr/>
           <p:nvPr/>
         </p:nvSpPr>
@@ -5858,7 +5700,7 @@
       </p:sp>
       <p:sp>
         <p:nvSpPr>
-          <p:cNvPr id="60" name="Text 58"/>
+          <p:cNvPr id="54" name="Text 52"/>
           <p:cNvSpPr txBox="1"/>
           <p:nvPr/>
         </p:nvSpPr>
@@ -5897,7 +5739,7 @@
       </p:sp>
       <p:sp>
         <p:nvSpPr>
-          <p:cNvPr id="61" name="Text 59"/>
+          <p:cNvPr id="55" name="Text 53"/>
           <p:cNvSpPr txBox="1"/>
           <p:nvPr/>
         </p:nvSpPr>
@@ -5936,7 +5778,7 @@
       </p:sp>
       <p:sp>
         <p:nvSpPr>
-          <p:cNvPr id="62" name="Milestone"/>
+          <p:cNvPr id="56" name="Milestone"/>
           <p:cNvSpPr/>
           <p:nvPr/>
         </p:nvSpPr>
@@ -5956,7 +5798,7 @@
       </p:sp>
       <p:sp>
         <p:nvSpPr>
-          <p:cNvPr id="63" name="Text 61"/>
+          <p:cNvPr id="57" name="Text 55"/>
           <p:cNvSpPr txBox="1"/>
           <p:nvPr/>
         </p:nvSpPr>
@@ -5995,7 +5837,7 @@
       </p:sp>
       <p:sp>
         <p:nvSpPr>
-          <p:cNvPr id="64" name="Text 62"/>
+          <p:cNvPr id="58" name="Text 56"/>
           <p:cNvSpPr txBox="1"/>
           <p:nvPr/>
         </p:nvSpPr>
@@ -6034,7 +5876,7 @@
       </p:sp>
       <p:sp>
         <p:nvSpPr>
-          <p:cNvPr id="65" name="Bar"/>
+          <p:cNvPr id="59" name="Bar"/>
           <p:cNvSpPr/>
           <p:nvPr/>
         </p:nvSpPr>
@@ -6054,46 +5896,7 @@
       </p:sp>
       <p:sp>
         <p:nvSpPr>
-          <p:cNvPr id="66" name="Text 64"/>
-          <p:cNvSpPr txBox="1"/>
-          <p:nvPr/>
-        </p:nvSpPr>
-        <p:spPr>
-          <a:xfrm>
-            <a:off x="7692136" y="5193792"/>
-            <a:ext cx="1691640" cy="265176"/>
-          </a:xfrm>
-          <a:prstGeom prst="rect">
-            <a:avLst/>
-          </a:prstGeom>
-          <a:noFill/>
-          <a:ln/>
-        </p:spPr>
-        <p:txBody>
-          <a:bodyPr wrap="none" lIns="0" tIns="0" rIns="0" bIns="0" rtlCol="0" anchor="ctr"/>
-          <a:lstStyle/>
-          <a:p>
-            <a:pPr algn="r" indent="0" marL="0">
-              <a:buNone/>
-            </a:pPr>
-            <a:r>
-              <a:rPr lang="en-US" sz="1600" dirty="0">
-                <a:solidFill>
-                  <a:srgbClr val="1F2937"/>
-                </a:solidFill>
-                <a:latin typeface="Arial" pitchFamily="34" charset="0"/>
-                <a:ea typeface="Arial" pitchFamily="34" charset="-122"/>
-                <a:cs typeface="Arial" pitchFamily="34" charset="-120"/>
-              </a:rPr>
-              <a:t>17/11 to 29/11</a:t>
-            </a:r>
-            <a:endParaRPr lang="en-US" sz="1600" dirty="0"/>
-          </a:p>
-        </p:txBody>
-      </p:sp>
-      <p:sp>
-        <p:nvSpPr>
-          <p:cNvPr id="67" name="Text 65"/>
+          <p:cNvPr id="60" name="Text 58"/>
           <p:cNvSpPr txBox="1"/>
           <p:nvPr/>
         </p:nvSpPr>
@@ -6132,7 +5935,7 @@
       </p:sp>
       <p:sp>
         <p:nvSpPr>
-          <p:cNvPr id="68" name="Milestone"/>
+          <p:cNvPr id="61" name="Milestone"/>
           <p:cNvSpPr/>
           <p:nvPr/>
         </p:nvSpPr>
@@ -6152,7 +5955,7 @@
       </p:sp>
       <p:sp>
         <p:nvSpPr>
-          <p:cNvPr id="69" name="Text 67"/>
+          <p:cNvPr id="62" name="Text 60"/>
           <p:cNvSpPr txBox="1"/>
           <p:nvPr/>
         </p:nvSpPr>
@@ -6191,7 +5994,7 @@
       </p:sp>
       <p:sp>
         <p:nvSpPr>
-          <p:cNvPr id="70" name="Text 68"/>
+          <p:cNvPr id="63" name="Text 61"/>
           <p:cNvSpPr txBox="1"/>
           <p:nvPr/>
         </p:nvSpPr>
@@ -6230,7 +6033,7 @@
       </p:sp>
       <p:sp>
         <p:nvSpPr>
-          <p:cNvPr id="71" name="Milestone"/>
+          <p:cNvPr id="64" name="Milestone"/>
           <p:cNvSpPr/>
           <p:nvPr/>
         </p:nvSpPr>
@@ -6250,7 +6053,7 @@
       </p:sp>
       <p:sp>
         <p:nvSpPr>
-          <p:cNvPr id="72" name="Text 70"/>
+          <p:cNvPr id="65" name="Text 63"/>
           <p:cNvSpPr txBox="1"/>
           <p:nvPr/>
         </p:nvSpPr>
@@ -6289,7 +6092,7 @@
       </p:sp>
       <p:sp>
         <p:nvSpPr>
-          <p:cNvPr id="73" name="Card"/>
+          <p:cNvPr id="66" name="Card"/>
           <p:cNvSpPr/>
           <p:nvPr/>
         </p:nvSpPr>
@@ -6309,7 +6112,7 @@
       </p:sp>
       <p:sp>
         <p:nvSpPr>
-          <p:cNvPr id="74" name="Text 72"/>
+          <p:cNvPr id="67" name="Text 65"/>
           <p:cNvSpPr txBox="1"/>
           <p:nvPr/>
         </p:nvSpPr>
@@ -6354,7 +6157,7 @@
                 <a:ea typeface="Arial" pitchFamily="34" charset="-122"/>
                 <a:cs typeface="Arial" pitchFamily="34" charset="-120"/>
               </a:rPr>
-              <a:t>answers 31/10 · freeze 12/11 · buffer 13/11 · I6 is not a rescue buffer</a:t>
+              <a:t>decide scope by 31/10 · freeze 12/11 · buffer day 13/11 · I6 only for feedback</a:t>
             </a:r>
             <a:endParaRPr lang="en-US" sz="1800" dirty="0"/>
           </a:p>
@@ -6507,7 +6310,7 @@
                 <a:ea typeface="Arial" pitchFamily="34" charset="-122"/>
                 <a:cs typeface="Arial" pitchFamily="34" charset="-120"/>
               </a:rPr>
-              <a:t>About 4 focused hours per student per day, 48 person-hours; setup is part of D1.</a:t>
+              <a:t>17–22/10, two people, about 4 focused hours each per day (48 person-hours).</a:t>
             </a:r>
             <a:endParaRPr lang="en-US" sz="1800" dirty="0"/>
           </a:p>
@@ -6536,11 +6339,11 @@
             <a:tbl>
               <a:tblPr/>
               <a:tblGrid>
-                <a:gridCol w="1417320"/>
-                <a:gridCol w="2377440"/>
-                <a:gridCol w="2560320"/>
+                <a:gridCol w="822960"/>
                 <a:gridCol w="2651760"/>
-                <a:gridCol w="2270455"/>
+                <a:gridCol w="2743200"/>
+                <a:gridCol w="2743200"/>
+                <a:gridCol w="2316175"/>
               </a:tblGrid>
               <a:tr h="411480">
                 <a:tc>
@@ -6764,7 +6567,7 @@
                           <a:ea typeface="Arial" pitchFamily="34" charset="-122"/>
                           <a:cs typeface="Arial" pitchFamily="34" charset="-120"/>
                         </a:rPr>
-                        <a:t>Quan (foundation)</a:t>
+                        <a:t>Quan L. (foundation)</a:t>
                       </a:r>
                       <a:endParaRPr lang="en-US" sz="1600" dirty="0">
                         <a:latin typeface="Arial" charset="0"/>
@@ -6910,27 +6713,6 @@
                         <a:cs typeface="Arial" charset="0"/>
                       </a:endParaRPr>
                     </a:p>
-                    <a:p>
-                      <a:pPr algn="l" indent="0" marL="0">
-                        <a:buNone/>
-                      </a:pPr>
-                      <a:r>
-                        <a:rPr lang="en-US" sz="1600" b="1" dirty="0">
-                          <a:solidFill>
-                            <a:srgbClr val="004387"/>
-                          </a:solidFill>
-                          <a:latin typeface="Arial" pitchFamily="34" charset="0"/>
-                          <a:ea typeface="Arial" pitchFamily="34" charset="-122"/>
-                          <a:cs typeface="Arial" pitchFamily="34" charset="-120"/>
-                        </a:rPr>
-                        <a:t>Sat 17/10</a:t>
-                      </a:r>
-                      <a:endParaRPr lang="en-US" sz="1600" dirty="0">
-                        <a:latin typeface="Arial" charset="0"/>
-                        <a:ea typeface="Arial" charset="0"/>
-                        <a:cs typeface="Arial" charset="0"/>
-                      </a:endParaRPr>
-                    </a:p>
                   </a:txBody>
                   <a:tcPr marL="91440" marR="91440" marT="36576" marB="36576" anchor="ctr">
                     <a:lnL w="9525" cap="flat" cmpd="sng" algn="ctr">
@@ -7261,27 +7043,6 @@
                         <a:cs typeface="Arial" charset="0"/>
                       </a:endParaRPr>
                     </a:p>
-                    <a:p>
-                      <a:pPr algn="l" indent="0" marL="0">
-                        <a:buNone/>
-                      </a:pPr>
-                      <a:r>
-                        <a:rPr lang="en-US" sz="1600" b="1" dirty="0">
-                          <a:solidFill>
-                            <a:srgbClr val="004387"/>
-                          </a:solidFill>
-                          <a:latin typeface="Arial" pitchFamily="34" charset="0"/>
-                          <a:ea typeface="Arial" pitchFamily="34" charset="-122"/>
-                          <a:cs typeface="Arial" pitchFamily="34" charset="-120"/>
-                        </a:rPr>
-                        <a:t>Sun 18/10</a:t>
-                      </a:r>
-                      <a:endParaRPr lang="en-US" sz="1600" dirty="0">
-                        <a:latin typeface="Arial" charset="0"/>
-                        <a:ea typeface="Arial" charset="0"/>
-                        <a:cs typeface="Arial" charset="0"/>
-                      </a:endParaRPr>
-                    </a:p>
                   </a:txBody>
                   <a:tcPr marL="91440" marR="91440" marT="36576" marB="36576" anchor="ctr">
                     <a:lnL w="9525" cap="flat" cmpd="sng" algn="ctr">
@@ -7612,27 +7373,6 @@
                         <a:cs typeface="Arial" charset="0"/>
                       </a:endParaRPr>
                     </a:p>
-                    <a:p>
-                      <a:pPr algn="l" indent="0" marL="0">
-                        <a:buNone/>
-                      </a:pPr>
-                      <a:r>
-                        <a:rPr lang="en-US" sz="1600" b="1" dirty="0">
-                          <a:solidFill>
-                            <a:srgbClr val="004387"/>
-                          </a:solidFill>
-                          <a:latin typeface="Arial" pitchFamily="34" charset="0"/>
-                          <a:ea typeface="Arial" pitchFamily="34" charset="-122"/>
-                          <a:cs typeface="Arial" pitchFamily="34" charset="-120"/>
-                        </a:rPr>
-                        <a:t>Mon 19/10</a:t>
-                      </a:r>
-                      <a:endParaRPr lang="en-US" sz="1600" dirty="0">
-                        <a:latin typeface="Arial" charset="0"/>
-                        <a:ea typeface="Arial" charset="0"/>
-                        <a:cs typeface="Arial" charset="0"/>
-                      </a:endParaRPr>
-                    </a:p>
                   </a:txBody>
                   <a:tcPr marL="91440" marR="91440" marT="36576" marB="36576" anchor="ctr">
                     <a:lnL w="9525" cap="flat" cmpd="sng" algn="ctr">
@@ -7963,27 +7703,6 @@
                         <a:cs typeface="Arial" charset="0"/>
                       </a:endParaRPr>
                     </a:p>
-                    <a:p>
-                      <a:pPr algn="l" indent="0" marL="0">
-                        <a:buNone/>
-                      </a:pPr>
-                      <a:r>
-                        <a:rPr lang="en-US" sz="1600" b="1" dirty="0">
-                          <a:solidFill>
-                            <a:srgbClr val="004387"/>
-                          </a:solidFill>
-                          <a:latin typeface="Arial" pitchFamily="34" charset="0"/>
-                          <a:ea typeface="Arial" pitchFamily="34" charset="-122"/>
-                          <a:cs typeface="Arial" pitchFamily="34" charset="-120"/>
-                        </a:rPr>
-                        <a:t>Tue 20/10</a:t>
-                      </a:r>
-                      <a:endParaRPr lang="en-US" sz="1600" dirty="0">
-                        <a:latin typeface="Arial" charset="0"/>
-                        <a:ea typeface="Arial" charset="0"/>
-                        <a:cs typeface="Arial" charset="0"/>
-                      </a:endParaRPr>
-                    </a:p>
                   </a:txBody>
                   <a:tcPr marL="91440" marR="91440" marT="36576" marB="36576" anchor="ctr">
                     <a:lnL w="9525" cap="flat" cmpd="sng" algn="ctr">
@@ -8314,27 +8033,6 @@
                         <a:cs typeface="Arial" charset="0"/>
                       </a:endParaRPr>
                     </a:p>
-                    <a:p>
-                      <a:pPr algn="l" indent="0" marL="0">
-                        <a:buNone/>
-                      </a:pPr>
-                      <a:r>
-                        <a:rPr lang="en-US" sz="1600" b="1" dirty="0">
-                          <a:solidFill>
-                            <a:srgbClr val="004387"/>
-                          </a:solidFill>
-                          <a:latin typeface="Arial" pitchFamily="34" charset="0"/>
-                          <a:ea typeface="Arial" pitchFamily="34" charset="-122"/>
-                          <a:cs typeface="Arial" pitchFamily="34" charset="-120"/>
-                        </a:rPr>
-                        <a:t>Wed 21/10</a:t>
-                      </a:r>
-                      <a:endParaRPr lang="en-US" sz="1600" dirty="0">
-                        <a:latin typeface="Arial" charset="0"/>
-                        <a:ea typeface="Arial" charset="0"/>
-                        <a:cs typeface="Arial" charset="0"/>
-                      </a:endParaRPr>
-                    </a:p>
                   </a:txBody>
                   <a:tcPr marL="91440" marR="91440" marT="36576" marB="36576" anchor="ctr">
                     <a:lnL w="9525" cap="flat" cmpd="sng" algn="ctr">
@@ -8665,27 +8363,6 @@
                         <a:cs typeface="Arial" charset="0"/>
                       </a:endParaRPr>
                     </a:p>
-                    <a:p>
-                      <a:pPr algn="l" indent="0" marL="0">
-                        <a:buNone/>
-                      </a:pPr>
-                      <a:r>
-                        <a:rPr lang="en-US" sz="1600" b="1" dirty="0">
-                          <a:solidFill>
-                            <a:srgbClr val="004387"/>
-                          </a:solidFill>
-                          <a:latin typeface="Arial" pitchFamily="34" charset="0"/>
-                          <a:ea typeface="Arial" pitchFamily="34" charset="-122"/>
-                          <a:cs typeface="Arial" pitchFamily="34" charset="-120"/>
-                        </a:rPr>
-                        <a:t>Thu 22/10</a:t>
-                      </a:r>
-                      <a:endParaRPr lang="en-US" sz="1600" dirty="0">
-                        <a:latin typeface="Arial" charset="0"/>
-                        <a:ea typeface="Arial" charset="0"/>
-                        <a:cs typeface="Arial" charset="0"/>
-                      </a:endParaRPr>
-                    </a:p>
                   </a:txBody>
                   <a:tcPr marL="91440" marR="91440" marT="36576" marB="36576" anchor="ctr">
                     <a:lnL w="9525" cap="flat" cmpd="sng" algn="ctr">
@@ -9102,7 +8779,7 @@
                 <a:ea typeface="Arial" pitchFamily="34" charset="-122"/>
                 <a:cs typeface="Arial" pitchFamily="34" charset="-120"/>
               </a:rPr>
-              <a:t>Iteration 1: COD order persisted and tested; 7 of 9 criteria met</a:t>
+              <a:t>Iteration 1: a COD order saved end to end; 8 of 9 criteria met</a:t>
             </a:r>
             <a:endParaRPr lang="en-US" sz="2600" dirty="0"/>
           </a:p>
@@ -9141,7 +8818,7 @@
                 <a:ea typeface="Arial" pitchFamily="34" charset="-122"/>
                 <a:cs typeface="Arial" pitchFamily="34" charset="-120"/>
               </a:rPr>
-              <a:t>Real figures from the repository, the pytest output and the hours log.</a:t>
+              <a:t>As of 20/10, from the repository and the pytest output.</a:t>
             </a:r>
             <a:endParaRPr lang="en-US" sz="1800" dirty="0"/>
           </a:p>
@@ -9398,7 +9075,7 @@
                           <a:ea typeface="Arial" pitchFamily="34" charset="-122"/>
                           <a:cs typeface="Arial" pitchFamily="34" charset="-120"/>
                         </a:rPr>
-                        <a:t>Days with evidence</a:t>
+                        <a:t>Criteria met</a:t>
                       </a:r>
                       <a:endParaRPr lang="en-US" sz="1600" dirty="0">
                         <a:latin typeface="Arial" charset="0"/>
@@ -9463,7 +9140,7 @@
                           <a:ea typeface="Arial" pitchFamily="34" charset="-122"/>
                           <a:cs typeface="Arial" pitchFamily="34" charset="-120"/>
                         </a:rPr>
-                        <a:t>6</a:t>
+                        <a:t>9 of 9</a:t>
                       </a:r>
                       <a:endParaRPr lang="en-US" sz="1600" dirty="0">
                         <a:latin typeface="Arial" charset="0"/>
@@ -9528,7 +9205,598 @@
                           <a:ea typeface="Arial" pitchFamily="34" charset="-122"/>
                           <a:cs typeface="Arial" pitchFamily="34" charset="-120"/>
                         </a:rPr>
-                        <a:t>D3–D5 scope built on D3; D6 open</a:t>
+                        <a:t>8 of 9 (AC-1 partial)</a:t>
+                      </a:r>
+                      <a:endParaRPr lang="en-US" sz="1600" dirty="0">
+                        <a:latin typeface="Arial" charset="0"/>
+                        <a:ea typeface="Arial" charset="0"/>
+                        <a:cs typeface="Arial" charset="0"/>
+                      </a:endParaRPr>
+                    </a:p>
+                  </a:txBody>
+                  <a:tcPr marL="91440" marR="91440" marT="36576" marB="36576" anchor="ctr">
+                    <a:lnL w="9525" cap="flat" cmpd="sng" algn="ctr">
+                      <a:solidFill>
+                        <a:srgbClr val="C9D3DC"/>
+                      </a:solidFill>
+                      <a:prstDash val="solid"/>
+                      <a:round/>
+                      <a:headEnd type="none" w="med" len="med"/>
+                      <a:tailEnd type="none" w="med" len="med"/>
+                    </a:lnL>
+                    <a:lnR w="9525" cap="flat" cmpd="sng" algn="ctr">
+                      <a:solidFill>
+                        <a:srgbClr val="C9D3DC"/>
+                      </a:solidFill>
+                      <a:prstDash val="solid"/>
+                      <a:round/>
+                      <a:headEnd type="none" w="med" len="med"/>
+                      <a:tailEnd type="none" w="med" len="med"/>
+                    </a:lnR>
+                    <a:lnT w="9525" cap="flat" cmpd="sng" algn="ctr">
+                      <a:solidFill>
+                        <a:srgbClr val="C9D3DC"/>
+                      </a:solidFill>
+                      <a:prstDash val="solid"/>
+                      <a:round/>
+                      <a:headEnd type="none" w="med" len="med"/>
+                      <a:tailEnd type="none" w="med" len="med"/>
+                    </a:lnT>
+                    <a:lnB w="9525" cap="flat" cmpd="sng" algn="ctr">
+                      <a:solidFill>
+                        <a:srgbClr val="C9D3DC"/>
+                      </a:solidFill>
+                      <a:prstDash val="solid"/>
+                      <a:round/>
+                      <a:headEnd type="none" w="med" len="med"/>
+                      <a:tailEnd type="none" w="med" len="med"/>
+                    </a:lnB>
+                  </a:tcPr>
+                </a:tc>
+              </a:tr>
+              <a:tr h="512064">
+                <a:tc>
+                  <a:txBody>
+                    <a:bodyPr/>
+                    <a:lstStyle/>
+                    <a:p>
+                      <a:pPr algn="l" indent="0" marL="0">
+                        <a:buNone/>
+                      </a:pPr>
+                      <a:r>
+                        <a:rPr lang="en-US" sz="1600" b="1" dirty="0">
+                          <a:solidFill>
+                            <a:srgbClr val="004387"/>
+                          </a:solidFill>
+                          <a:latin typeface="Arial" pitchFamily="34" charset="0"/>
+                          <a:ea typeface="Arial" pitchFamily="34" charset="-122"/>
+                          <a:cs typeface="Arial" pitchFamily="34" charset="-120"/>
+                        </a:rPr>
+                        <a:t>Tests</a:t>
+                      </a:r>
+                      <a:endParaRPr lang="en-US" sz="1600" dirty="0">
+                        <a:latin typeface="Arial" charset="0"/>
+                        <a:ea typeface="Arial" charset="0"/>
+                        <a:cs typeface="Arial" charset="0"/>
+                      </a:endParaRPr>
+                    </a:p>
+                  </a:txBody>
+                  <a:tcPr marL="91440" marR="91440" marT="36576" marB="36576" anchor="ctr">
+                    <a:lnL w="9525" cap="flat" cmpd="sng" algn="ctr">
+                      <a:solidFill>
+                        <a:srgbClr val="C9D3DC"/>
+                      </a:solidFill>
+                      <a:prstDash val="solid"/>
+                      <a:round/>
+                      <a:headEnd type="none" w="med" len="med"/>
+                      <a:tailEnd type="none" w="med" len="med"/>
+                    </a:lnL>
+                    <a:lnR w="9525" cap="flat" cmpd="sng" algn="ctr">
+                      <a:solidFill>
+                        <a:srgbClr val="C9D3DC"/>
+                      </a:solidFill>
+                      <a:prstDash val="solid"/>
+                      <a:round/>
+                      <a:headEnd type="none" w="med" len="med"/>
+                      <a:tailEnd type="none" w="med" len="med"/>
+                    </a:lnR>
+                    <a:lnT w="9525" cap="flat" cmpd="sng" algn="ctr">
+                      <a:solidFill>
+                        <a:srgbClr val="C9D3DC"/>
+                      </a:solidFill>
+                      <a:prstDash val="solid"/>
+                      <a:round/>
+                      <a:headEnd type="none" w="med" len="med"/>
+                      <a:tailEnd type="none" w="med" len="med"/>
+                    </a:lnT>
+                    <a:lnB w="9525" cap="flat" cmpd="sng" algn="ctr">
+                      <a:solidFill>
+                        <a:srgbClr val="C9D3DC"/>
+                      </a:solidFill>
+                      <a:prstDash val="solid"/>
+                      <a:round/>
+                      <a:headEnd type="none" w="med" len="med"/>
+                      <a:tailEnd type="none" w="med" len="med"/>
+                    </a:lnB>
+                  </a:tcPr>
+                </a:tc>
+                <a:tc>
+                  <a:txBody>
+                    <a:bodyPr/>
+                    <a:lstStyle/>
+                    <a:p>
+                      <a:pPr algn="l" indent="0" marL="0">
+                        <a:buNone/>
+                      </a:pPr>
+                      <a:r>
+                        <a:rPr lang="en-US" sz="1600" dirty="0">
+                          <a:solidFill>
+                            <a:srgbClr val="1F2937"/>
+                          </a:solidFill>
+                          <a:latin typeface="Arial" pitchFamily="34" charset="0"/>
+                          <a:ea typeface="Arial" pitchFamily="34" charset="-122"/>
+                          <a:cs typeface="Arial" pitchFamily="34" charset="-120"/>
+                        </a:rPr>
+                        <a:t>AC-4 to AC-8</a:t>
+                      </a:r>
+                      <a:endParaRPr lang="en-US" sz="1600" dirty="0">
+                        <a:latin typeface="Arial" charset="0"/>
+                        <a:ea typeface="Arial" charset="0"/>
+                        <a:cs typeface="Arial" charset="0"/>
+                      </a:endParaRPr>
+                    </a:p>
+                  </a:txBody>
+                  <a:tcPr marL="91440" marR="91440" marT="36576" marB="36576" anchor="ctr">
+                    <a:lnL w="9525" cap="flat" cmpd="sng" algn="ctr">
+                      <a:solidFill>
+                        <a:srgbClr val="C9D3DC"/>
+                      </a:solidFill>
+                      <a:prstDash val="solid"/>
+                      <a:round/>
+                      <a:headEnd type="none" w="med" len="med"/>
+                      <a:tailEnd type="none" w="med" len="med"/>
+                    </a:lnL>
+                    <a:lnR w="9525" cap="flat" cmpd="sng" algn="ctr">
+                      <a:solidFill>
+                        <a:srgbClr val="C9D3DC"/>
+                      </a:solidFill>
+                      <a:prstDash val="solid"/>
+                      <a:round/>
+                      <a:headEnd type="none" w="med" len="med"/>
+                      <a:tailEnd type="none" w="med" len="med"/>
+                    </a:lnR>
+                    <a:lnT w="9525" cap="flat" cmpd="sng" algn="ctr">
+                      <a:solidFill>
+                        <a:srgbClr val="C9D3DC"/>
+                      </a:solidFill>
+                      <a:prstDash val="solid"/>
+                      <a:round/>
+                      <a:headEnd type="none" w="med" len="med"/>
+                      <a:tailEnd type="none" w="med" len="med"/>
+                    </a:lnT>
+                    <a:lnB w="9525" cap="flat" cmpd="sng" algn="ctr">
+                      <a:solidFill>
+                        <a:srgbClr val="C9D3DC"/>
+                      </a:solidFill>
+                      <a:prstDash val="solid"/>
+                      <a:round/>
+                      <a:headEnd type="none" w="med" len="med"/>
+                      <a:tailEnd type="none" w="med" len="med"/>
+                    </a:lnB>
+                  </a:tcPr>
+                </a:tc>
+                <a:tc>
+                  <a:txBody>
+                    <a:bodyPr/>
+                    <a:lstStyle/>
+                    <a:p>
+                      <a:pPr algn="l" indent="0" marL="0">
+                        <a:buNone/>
+                      </a:pPr>
+                      <a:r>
+                        <a:rPr lang="en-US" sz="1600" dirty="0">
+                          <a:solidFill>
+                            <a:srgbClr val="1F2937"/>
+                          </a:solidFill>
+                          <a:latin typeface="Arial" pitchFamily="34" charset="0"/>
+                          <a:ea typeface="Arial" pitchFamily="34" charset="-122"/>
+                          <a:cs typeface="Arial" pitchFamily="34" charset="-120"/>
+                        </a:rPr>
+                        <a:t>90 passed, 0 failed</a:t>
+                      </a:r>
+                      <a:endParaRPr lang="en-US" sz="1600" dirty="0">
+                        <a:latin typeface="Arial" charset="0"/>
+                        <a:ea typeface="Arial" charset="0"/>
+                        <a:cs typeface="Arial" charset="0"/>
+                      </a:endParaRPr>
+                    </a:p>
+                  </a:txBody>
+                  <a:tcPr marL="91440" marR="91440" marT="36576" marB="36576" anchor="ctr">
+                    <a:lnL w="9525" cap="flat" cmpd="sng" algn="ctr">
+                      <a:solidFill>
+                        <a:srgbClr val="C9D3DC"/>
+                      </a:solidFill>
+                      <a:prstDash val="solid"/>
+                      <a:round/>
+                      <a:headEnd type="none" w="med" len="med"/>
+                      <a:tailEnd type="none" w="med" len="med"/>
+                    </a:lnL>
+                    <a:lnR w="9525" cap="flat" cmpd="sng" algn="ctr">
+                      <a:solidFill>
+                        <a:srgbClr val="C9D3DC"/>
+                      </a:solidFill>
+                      <a:prstDash val="solid"/>
+                      <a:round/>
+                      <a:headEnd type="none" w="med" len="med"/>
+                      <a:tailEnd type="none" w="med" len="med"/>
+                    </a:lnR>
+                    <a:lnT w="9525" cap="flat" cmpd="sng" algn="ctr">
+                      <a:solidFill>
+                        <a:srgbClr val="C9D3DC"/>
+                      </a:solidFill>
+                      <a:prstDash val="solid"/>
+                      <a:round/>
+                      <a:headEnd type="none" w="med" len="med"/>
+                      <a:tailEnd type="none" w="med" len="med"/>
+                    </a:lnT>
+                    <a:lnB w="9525" cap="flat" cmpd="sng" algn="ctr">
+                      <a:solidFill>
+                        <a:srgbClr val="C9D3DC"/>
+                      </a:solidFill>
+                      <a:prstDash val="solid"/>
+                      <a:round/>
+                      <a:headEnd type="none" w="med" len="med"/>
+                      <a:tailEnd type="none" w="med" len="med"/>
+                    </a:lnB>
+                  </a:tcPr>
+                </a:tc>
+              </a:tr>
+              <a:tr h="512064">
+                <a:tc>
+                  <a:txBody>
+                    <a:bodyPr/>
+                    <a:lstStyle/>
+                    <a:p>
+                      <a:pPr algn="l" indent="0" marL="0">
+                        <a:buNone/>
+                      </a:pPr>
+                      <a:r>
+                        <a:rPr lang="en-US" sz="1600" b="1" dirty="0">
+                          <a:solidFill>
+                            <a:srgbClr val="004387"/>
+                          </a:solidFill>
+                          <a:latin typeface="Arial" pitchFamily="34" charset="0"/>
+                          <a:ea typeface="Arial" pitchFamily="34" charset="-122"/>
+                          <a:cs typeface="Arial" pitchFamily="34" charset="-120"/>
+                        </a:rPr>
+                        <a:t>Clean machine</a:t>
+                      </a:r>
+                      <a:endParaRPr lang="en-US" sz="1600" dirty="0">
+                        <a:latin typeface="Arial" charset="0"/>
+                        <a:ea typeface="Arial" charset="0"/>
+                        <a:cs typeface="Arial" charset="0"/>
+                      </a:endParaRPr>
+                    </a:p>
+                  </a:txBody>
+                  <a:tcPr marL="91440" marR="91440" marT="36576" marB="36576" anchor="ctr">
+                    <a:lnL w="9525" cap="flat" cmpd="sng" algn="ctr">
+                      <a:solidFill>
+                        <a:srgbClr val="C9D3DC"/>
+                      </a:solidFill>
+                      <a:prstDash val="solid"/>
+                      <a:round/>
+                      <a:headEnd type="none" w="med" len="med"/>
+                      <a:tailEnd type="none" w="med" len="med"/>
+                    </a:lnL>
+                    <a:lnR w="9525" cap="flat" cmpd="sng" algn="ctr">
+                      <a:solidFill>
+                        <a:srgbClr val="C9D3DC"/>
+                      </a:solidFill>
+                      <a:prstDash val="solid"/>
+                      <a:round/>
+                      <a:headEnd type="none" w="med" len="med"/>
+                      <a:tailEnd type="none" w="med" len="med"/>
+                    </a:lnR>
+                    <a:lnT w="9525" cap="flat" cmpd="sng" algn="ctr">
+                      <a:solidFill>
+                        <a:srgbClr val="C9D3DC"/>
+                      </a:solidFill>
+                      <a:prstDash val="solid"/>
+                      <a:round/>
+                      <a:headEnd type="none" w="med" len="med"/>
+                      <a:tailEnd type="none" w="med" len="med"/>
+                    </a:lnT>
+                    <a:lnB w="9525" cap="flat" cmpd="sng" algn="ctr">
+                      <a:solidFill>
+                        <a:srgbClr val="C9D3DC"/>
+                      </a:solidFill>
+                      <a:prstDash val="solid"/>
+                      <a:round/>
+                      <a:headEnd type="none" w="med" len="med"/>
+                      <a:tailEnd type="none" w="med" len="med"/>
+                    </a:lnB>
+                  </a:tcPr>
+                </a:tc>
+                <a:tc>
+                  <a:txBody>
+                    <a:bodyPr/>
+                    <a:lstStyle/>
+                    <a:p>
+                      <a:pPr algn="l" indent="0" marL="0">
+                        <a:buNone/>
+                      </a:pPr>
+                      <a:r>
+                        <a:rPr lang="en-US" sz="1600" dirty="0">
+                          <a:solidFill>
+                            <a:srgbClr val="1F2937"/>
+                          </a:solidFill>
+                          <a:latin typeface="Arial" pitchFamily="34" charset="0"/>
+                          <a:ea typeface="Arial" pitchFamily="34" charset="-122"/>
+                          <a:cs typeface="Arial" pitchFamily="34" charset="-120"/>
+                        </a:rPr>
+                        <a:t>Passes</a:t>
+                      </a:r>
+                      <a:endParaRPr lang="en-US" sz="1600" dirty="0">
+                        <a:latin typeface="Arial" charset="0"/>
+                        <a:ea typeface="Arial" charset="0"/>
+                        <a:cs typeface="Arial" charset="0"/>
+                      </a:endParaRPr>
+                    </a:p>
+                  </a:txBody>
+                  <a:tcPr marL="91440" marR="91440" marT="36576" marB="36576" anchor="ctr">
+                    <a:lnL w="9525" cap="flat" cmpd="sng" algn="ctr">
+                      <a:solidFill>
+                        <a:srgbClr val="C9D3DC"/>
+                      </a:solidFill>
+                      <a:prstDash val="solid"/>
+                      <a:round/>
+                      <a:headEnd type="none" w="med" len="med"/>
+                      <a:tailEnd type="none" w="med" len="med"/>
+                    </a:lnL>
+                    <a:lnR w="9525" cap="flat" cmpd="sng" algn="ctr">
+                      <a:solidFill>
+                        <a:srgbClr val="C9D3DC"/>
+                      </a:solidFill>
+                      <a:prstDash val="solid"/>
+                      <a:round/>
+                      <a:headEnd type="none" w="med" len="med"/>
+                      <a:tailEnd type="none" w="med" len="med"/>
+                    </a:lnR>
+                    <a:lnT w="9525" cap="flat" cmpd="sng" algn="ctr">
+                      <a:solidFill>
+                        <a:srgbClr val="C9D3DC"/>
+                      </a:solidFill>
+                      <a:prstDash val="solid"/>
+                      <a:round/>
+                      <a:headEnd type="none" w="med" len="med"/>
+                      <a:tailEnd type="none" w="med" len="med"/>
+                    </a:lnT>
+                    <a:lnB w="9525" cap="flat" cmpd="sng" algn="ctr">
+                      <a:solidFill>
+                        <a:srgbClr val="C9D3DC"/>
+                      </a:solidFill>
+                      <a:prstDash val="solid"/>
+                      <a:round/>
+                      <a:headEnd type="none" w="med" len="med"/>
+                      <a:tailEnd type="none" w="med" len="med"/>
+                    </a:lnB>
+                  </a:tcPr>
+                </a:tc>
+                <a:tc>
+                  <a:txBody>
+                    <a:bodyPr/>
+                    <a:lstStyle/>
+                    <a:p>
+                      <a:pPr algn="l" indent="0" marL="0">
+                        <a:buNone/>
+                      </a:pPr>
+                      <a:r>
+                        <a:rPr lang="en-US" sz="1600" dirty="0">
+                          <a:solidFill>
+                            <a:srgbClr val="1F2937"/>
+                          </a:solidFill>
+                          <a:latin typeface="Arial" pitchFamily="34" charset="0"/>
+                          <a:ea typeface="Arial" pitchFamily="34" charset="-122"/>
+                          <a:cs typeface="Arial" pitchFamily="34" charset="-120"/>
+                        </a:rPr>
+                        <a:t>Docker passes; laptop by 25/10</a:t>
+                      </a:r>
+                      <a:endParaRPr lang="en-US" sz="1600" dirty="0">
+                        <a:latin typeface="Arial" charset="0"/>
+                        <a:ea typeface="Arial" charset="0"/>
+                        <a:cs typeface="Arial" charset="0"/>
+                      </a:endParaRPr>
+                    </a:p>
+                  </a:txBody>
+                  <a:tcPr marL="91440" marR="91440" marT="36576" marB="36576" anchor="ctr">
+                    <a:lnL w="9525" cap="flat" cmpd="sng" algn="ctr">
+                      <a:solidFill>
+                        <a:srgbClr val="C9D3DC"/>
+                      </a:solidFill>
+                      <a:prstDash val="solid"/>
+                      <a:round/>
+                      <a:headEnd type="none" w="med" len="med"/>
+                      <a:tailEnd type="none" w="med" len="med"/>
+                    </a:lnL>
+                    <a:lnR w="9525" cap="flat" cmpd="sng" algn="ctr">
+                      <a:solidFill>
+                        <a:srgbClr val="C9D3DC"/>
+                      </a:solidFill>
+                      <a:prstDash val="solid"/>
+                      <a:round/>
+                      <a:headEnd type="none" w="med" len="med"/>
+                      <a:tailEnd type="none" w="med" len="med"/>
+                    </a:lnR>
+                    <a:lnT w="9525" cap="flat" cmpd="sng" algn="ctr">
+                      <a:solidFill>
+                        <a:srgbClr val="C9D3DC"/>
+                      </a:solidFill>
+                      <a:prstDash val="solid"/>
+                      <a:round/>
+                      <a:headEnd type="none" w="med" len="med"/>
+                      <a:tailEnd type="none" w="med" len="med"/>
+                    </a:lnT>
+                    <a:lnB w="9525" cap="flat" cmpd="sng" algn="ctr">
+                      <a:solidFill>
+                        <a:srgbClr val="C9D3DC"/>
+                      </a:solidFill>
+                      <a:prstDash val="solid"/>
+                      <a:round/>
+                      <a:headEnd type="none" w="med" len="med"/>
+                      <a:tailEnd type="none" w="med" len="med"/>
+                    </a:lnB>
+                  </a:tcPr>
+                </a:tc>
+              </a:tr>
+              <a:tr h="512064">
+                <a:tc>
+                  <a:txBody>
+                    <a:bodyPr/>
+                    <a:lstStyle/>
+                    <a:p>
+                      <a:pPr algn="l" indent="0" marL="0">
+                        <a:buNone/>
+                      </a:pPr>
+                      <a:r>
+                        <a:rPr lang="en-US" sz="1600" b="1" dirty="0">
+                          <a:solidFill>
+                            <a:srgbClr val="004387"/>
+                          </a:solidFill>
+                          <a:latin typeface="Arial" pitchFamily="34" charset="0"/>
+                          <a:ea typeface="Arial" pitchFamily="34" charset="-122"/>
+                          <a:cs typeface="Arial" pitchFamily="34" charset="-120"/>
+                        </a:rPr>
+                        <a:t>Code review</a:t>
+                      </a:r>
+                      <a:endParaRPr lang="en-US" sz="1600" dirty="0">
+                        <a:latin typeface="Arial" charset="0"/>
+                        <a:ea typeface="Arial" charset="0"/>
+                        <a:cs typeface="Arial" charset="0"/>
+                      </a:endParaRPr>
+                    </a:p>
+                  </a:txBody>
+                  <a:tcPr marL="91440" marR="91440" marT="36576" marB="36576" anchor="ctr">
+                    <a:lnL w="9525" cap="flat" cmpd="sng" algn="ctr">
+                      <a:solidFill>
+                        <a:srgbClr val="C9D3DC"/>
+                      </a:solidFill>
+                      <a:prstDash val="solid"/>
+                      <a:round/>
+                      <a:headEnd type="none" w="med" len="med"/>
+                      <a:tailEnd type="none" w="med" len="med"/>
+                    </a:lnL>
+                    <a:lnR w="9525" cap="flat" cmpd="sng" algn="ctr">
+                      <a:solidFill>
+                        <a:srgbClr val="C9D3DC"/>
+                      </a:solidFill>
+                      <a:prstDash val="solid"/>
+                      <a:round/>
+                      <a:headEnd type="none" w="med" len="med"/>
+                      <a:tailEnd type="none" w="med" len="med"/>
+                    </a:lnR>
+                    <a:lnT w="9525" cap="flat" cmpd="sng" algn="ctr">
+                      <a:solidFill>
+                        <a:srgbClr val="C9D3DC"/>
+                      </a:solidFill>
+                      <a:prstDash val="solid"/>
+                      <a:round/>
+                      <a:headEnd type="none" w="med" len="med"/>
+                      <a:tailEnd type="none" w="med" len="med"/>
+                    </a:lnT>
+                    <a:lnB w="9525" cap="flat" cmpd="sng" algn="ctr">
+                      <a:solidFill>
+                        <a:srgbClr val="C9D3DC"/>
+                      </a:solidFill>
+                      <a:prstDash val="solid"/>
+                      <a:round/>
+                      <a:headEnd type="none" w="med" len="med"/>
+                      <a:tailEnd type="none" w="med" len="med"/>
+                    </a:lnB>
+                  </a:tcPr>
+                </a:tc>
+                <a:tc>
+                  <a:txBody>
+                    <a:bodyPr/>
+                    <a:lstStyle/>
+                    <a:p>
+                      <a:pPr algn="l" indent="0" marL="0">
+                        <a:buNone/>
+                      </a:pPr>
+                      <a:r>
+                        <a:rPr lang="en-US" sz="1600" dirty="0">
+                          <a:solidFill>
+                            <a:srgbClr val="1F2937"/>
+                          </a:solidFill>
+                          <a:latin typeface="Arial" pitchFamily="34" charset="0"/>
+                          <a:ea typeface="Arial" pitchFamily="34" charset="-122"/>
+                          <a:cs typeface="Arial" pitchFamily="34" charset="-120"/>
+                        </a:rPr>
+                        <a:t>On D6</a:t>
+                      </a:r>
+                      <a:endParaRPr lang="en-US" sz="1600" dirty="0">
+                        <a:latin typeface="Arial" charset="0"/>
+                        <a:ea typeface="Arial" charset="0"/>
+                        <a:cs typeface="Arial" charset="0"/>
+                      </a:endParaRPr>
+                    </a:p>
+                  </a:txBody>
+                  <a:tcPr marL="91440" marR="91440" marT="36576" marB="36576" anchor="ctr">
+                    <a:lnL w="9525" cap="flat" cmpd="sng" algn="ctr">
+                      <a:solidFill>
+                        <a:srgbClr val="C9D3DC"/>
+                      </a:solidFill>
+                      <a:prstDash val="solid"/>
+                      <a:round/>
+                      <a:headEnd type="none" w="med" len="med"/>
+                      <a:tailEnd type="none" w="med" len="med"/>
+                    </a:lnL>
+                    <a:lnR w="9525" cap="flat" cmpd="sng" algn="ctr">
+                      <a:solidFill>
+                        <a:srgbClr val="C9D3DC"/>
+                      </a:solidFill>
+                      <a:prstDash val="solid"/>
+                      <a:round/>
+                      <a:headEnd type="none" w="med" len="med"/>
+                      <a:tailEnd type="none" w="med" len="med"/>
+                    </a:lnR>
+                    <a:lnT w="9525" cap="flat" cmpd="sng" algn="ctr">
+                      <a:solidFill>
+                        <a:srgbClr val="C9D3DC"/>
+                      </a:solidFill>
+                      <a:prstDash val="solid"/>
+                      <a:round/>
+                      <a:headEnd type="none" w="med" len="med"/>
+                      <a:tailEnd type="none" w="med" len="med"/>
+                    </a:lnT>
+                    <a:lnB w="9525" cap="flat" cmpd="sng" algn="ctr">
+                      <a:solidFill>
+                        <a:srgbClr val="C9D3DC"/>
+                      </a:solidFill>
+                      <a:prstDash val="solid"/>
+                      <a:round/>
+                      <a:headEnd type="none" w="med" len="med"/>
+                      <a:tailEnd type="none" w="med" len="med"/>
+                    </a:lnB>
+                  </a:tcPr>
+                </a:tc>
+                <a:tc>
+                  <a:txBody>
+                    <a:bodyPr/>
+                    <a:lstStyle/>
+                    <a:p>
+                      <a:pPr algn="l" indent="0" marL="0">
+                        <a:buNone/>
+                      </a:pPr>
+                      <a:r>
+                        <a:rPr lang="en-US" sz="1600" dirty="0">
+                          <a:solidFill>
+                            <a:srgbClr val="1F2937"/>
+                          </a:solidFill>
+                          <a:latin typeface="Arial" pitchFamily="34" charset="0"/>
+                          <a:ea typeface="Arial" pitchFamily="34" charset="-122"/>
+                          <a:cs typeface="Arial" pitchFamily="34" charset="-120"/>
+                        </a:rPr>
+                        <a:t>20/10: 2 defects found, both fixed</a:t>
                       </a:r>
                       <a:endParaRPr lang="en-US" sz="1600" dirty="0">
                         <a:latin typeface="Arial" charset="0"/>
@@ -9725,7 +9993,7 @@
                           <a:ea typeface="Arial" pitchFamily="34" charset="-122"/>
                           <a:cs typeface="Arial" pitchFamily="34" charset="-120"/>
                         </a:rPr>
-                        <a:t>⟦ACTUAL s13_hours: hours⟧</a:t>
+                        <a:t>Not logged per day</a:t>
                       </a:r>
                       <a:endParaRPr lang="en-US" sz="1600" dirty="0">
                         <a:latin typeface="Arial" charset="0"/>
@@ -9771,603 +10039,6 @@
                       <a:headEnd type="none" w="med" len="med"/>
                       <a:tailEnd type="none" w="med" len="med"/>
                     </a:lnB>
-                    <a:solidFill>
-                      <a:srgbClr val="FFF3C4"/>
-                    </a:solidFill>
-                  </a:tcPr>
-                </a:tc>
-              </a:tr>
-              <a:tr h="512064">
-                <a:tc>
-                  <a:txBody>
-                    <a:bodyPr/>
-                    <a:lstStyle/>
-                    <a:p>
-                      <a:pPr algn="l" indent="0" marL="0">
-                        <a:buNone/>
-                      </a:pPr>
-                      <a:r>
-                        <a:rPr lang="en-US" sz="1600" b="1" dirty="0">
-                          <a:solidFill>
-                            <a:srgbClr val="004387"/>
-                          </a:solidFill>
-                          <a:latin typeface="Arial" pitchFamily="34" charset="0"/>
-                          <a:ea typeface="Arial" pitchFamily="34" charset="-122"/>
-                          <a:cs typeface="Arial" pitchFamily="34" charset="-120"/>
-                        </a:rPr>
-                        <a:t>Criteria met</a:t>
-                      </a:r>
-                      <a:endParaRPr lang="en-US" sz="1600" dirty="0">
-                        <a:latin typeface="Arial" charset="0"/>
-                        <a:ea typeface="Arial" charset="0"/>
-                        <a:cs typeface="Arial" charset="0"/>
-                      </a:endParaRPr>
-                    </a:p>
-                  </a:txBody>
-                  <a:tcPr marL="91440" marR="91440" marT="36576" marB="36576" anchor="ctr">
-                    <a:lnL w="9525" cap="flat" cmpd="sng" algn="ctr">
-                      <a:solidFill>
-                        <a:srgbClr val="C9D3DC"/>
-                      </a:solidFill>
-                      <a:prstDash val="solid"/>
-                      <a:round/>
-                      <a:headEnd type="none" w="med" len="med"/>
-                      <a:tailEnd type="none" w="med" len="med"/>
-                    </a:lnL>
-                    <a:lnR w="9525" cap="flat" cmpd="sng" algn="ctr">
-                      <a:solidFill>
-                        <a:srgbClr val="C9D3DC"/>
-                      </a:solidFill>
-                      <a:prstDash val="solid"/>
-                      <a:round/>
-                      <a:headEnd type="none" w="med" len="med"/>
-                      <a:tailEnd type="none" w="med" len="med"/>
-                    </a:lnR>
-                    <a:lnT w="9525" cap="flat" cmpd="sng" algn="ctr">
-                      <a:solidFill>
-                        <a:srgbClr val="C9D3DC"/>
-                      </a:solidFill>
-                      <a:prstDash val="solid"/>
-                      <a:round/>
-                      <a:headEnd type="none" w="med" len="med"/>
-                      <a:tailEnd type="none" w="med" len="med"/>
-                    </a:lnT>
-                    <a:lnB w="9525" cap="flat" cmpd="sng" algn="ctr">
-                      <a:solidFill>
-                        <a:srgbClr val="C9D3DC"/>
-                      </a:solidFill>
-                      <a:prstDash val="solid"/>
-                      <a:round/>
-                      <a:headEnd type="none" w="med" len="med"/>
-                      <a:tailEnd type="none" w="med" len="med"/>
-                    </a:lnB>
-                  </a:tcPr>
-                </a:tc>
-                <a:tc>
-                  <a:txBody>
-                    <a:bodyPr/>
-                    <a:lstStyle/>
-                    <a:p>
-                      <a:pPr algn="l" indent="0" marL="0">
-                        <a:buNone/>
-                      </a:pPr>
-                      <a:r>
-                        <a:rPr lang="en-US" sz="1600" dirty="0">
-                          <a:solidFill>
-                            <a:srgbClr val="1F2937"/>
-                          </a:solidFill>
-                          <a:latin typeface="Arial" pitchFamily="34" charset="0"/>
-                          <a:ea typeface="Arial" pitchFamily="34" charset="-122"/>
-                          <a:cs typeface="Arial" pitchFamily="34" charset="-120"/>
-                        </a:rPr>
-                        <a:t>9 of 9</a:t>
-                      </a:r>
-                      <a:endParaRPr lang="en-US" sz="1600" dirty="0">
-                        <a:latin typeface="Arial" charset="0"/>
-                        <a:ea typeface="Arial" charset="0"/>
-                        <a:cs typeface="Arial" charset="0"/>
-                      </a:endParaRPr>
-                    </a:p>
-                  </a:txBody>
-                  <a:tcPr marL="91440" marR="91440" marT="36576" marB="36576" anchor="ctr">
-                    <a:lnL w="9525" cap="flat" cmpd="sng" algn="ctr">
-                      <a:solidFill>
-                        <a:srgbClr val="C9D3DC"/>
-                      </a:solidFill>
-                      <a:prstDash val="solid"/>
-                      <a:round/>
-                      <a:headEnd type="none" w="med" len="med"/>
-                      <a:tailEnd type="none" w="med" len="med"/>
-                    </a:lnL>
-                    <a:lnR w="9525" cap="flat" cmpd="sng" algn="ctr">
-                      <a:solidFill>
-                        <a:srgbClr val="C9D3DC"/>
-                      </a:solidFill>
-                      <a:prstDash val="solid"/>
-                      <a:round/>
-                      <a:headEnd type="none" w="med" len="med"/>
-                      <a:tailEnd type="none" w="med" len="med"/>
-                    </a:lnR>
-                    <a:lnT w="9525" cap="flat" cmpd="sng" algn="ctr">
-                      <a:solidFill>
-                        <a:srgbClr val="C9D3DC"/>
-                      </a:solidFill>
-                      <a:prstDash val="solid"/>
-                      <a:round/>
-                      <a:headEnd type="none" w="med" len="med"/>
-                      <a:tailEnd type="none" w="med" len="med"/>
-                    </a:lnT>
-                    <a:lnB w="9525" cap="flat" cmpd="sng" algn="ctr">
-                      <a:solidFill>
-                        <a:srgbClr val="C9D3DC"/>
-                      </a:solidFill>
-                      <a:prstDash val="solid"/>
-                      <a:round/>
-                      <a:headEnd type="none" w="med" len="med"/>
-                      <a:tailEnd type="none" w="med" len="med"/>
-                    </a:lnB>
-                  </a:tcPr>
-                </a:tc>
-                <a:tc>
-                  <a:txBody>
-                    <a:bodyPr/>
-                    <a:lstStyle/>
-                    <a:p>
-                      <a:pPr algn="l" indent="0" marL="0">
-                        <a:buNone/>
-                      </a:pPr>
-                      <a:r>
-                        <a:rPr lang="en-US" sz="1600" dirty="0">
-                          <a:solidFill>
-                            <a:srgbClr val="1F2937"/>
-                          </a:solidFill>
-                          <a:latin typeface="Arial" pitchFamily="34" charset="0"/>
-                          <a:ea typeface="Arial" pitchFamily="34" charset="-122"/>
-                          <a:cs typeface="Arial" pitchFamily="34" charset="-120"/>
-                        </a:rPr>
-                        <a:t>7 of 9 (AC-1, AC-9 partial)</a:t>
-                      </a:r>
-                      <a:endParaRPr lang="en-US" sz="1600" dirty="0">
-                        <a:latin typeface="Arial" charset="0"/>
-                        <a:ea typeface="Arial" charset="0"/>
-                        <a:cs typeface="Arial" charset="0"/>
-                      </a:endParaRPr>
-                    </a:p>
-                  </a:txBody>
-                  <a:tcPr marL="91440" marR="91440" marT="36576" marB="36576" anchor="ctr">
-                    <a:lnL w="9525" cap="flat" cmpd="sng" algn="ctr">
-                      <a:solidFill>
-                        <a:srgbClr val="C9D3DC"/>
-                      </a:solidFill>
-                      <a:prstDash val="solid"/>
-                      <a:round/>
-                      <a:headEnd type="none" w="med" len="med"/>
-                      <a:tailEnd type="none" w="med" len="med"/>
-                    </a:lnL>
-                    <a:lnR w="9525" cap="flat" cmpd="sng" algn="ctr">
-                      <a:solidFill>
-                        <a:srgbClr val="C9D3DC"/>
-                      </a:solidFill>
-                      <a:prstDash val="solid"/>
-                      <a:round/>
-                      <a:headEnd type="none" w="med" len="med"/>
-                      <a:tailEnd type="none" w="med" len="med"/>
-                    </a:lnR>
-                    <a:lnT w="9525" cap="flat" cmpd="sng" algn="ctr">
-                      <a:solidFill>
-                        <a:srgbClr val="C9D3DC"/>
-                      </a:solidFill>
-                      <a:prstDash val="solid"/>
-                      <a:round/>
-                      <a:headEnd type="none" w="med" len="med"/>
-                      <a:tailEnd type="none" w="med" len="med"/>
-                    </a:lnT>
-                    <a:lnB w="9525" cap="flat" cmpd="sng" algn="ctr">
-                      <a:solidFill>
-                        <a:srgbClr val="C9D3DC"/>
-                      </a:solidFill>
-                      <a:prstDash val="solid"/>
-                      <a:round/>
-                      <a:headEnd type="none" w="med" len="med"/>
-                      <a:tailEnd type="none" w="med" len="med"/>
-                    </a:lnB>
-                  </a:tcPr>
-                </a:tc>
-              </a:tr>
-              <a:tr h="512064">
-                <a:tc>
-                  <a:txBody>
-                    <a:bodyPr/>
-                    <a:lstStyle/>
-                    <a:p>
-                      <a:pPr algn="l" indent="0" marL="0">
-                        <a:buNone/>
-                      </a:pPr>
-                      <a:r>
-                        <a:rPr lang="en-US" sz="1600" b="1" dirty="0">
-                          <a:solidFill>
-                            <a:srgbClr val="004387"/>
-                          </a:solidFill>
-                          <a:latin typeface="Arial" pitchFamily="34" charset="0"/>
-                          <a:ea typeface="Arial" pitchFamily="34" charset="-122"/>
-                          <a:cs typeface="Arial" pitchFamily="34" charset="-120"/>
-                        </a:rPr>
-                        <a:t>pytest</a:t>
-                      </a:r>
-                      <a:endParaRPr lang="en-US" sz="1600" dirty="0">
-                        <a:latin typeface="Arial" charset="0"/>
-                        <a:ea typeface="Arial" charset="0"/>
-                        <a:cs typeface="Arial" charset="0"/>
-                      </a:endParaRPr>
-                    </a:p>
-                  </a:txBody>
-                  <a:tcPr marL="91440" marR="91440" marT="36576" marB="36576" anchor="ctr">
-                    <a:lnL w="9525" cap="flat" cmpd="sng" algn="ctr">
-                      <a:solidFill>
-                        <a:srgbClr val="C9D3DC"/>
-                      </a:solidFill>
-                      <a:prstDash val="solid"/>
-                      <a:round/>
-                      <a:headEnd type="none" w="med" len="med"/>
-                      <a:tailEnd type="none" w="med" len="med"/>
-                    </a:lnL>
-                    <a:lnR w="9525" cap="flat" cmpd="sng" algn="ctr">
-                      <a:solidFill>
-                        <a:srgbClr val="C9D3DC"/>
-                      </a:solidFill>
-                      <a:prstDash val="solid"/>
-                      <a:round/>
-                      <a:headEnd type="none" w="med" len="med"/>
-                      <a:tailEnd type="none" w="med" len="med"/>
-                    </a:lnR>
-                    <a:lnT w="9525" cap="flat" cmpd="sng" algn="ctr">
-                      <a:solidFill>
-                        <a:srgbClr val="C9D3DC"/>
-                      </a:solidFill>
-                      <a:prstDash val="solid"/>
-                      <a:round/>
-                      <a:headEnd type="none" w="med" len="med"/>
-                      <a:tailEnd type="none" w="med" len="med"/>
-                    </a:lnT>
-                    <a:lnB w="9525" cap="flat" cmpd="sng" algn="ctr">
-                      <a:solidFill>
-                        <a:srgbClr val="C9D3DC"/>
-                      </a:solidFill>
-                      <a:prstDash val="solid"/>
-                      <a:round/>
-                      <a:headEnd type="none" w="med" len="med"/>
-                      <a:tailEnd type="none" w="med" len="med"/>
-                    </a:lnB>
-                  </a:tcPr>
-                </a:tc>
-                <a:tc>
-                  <a:txBody>
-                    <a:bodyPr/>
-                    <a:lstStyle/>
-                    <a:p>
-                      <a:pPr algn="l" indent="0" marL="0">
-                        <a:buNone/>
-                      </a:pPr>
-                      <a:r>
-                        <a:rPr lang="en-US" sz="1600" dirty="0">
-                          <a:solidFill>
-                            <a:srgbClr val="1F2937"/>
-                          </a:solidFill>
-                          <a:latin typeface="Arial" pitchFamily="34" charset="0"/>
-                          <a:ea typeface="Arial" pitchFamily="34" charset="-122"/>
-                          <a:cs typeface="Arial" pitchFamily="34" charset="-120"/>
-                        </a:rPr>
-                        <a:t>AC-4 to AC-8</a:t>
-                      </a:r>
-                      <a:endParaRPr lang="en-US" sz="1600" dirty="0">
-                        <a:latin typeface="Arial" charset="0"/>
-                        <a:ea typeface="Arial" charset="0"/>
-                        <a:cs typeface="Arial" charset="0"/>
-                      </a:endParaRPr>
-                    </a:p>
-                  </a:txBody>
-                  <a:tcPr marL="91440" marR="91440" marT="36576" marB="36576" anchor="ctr">
-                    <a:lnL w="9525" cap="flat" cmpd="sng" algn="ctr">
-                      <a:solidFill>
-                        <a:srgbClr val="C9D3DC"/>
-                      </a:solidFill>
-                      <a:prstDash val="solid"/>
-                      <a:round/>
-                      <a:headEnd type="none" w="med" len="med"/>
-                      <a:tailEnd type="none" w="med" len="med"/>
-                    </a:lnL>
-                    <a:lnR w="9525" cap="flat" cmpd="sng" algn="ctr">
-                      <a:solidFill>
-                        <a:srgbClr val="C9D3DC"/>
-                      </a:solidFill>
-                      <a:prstDash val="solid"/>
-                      <a:round/>
-                      <a:headEnd type="none" w="med" len="med"/>
-                      <a:tailEnd type="none" w="med" len="med"/>
-                    </a:lnR>
-                    <a:lnT w="9525" cap="flat" cmpd="sng" algn="ctr">
-                      <a:solidFill>
-                        <a:srgbClr val="C9D3DC"/>
-                      </a:solidFill>
-                      <a:prstDash val="solid"/>
-                      <a:round/>
-                      <a:headEnd type="none" w="med" len="med"/>
-                      <a:tailEnd type="none" w="med" len="med"/>
-                    </a:lnT>
-                    <a:lnB w="9525" cap="flat" cmpd="sng" algn="ctr">
-                      <a:solidFill>
-                        <a:srgbClr val="C9D3DC"/>
-                      </a:solidFill>
-                      <a:prstDash val="solid"/>
-                      <a:round/>
-                      <a:headEnd type="none" w="med" len="med"/>
-                      <a:tailEnd type="none" w="med" len="med"/>
-                    </a:lnB>
-                  </a:tcPr>
-                </a:tc>
-                <a:tc>
-                  <a:txBody>
-                    <a:bodyPr/>
-                    <a:lstStyle/>
-                    <a:p>
-                      <a:pPr algn="l" indent="0" marL="0">
-                        <a:buNone/>
-                      </a:pPr>
-                      <a:r>
-                        <a:rPr lang="en-US" sz="1600" dirty="0">
-                          <a:solidFill>
-                            <a:srgbClr val="1F2937"/>
-                          </a:solidFill>
-                          <a:latin typeface="Arial" pitchFamily="34" charset="0"/>
-                          <a:ea typeface="Arial" pitchFamily="34" charset="-122"/>
-                          <a:cs typeface="Arial" pitchFamily="34" charset="-120"/>
-                        </a:rPr>
-                        <a:t>81 passed, 0 failed (19/10)</a:t>
-                      </a:r>
-                      <a:endParaRPr lang="en-US" sz="1600" dirty="0">
-                        <a:latin typeface="Arial" charset="0"/>
-                        <a:ea typeface="Arial" charset="0"/>
-                        <a:cs typeface="Arial" charset="0"/>
-                      </a:endParaRPr>
-                    </a:p>
-                  </a:txBody>
-                  <a:tcPr marL="91440" marR="91440" marT="36576" marB="36576" anchor="ctr">
-                    <a:lnL w="9525" cap="flat" cmpd="sng" algn="ctr">
-                      <a:solidFill>
-                        <a:srgbClr val="C9D3DC"/>
-                      </a:solidFill>
-                      <a:prstDash val="solid"/>
-                      <a:round/>
-                      <a:headEnd type="none" w="med" len="med"/>
-                      <a:tailEnd type="none" w="med" len="med"/>
-                    </a:lnL>
-                    <a:lnR w="9525" cap="flat" cmpd="sng" algn="ctr">
-                      <a:solidFill>
-                        <a:srgbClr val="C9D3DC"/>
-                      </a:solidFill>
-                      <a:prstDash val="solid"/>
-                      <a:round/>
-                      <a:headEnd type="none" w="med" len="med"/>
-                      <a:tailEnd type="none" w="med" len="med"/>
-                    </a:lnR>
-                    <a:lnT w="9525" cap="flat" cmpd="sng" algn="ctr">
-                      <a:solidFill>
-                        <a:srgbClr val="C9D3DC"/>
-                      </a:solidFill>
-                      <a:prstDash val="solid"/>
-                      <a:round/>
-                      <a:headEnd type="none" w="med" len="med"/>
-                      <a:tailEnd type="none" w="med" len="med"/>
-                    </a:lnT>
-                    <a:lnB w="9525" cap="flat" cmpd="sng" algn="ctr">
-                      <a:solidFill>
-                        <a:srgbClr val="C9D3DC"/>
-                      </a:solidFill>
-                      <a:prstDash val="solid"/>
-                      <a:round/>
-                      <a:headEnd type="none" w="med" len="med"/>
-                      <a:tailEnd type="none" w="med" len="med"/>
-                    </a:lnB>
-                  </a:tcPr>
-                </a:tc>
-              </a:tr>
-              <a:tr h="512064">
-                <a:tc>
-                  <a:txBody>
-                    <a:bodyPr/>
-                    <a:lstStyle/>
-                    <a:p>
-                      <a:pPr algn="l" indent="0" marL="0">
-                        <a:buNone/>
-                      </a:pPr>
-                      <a:r>
-                        <a:rPr lang="en-US" sz="1600" b="1" dirty="0">
-                          <a:solidFill>
-                            <a:srgbClr val="004387"/>
-                          </a:solidFill>
-                          <a:latin typeface="Arial" pitchFamily="34" charset="0"/>
-                          <a:ea typeface="Arial" pitchFamily="34" charset="-122"/>
-                          <a:cs typeface="Arial" pitchFamily="34" charset="-120"/>
-                        </a:rPr>
-                        <a:t>Second machine</a:t>
-                      </a:r>
-                      <a:endParaRPr lang="en-US" sz="1600" dirty="0">
-                        <a:latin typeface="Arial" charset="0"/>
-                        <a:ea typeface="Arial" charset="0"/>
-                        <a:cs typeface="Arial" charset="0"/>
-                      </a:endParaRPr>
-                    </a:p>
-                  </a:txBody>
-                  <a:tcPr marL="91440" marR="91440" marT="36576" marB="36576" anchor="ctr">
-                    <a:lnL w="9525" cap="flat" cmpd="sng" algn="ctr">
-                      <a:solidFill>
-                        <a:srgbClr val="C9D3DC"/>
-                      </a:solidFill>
-                      <a:prstDash val="solid"/>
-                      <a:round/>
-                      <a:headEnd type="none" w="med" len="med"/>
-                      <a:tailEnd type="none" w="med" len="med"/>
-                    </a:lnL>
-                    <a:lnR w="9525" cap="flat" cmpd="sng" algn="ctr">
-                      <a:solidFill>
-                        <a:srgbClr val="C9D3DC"/>
-                      </a:solidFill>
-                      <a:prstDash val="solid"/>
-                      <a:round/>
-                      <a:headEnd type="none" w="med" len="med"/>
-                      <a:tailEnd type="none" w="med" len="med"/>
-                    </a:lnR>
-                    <a:lnT w="9525" cap="flat" cmpd="sng" algn="ctr">
-                      <a:solidFill>
-                        <a:srgbClr val="C9D3DC"/>
-                      </a:solidFill>
-                      <a:prstDash val="solid"/>
-                      <a:round/>
-                      <a:headEnd type="none" w="med" len="med"/>
-                      <a:tailEnd type="none" w="med" len="med"/>
-                    </a:lnT>
-                    <a:lnB w="9525" cap="flat" cmpd="sng" algn="ctr">
-                      <a:solidFill>
-                        <a:srgbClr val="C9D3DC"/>
-                      </a:solidFill>
-                      <a:prstDash val="solid"/>
-                      <a:round/>
-                      <a:headEnd type="none" w="med" len="med"/>
-                      <a:tailEnd type="none" w="med" len="med"/>
-                    </a:lnB>
-                  </a:tcPr>
-                </a:tc>
-                <a:tc>
-                  <a:txBody>
-                    <a:bodyPr/>
-                    <a:lstStyle/>
-                    <a:p>
-                      <a:pPr algn="l" indent="0" marL="0">
-                        <a:buNone/>
-                      </a:pPr>
-                      <a:r>
-                        <a:rPr lang="en-US" sz="1600" dirty="0">
-                          <a:solidFill>
-                            <a:srgbClr val="1F2937"/>
-                          </a:solidFill>
-                          <a:latin typeface="Arial" pitchFamily="34" charset="0"/>
-                          <a:ea typeface="Arial" pitchFamily="34" charset="-122"/>
-                          <a:cs typeface="Arial" pitchFamily="34" charset="-120"/>
-                        </a:rPr>
-                        <a:t>Passes</a:t>
-                      </a:r>
-                      <a:endParaRPr lang="en-US" sz="1600" dirty="0">
-                        <a:latin typeface="Arial" charset="0"/>
-                        <a:ea typeface="Arial" charset="0"/>
-                        <a:cs typeface="Arial" charset="0"/>
-                      </a:endParaRPr>
-                    </a:p>
-                  </a:txBody>
-                  <a:tcPr marL="91440" marR="91440" marT="36576" marB="36576" anchor="ctr">
-                    <a:lnL w="9525" cap="flat" cmpd="sng" algn="ctr">
-                      <a:solidFill>
-                        <a:srgbClr val="C9D3DC"/>
-                      </a:solidFill>
-                      <a:prstDash val="solid"/>
-                      <a:round/>
-                      <a:headEnd type="none" w="med" len="med"/>
-                      <a:tailEnd type="none" w="med" len="med"/>
-                    </a:lnL>
-                    <a:lnR w="9525" cap="flat" cmpd="sng" algn="ctr">
-                      <a:solidFill>
-                        <a:srgbClr val="C9D3DC"/>
-                      </a:solidFill>
-                      <a:prstDash val="solid"/>
-                      <a:round/>
-                      <a:headEnd type="none" w="med" len="med"/>
-                      <a:tailEnd type="none" w="med" len="med"/>
-                    </a:lnR>
-                    <a:lnT w="9525" cap="flat" cmpd="sng" algn="ctr">
-                      <a:solidFill>
-                        <a:srgbClr val="C9D3DC"/>
-                      </a:solidFill>
-                      <a:prstDash val="solid"/>
-                      <a:round/>
-                      <a:headEnd type="none" w="med" len="med"/>
-                      <a:tailEnd type="none" w="med" len="med"/>
-                    </a:lnT>
-                    <a:lnB w="9525" cap="flat" cmpd="sng" algn="ctr">
-                      <a:solidFill>
-                        <a:srgbClr val="C9D3DC"/>
-                      </a:solidFill>
-                      <a:prstDash val="solid"/>
-                      <a:round/>
-                      <a:headEnd type="none" w="med" len="med"/>
-                      <a:tailEnd type="none" w="med" len="med"/>
-                    </a:lnB>
-                  </a:tcPr>
-                </a:tc>
-                <a:tc>
-                  <a:txBody>
-                    <a:bodyPr/>
-                    <a:lstStyle/>
-                    <a:p>
-                      <a:pPr algn="l" indent="0" marL="0">
-                        <a:buNone/>
-                      </a:pPr>
-                      <a:r>
-                        <a:rPr lang="en-US" sz="1600" dirty="0">
-                          <a:solidFill>
-                            <a:srgbClr val="1F2937"/>
-                          </a:solidFill>
-                          <a:latin typeface="Arial" pitchFamily="34" charset="0"/>
-                          <a:ea typeface="Arial" pitchFamily="34" charset="-122"/>
-                          <a:cs typeface="Arial" pitchFamily="34" charset="-120"/>
-                        </a:rPr>
-                        <a:t>⟦ACTUAL s13_second_machine: result⟧</a:t>
-                      </a:r>
-                      <a:endParaRPr lang="en-US" sz="1600" dirty="0">
-                        <a:latin typeface="Arial" charset="0"/>
-                        <a:ea typeface="Arial" charset="0"/>
-                        <a:cs typeface="Arial" charset="0"/>
-                      </a:endParaRPr>
-                    </a:p>
-                  </a:txBody>
-                  <a:tcPr marL="91440" marR="91440" marT="36576" marB="36576" anchor="ctr">
-                    <a:lnL w="9525" cap="flat" cmpd="sng" algn="ctr">
-                      <a:solidFill>
-                        <a:srgbClr val="C9D3DC"/>
-                      </a:solidFill>
-                      <a:prstDash val="solid"/>
-                      <a:round/>
-                      <a:headEnd type="none" w="med" len="med"/>
-                      <a:tailEnd type="none" w="med" len="med"/>
-                    </a:lnL>
-                    <a:lnR w="9525" cap="flat" cmpd="sng" algn="ctr">
-                      <a:solidFill>
-                        <a:srgbClr val="C9D3DC"/>
-                      </a:solidFill>
-                      <a:prstDash val="solid"/>
-                      <a:round/>
-                      <a:headEnd type="none" w="med" len="med"/>
-                      <a:tailEnd type="none" w="med" len="med"/>
-                    </a:lnR>
-                    <a:lnT w="9525" cap="flat" cmpd="sng" algn="ctr">
-                      <a:solidFill>
-                        <a:srgbClr val="C9D3DC"/>
-                      </a:solidFill>
-                      <a:prstDash val="solid"/>
-                      <a:round/>
-                      <a:headEnd type="none" w="med" len="med"/>
-                      <a:tailEnd type="none" w="med" len="med"/>
-                    </a:lnT>
-                    <a:lnB w="9525" cap="flat" cmpd="sng" algn="ctr">
-                      <a:solidFill>
-                        <a:srgbClr val="C9D3DC"/>
-                      </a:solidFill>
-                      <a:prstDash val="solid"/>
-                      <a:round/>
-                      <a:headEnd type="none" w="med" len="med"/>
-                      <a:tailEnd type="none" w="med" len="med"/>
-                    </a:lnB>
-                    <a:solidFill>
-                      <a:srgbClr val="FFF3C4"/>
-                    </a:solidFill>
                   </a:tcPr>
                 </a:tc>
               </a:tr>
@@ -10519,7 +10190,7 @@
                           <a:ea typeface="Arial" pitchFamily="34" charset="-122"/>
                           <a:cs typeface="Arial" pitchFamily="34" charset="-120"/>
                         </a:rPr>
-                        <a:t>⟦ACTUAL s13_roadmap_change: change⟧</a:t>
+                        <a:t>Third member from I2</a:t>
                       </a:r>
                       <a:endParaRPr lang="en-US" sz="1600" dirty="0">
                         <a:latin typeface="Arial" charset="0"/>
@@ -10565,9 +10236,6 @@
                       <a:headEnd type="none" w="med" len="med"/>
                       <a:tailEnd type="none" w="med" len="med"/>
                     </a:lnB>
-                    <a:solidFill>
-                      <a:srgbClr val="FFF3C4"/>
-                    </a:solidFill>
                   </a:tcPr>
                 </a:tc>
               </a:tr>
@@ -10730,7 +10398,7 @@
                 <a:ea typeface="Arial" pitchFamily="34" charset="-122"/>
                 <a:cs typeface="Arial" pitchFamily="34" charset="-120"/>
               </a:rPr>
-              <a:t>Built early on 19/10 with AI assistance; team review pending.</a:t>
+              <a:t>Built early on 19/10 with AI assistance; reviewed and fixed by the team on 20/10/2026.</a:t>
             </a:r>
             <a:endParaRPr lang="en-US" sz="1800" dirty="0"/>
           </a:p>
@@ -10751,7 +10419,7 @@
             <a:avLst/>
           </a:prstGeom>
           <a:solidFill>
-            <a:srgbClr val="FFF3C4"/>
+            <a:srgbClr val="E3ECF3"/>
           </a:solidFill>
           <a:ln/>
         </p:spPr>
@@ -10803,7 +10471,7 @@
                 <a:ea typeface="Arial" pitchFamily="34" charset="-122"/>
                 <a:cs typeface="Arial" pitchFamily="34" charset="-120"/>
               </a:rPr>
-              <a:t>⟦ACTUAL lesson_learned: lesson from Iteration 1⟧</a:t>
+              <a:t>Green tests are not proof: the review found a price bug all 81 tests missed. Each finding now gets a test.</a:t>
             </a:r>
             <a:endParaRPr lang="en-US" sz="1800" dirty="0"/>
           </a:p>
@@ -10956,7 +10624,7 @@
                 <a:ea typeface="Arial" pitchFamily="34" charset="-122"/>
                 <a:cs typeface="Arial" pitchFamily="34" charset="-120"/>
               </a:rPr>
-              <a:t>Each risk has an owner and a concrete mitigation; none relies on I6.</a:t>
+              <a:t>Each risk has a warning sign we watch and one owner.</a:t>
             </a:r>
             <a:endParaRPr lang="en-US" sz="1800" dirty="0"/>
           </a:p>
@@ -11611,7 +11279,7 @@
                           <a:ea typeface="Arial" pitchFamily="34" charset="-122"/>
                           <a:cs typeface="Arial" pitchFamily="34" charset="-120"/>
                         </a:rPr>
-                        <a:t>Answer by 31/10; generic admin fallback</a:t>
+                        <a:t>Decide by 31/10; reuse UC-06 admin pattern</a:t>
                       </a:r>
                       <a:endParaRPr lang="en-US" sz="1600" dirty="0">
                         <a:latin typeface="Arial" charset="0"/>
@@ -12730,7 +12398,7 @@
                           <a:ea typeface="Arial" pitchFamily="34" charset="-122"/>
                           <a:cs typeface="Arial" pitchFamily="34" charset="-120"/>
                         </a:rPr>
-                        <a:t>Member unavailable or late</a:t>
+                        <a:t>Member absent; new member ramping up</a:t>
                       </a:r>
                       <a:endParaRPr lang="en-US" sz="1600" dirty="0">
                         <a:latin typeface="Arial" charset="0"/>
@@ -12860,7 +12528,7 @@
                           <a:ea typeface="Arial" pitchFamily="34" charset="-122"/>
                           <a:cs typeface="Arial" pitchFamily="34" charset="-120"/>
                         </a:rPr>
-                        <a:t>Quan</a:t>
+                        <a:t>Dat</a:t>
                       </a:r>
                       <a:endParaRPr lang="en-US" sz="1600" dirty="0">
                         <a:latin typeface="Arial" charset="0"/>
@@ -12925,7 +12593,7 @@
                           <a:ea typeface="Arial" pitchFamily="34" charset="-122"/>
                           <a:cs typeface="Arial" pitchFamily="34" charset="-120"/>
                         </a:rPr>
-                        <a:t>Cross-review; I5 buffer on 13/11</a:t>
+                        <a:t>Pairing in I2; buffer day 13/11</a:t>
                       </a:r>
                       <a:endParaRPr lang="en-US" sz="1600" dirty="0">
                         <a:latin typeface="Arial" charset="0"/>
@@ -12978,118 +12646,6 @@
           </a:graphicData>
         </a:graphic>
       </p:graphicFrame>
-      <p:sp>
-        <p:nvSpPr>
-          <p:cNvPr id="5" name="Card"/>
-          <p:cNvSpPr/>
-          <p:nvPr/>
-        </p:nvSpPr>
-        <p:spPr>
-          <a:xfrm>
-            <a:off x="457200" y="5486400"/>
-            <a:ext cx="11277295" cy="457200"/>
-          </a:xfrm>
-          <a:prstGeom prst="rect">
-            <a:avLst/>
-          </a:prstGeom>
-          <a:solidFill>
-            <a:srgbClr val="FBE9E7"/>
-          </a:solidFill>
-          <a:ln/>
-        </p:spPr>
-      </p:sp>
-      <p:sp>
-        <p:nvSpPr>
-          <p:cNvPr id="6" name="Text 3"/>
-          <p:cNvSpPr txBox="1"/>
-          <p:nvPr/>
-        </p:nvSpPr>
-        <p:spPr>
-          <a:xfrm>
-            <a:off x="585216" y="5486400"/>
-            <a:ext cx="11021263" cy="457200"/>
-          </a:xfrm>
-          <a:prstGeom prst="rect">
-            <a:avLst/>
-          </a:prstGeom>
-          <a:noFill/>
-          <a:ln/>
-        </p:spPr>
-        <p:txBody>
-          <a:bodyPr wrap="square" lIns="0" tIns="0" rIns="0" bIns="0" rtlCol="0" anchor="ctr"/>
-          <a:lstStyle/>
-          <a:p>
-            <a:pPr algn="l" indent="0" marL="0">
-              <a:buNone/>
-            </a:pPr>
-            <a:r>
-              <a:rPr lang="en-US" sz="1800" b="1" dirty="0">
-                <a:solidFill>
-                  <a:srgbClr val="C95B55"/>
-                </a:solidFill>
-                <a:latin typeface="Arial" pitchFamily="34" charset="0"/>
-                <a:ea typeface="Arial" pitchFamily="34" charset="-122"/>
-                <a:cs typeface="Arial" pitchFamily="34" charset="-120"/>
-              </a:rPr>
-              <a:t>Contingency  </a:t>
-            </a:r>
-            <a:pPr algn="l" indent="0" marL="0">
-              <a:buNone/>
-            </a:pPr>
-            <a:r>
-              <a:rPr lang="en-US" sz="1800" dirty="0">
-                <a:solidFill>
-                  <a:srgbClr val="1F2937"/>
-                </a:solidFill>
-                <a:latin typeface="Arial" pitchFamily="34" charset="0"/>
-                <a:ea typeface="Arial" pitchFamily="34" charset="-122"/>
-                <a:cs typeface="Arial" pitchFamily="34" charset="-120"/>
-              </a:rPr>
-              <a:t>answers 31/10 · freeze 12/11 · buffer 13/11 · I6 is not a rescue buffer</a:t>
-            </a:r>
-            <a:endParaRPr lang="en-US" sz="1800" dirty="0"/>
-          </a:p>
-        </p:txBody>
-      </p:sp>
-      <p:sp>
-        <p:nvSpPr>
-          <p:cNvPr id="7" name="Text 4"/>
-          <p:cNvSpPr txBox="1"/>
-          <p:nvPr/>
-        </p:nvSpPr>
-        <p:spPr>
-          <a:xfrm>
-            <a:off x="457200" y="5989320"/>
-            <a:ext cx="11277295" cy="365760"/>
-          </a:xfrm>
-          <a:prstGeom prst="rect">
-            <a:avLst/>
-          </a:prstGeom>
-          <a:noFill/>
-          <a:ln/>
-        </p:spPr>
-        <p:txBody>
-          <a:bodyPr wrap="square" lIns="0" tIns="0" rIns="0" bIns="0" rtlCol="0" anchor="ctr"/>
-          <a:lstStyle/>
-          <a:p>
-            <a:pPr indent="0" marL="0">
-              <a:buNone/>
-            </a:pPr>
-            <a:r>
-              <a:rPr lang="en-US" sz="1800" dirty="0">
-                <a:solidFill>
-                  <a:srgbClr val="C95B55"/>
-                </a:solidFill>
-                <a:latin typeface="Arial" pitchFamily="34" charset="0"/>
-                <a:ea typeface="Arial" pitchFamily="34" charset="-122"/>
-                <a:cs typeface="Arial" pitchFamily="34" charset="-120"/>
-              </a:rPr>
-              <a:t>Red marks the two risks in the title: R-02 and R-03.</a:t>
-            </a:r>
-            <a:endParaRPr lang="en-US" sz="1800" dirty="0"/>
-          </a:p>
-        </p:txBody>
-      </p:sp>
       <p:sp>
         <p:nvSpPr>
           <p:cNvPr id="25" name="Slide Number Placeholder 0"/>
@@ -13198,7 +12754,7 @@
                 <a:ea typeface="Arial" pitchFamily="34" charset="-122"/>
                 <a:cs typeface="Arial" pitchFamily="34" charset="-120"/>
               </a:rPr>
-              <a:t>Five client and four lecturer questions decide the open rules</a:t>
+              <a:t>What we need from you</a:t>
             </a:r>
             <a:endParaRPr lang="en-US" sz="2600" dirty="0"/>
           </a:p>
@@ -13237,7 +12793,7 @@
                 <a:ea typeface="Arial" pitchFamily="34" charset="-122"/>
                 <a:cs typeface="Arial" pitchFamily="34" charset="-120"/>
               </a:rPr>
-              <a:t>Each question asks for one decision and carries our default.</a:t>
+              <a:t>We keep building on our defaults until the answers arrive.</a:t>
             </a:r>
             <a:endParaRPr lang="en-US" sz="1800" dirty="0"/>
           </a:p>
@@ -13349,7 +12905,7 @@
                 <a:ea typeface="Arial" pitchFamily="34" charset="-122"/>
                 <a:cs typeface="Arial" pitchFamily="34" charset="-120"/>
               </a:rPr>
-              <a:t>Busy count? Default: at capacity.</a:t>
+              <a:t>Busy and quiet hub? Default: at capacity; quiet gets 5,000 VND off.</a:t>
             </a:r>
             <a:endParaRPr lang="en-US" sz="1800" dirty="0"/>
           </a:p>
@@ -13495,7 +13051,7 @@
                 <a:ea typeface="Arial" pitchFamily="34" charset="-122"/>
                 <a:cs typeface="Arial" pitchFamily="34" charset="-120"/>
               </a:rPr>
-              <a:t>Until when? Default: before PREPARING.</a:t>
+              <a:t>Until when? Default: before cooking; refund in full.</a:t>
             </a:r>
             <a:endParaRPr lang="en-US" sz="1800" dirty="0"/>
           </a:p>
@@ -13695,7 +13251,7 @@
         <p:spPr>
           <a:xfrm>
             <a:off x="7589520" y="1965960"/>
-            <a:ext cx="4144975" cy="770382"/>
+            <a:ext cx="4144975" cy="603504"/>
           </a:xfrm>
           <a:prstGeom prst="rect">
             <a:avLst/>
@@ -13715,7 +13271,7 @@
         <p:spPr>
           <a:xfrm>
             <a:off x="7717536" y="1965960"/>
-            <a:ext cx="3888943" cy="770382"/>
+            <a:ext cx="3888943" cy="603504"/>
           </a:xfrm>
           <a:prstGeom prst="rect">
             <a:avLst/>
@@ -13753,7 +13309,7 @@
                 <a:ea typeface="Arial" pitchFamily="34" charset="-122"/>
                 <a:cs typeface="Arial" pitchFamily="34" charset="-120"/>
               </a:rPr>
-              <a:t>Analysis plus seed data enough?</a:t>
+              <a:t>Analysis plus seed data enough for CRUD?</a:t>
             </a:r>
             <a:endParaRPr lang="en-US" sz="1800" dirty="0"/>
           </a:p>
@@ -13767,8 +13323,8 @@
         </p:nvSpPr>
         <p:spPr>
           <a:xfrm>
-            <a:off x="7589520" y="2800350"/>
-            <a:ext cx="4144975" cy="770382"/>
+            <a:off x="7589520" y="2633472"/>
+            <a:ext cx="4144975" cy="603504"/>
           </a:xfrm>
           <a:prstGeom prst="rect">
             <a:avLst/>
@@ -13787,8 +13343,8 @@
         </p:nvSpPr>
         <p:spPr>
           <a:xfrm>
-            <a:off x="7717536" y="2800350"/>
-            <a:ext cx="3888943" cy="770382"/>
+            <a:off x="7717536" y="2633472"/>
+            <a:ext cx="3888943" cy="603504"/>
           </a:xfrm>
           <a:prstGeom prst="rect">
             <a:avLst/>
@@ -13840,8 +13396,8 @@
         </p:nvSpPr>
         <p:spPr>
           <a:xfrm>
-            <a:off x="7589520" y="3634740"/>
-            <a:ext cx="4144975" cy="770382"/>
+            <a:off x="7589520" y="3300984"/>
+            <a:ext cx="4144975" cy="603504"/>
           </a:xfrm>
           <a:prstGeom prst="rect">
             <a:avLst/>
@@ -13860,8 +13416,8 @@
         </p:nvSpPr>
         <p:spPr>
           <a:xfrm>
-            <a:off x="7717536" y="3634740"/>
-            <a:ext cx="3888943" cy="770382"/>
+            <a:off x="7717536" y="3300984"/>
+            <a:ext cx="3888943" cy="603504"/>
           </a:xfrm>
           <a:prstGeom prst="rect">
             <a:avLst/>
@@ -13913,8 +13469,8 @@
         </p:nvSpPr>
         <p:spPr>
           <a:xfrm>
-            <a:off x="7589520" y="4469130"/>
-            <a:ext cx="4144975" cy="770382"/>
+            <a:off x="7589520" y="3968496"/>
+            <a:ext cx="4144975" cy="603504"/>
           </a:xfrm>
           <a:prstGeom prst="rect">
             <a:avLst/>
@@ -13933,8 +13489,8 @@
         </p:nvSpPr>
         <p:spPr>
           <a:xfrm>
-            <a:off x="7717536" y="4469130"/>
-            <a:ext cx="3888943" cy="770382"/>
+            <a:off x="7717536" y="3968496"/>
+            <a:ext cx="3888943" cy="603504"/>
           </a:xfrm>
           <a:prstGeom prst="rect">
             <a:avLst/>
@@ -13972,7 +13528,7 @@
                 <a:ea typeface="Arial" pitchFamily="34" charset="-122"/>
                 <a:cs typeface="Arial" pitchFamily="34" charset="-120"/>
               </a:rPr>
-              <a:t>Python 3.12 or later acceptable?</a:t>
+              <a:t>Python with Flask acceptable?</a:t>
             </a:r>
             <a:endParaRPr lang="en-US" sz="1800" dirty="0"/>
           </a:p>
@@ -13986,8 +13542,8 @@
         </p:nvSpPr>
         <p:spPr>
           <a:xfrm>
-            <a:off x="457200" y="5532120"/>
-            <a:ext cx="11277295" cy="777240"/>
+            <a:off x="7589520" y="4636008"/>
+            <a:ext cx="4144975" cy="603504"/>
           </a:xfrm>
           <a:prstGeom prst="rect">
             <a:avLst/>
@@ -14001,6 +13557,79 @@
       <p:sp>
         <p:nvSpPr>
           <p:cNvPr id="25" name="Text 23"/>
+          <p:cNvSpPr txBox="1"/>
+          <p:nvPr/>
+        </p:nvSpPr>
+        <p:spPr>
+          <a:xfrm>
+            <a:off x="7717536" y="4636008"/>
+            <a:ext cx="3888943" cy="603504"/>
+          </a:xfrm>
+          <a:prstGeom prst="rect">
+            <a:avLst/>
+          </a:prstGeom>
+          <a:noFill/>
+          <a:ln/>
+        </p:spPr>
+        <p:txBody>
+          <a:bodyPr wrap="square" lIns="0" tIns="0" rIns="0" bIns="0" rtlCol="0" anchor="ctr"/>
+          <a:lstStyle/>
+          <a:p>
+            <a:pPr algn="l" indent="0" marL="0">
+              <a:buNone/>
+            </a:pPr>
+            <a:r>
+              <a:rPr lang="en-US" sz="1800" b="1" dirty="0">
+                <a:solidFill>
+                  <a:srgbClr val="004387"/>
+                </a:solidFill>
+                <a:latin typeface="Arial" pitchFamily="34" charset="0"/>
+                <a:ea typeface="Arial" pitchFamily="34" charset="-122"/>
+                <a:cs typeface="Arial" pitchFamily="34" charset="-120"/>
+              </a:rPr>
+              <a:t>L5   </a:t>
+            </a:r>
+            <a:pPr algn="l" indent="0" marL="0">
+              <a:buNone/>
+            </a:pPr>
+            <a:r>
+              <a:rPr lang="en-US" sz="1800" dirty="0">
+                <a:solidFill>
+                  <a:srgbClr val="1F2937"/>
+                </a:solidFill>
+                <a:latin typeface="Arial" pitchFamily="34" charset="0"/>
+                <a:ea typeface="Arial" pitchFamily="34" charset="-122"/>
+                <a:cs typeface="Arial" pitchFamily="34" charset="-120"/>
+              </a:rPr>
+              <a:t>Third member, UC-05 and UC-06 accepted?</a:t>
+            </a:r>
+            <a:endParaRPr lang="en-US" sz="1800" dirty="0"/>
+          </a:p>
+        </p:txBody>
+      </p:sp>
+      <p:sp>
+        <p:nvSpPr>
+          <p:cNvPr id="26" name="Card"/>
+          <p:cNvSpPr/>
+          <p:nvPr/>
+        </p:nvSpPr>
+        <p:spPr>
+          <a:xfrm>
+            <a:off x="457200" y="5532120"/>
+            <a:ext cx="11277295" cy="777240"/>
+          </a:xfrm>
+          <a:prstGeom prst="rect">
+            <a:avLst/>
+          </a:prstGeom>
+          <a:solidFill>
+            <a:srgbClr val="E3ECF3"/>
+          </a:solidFill>
+          <a:ln/>
+        </p:spPr>
+      </p:sp>
+      <p:sp>
+        <p:nvSpPr>
+          <p:cNvPr id="27" name="Text 25"/>
           <p:cNvSpPr txBox="1"/>
           <p:nvPr/>
         </p:nvSpPr>
@@ -14045,7 +13674,7 @@
                 <a:ea typeface="Arial" pitchFamily="34" charset="-122"/>
                 <a:cs typeface="Arial" pitchFamily="34" charset="-120"/>
               </a:rPr>
-              <a:t>Answers needed by 31/10. A-10 confirmed verbally by the lecturer. Next: Iteration 2 on 27/10.</a:t>
+              <a:t>Please answer by 31/10. Iteration 2 starts on 27/10.</a:t>
             </a:r>
             <a:endParaRPr lang="en-US" sz="1800" dirty="0"/>
           </a:p>
@@ -14198,7 +13827,7 @@
                 <a:ea typeface="Arial" pitchFamily="34" charset="-122"/>
                 <a:cs typeface="Arial" pitchFamily="34" charset="-120"/>
               </a:rPr>
-              <a:t>Five pains from the case map to five capabilities of one shared platform.</a:t>
+              <a:t>Five pains from the case, and what the platform does about each.</a:t>
             </a:r>
             <a:endParaRPr lang="en-US" sz="1800" dirty="0"/>
           </a:p>
@@ -14316,7 +13945,7 @@
                           <a:ea typeface="Arial" pitchFamily="34" charset="-122"/>
                           <a:cs typeface="Arial" pitchFamily="34" charset="-120"/>
                         </a:rPr>
-                        <a:t>Capability in this release</a:t>
+                        <a:t>What the platform does</a:t>
                       </a:r>
                       <a:endParaRPr lang="en-US" sz="1600" dirty="0">
                         <a:latin typeface="Arial" charset="0"/>
@@ -14583,7 +14212,7 @@
                           <a:ea typeface="Arial" pitchFamily="34" charset="-122"/>
                           <a:cs typeface="Arial" pitchFamily="34" charset="-120"/>
                         </a:rPr>
-                        <a:t>Cash recorded per order, reconciled</a:t>
+                        <a:t>Shipper records cash per order</a:t>
                       </a:r>
                       <a:endParaRPr lang="en-US" sz="1600" dirty="0">
                         <a:latin typeface="Arial" charset="0"/>
@@ -14715,7 +14344,7 @@
                           <a:ea typeface="Arial" pitchFamily="34" charset="-122"/>
                           <a:cs typeface="Arial" pitchFamily="34" charset="-120"/>
                         </a:rPr>
-                        <a:t>Reject or replace with consent</a:t>
+                        <a:t>Kitchen rejects, or replaces with consent</a:t>
                       </a:r>
                       <a:endParaRPr lang="en-US" sz="1600" dirty="0">
                         <a:latin typeface="Arial" charset="0"/>
@@ -15099,7 +14728,7 @@
                 <a:ea typeface="Arial" pitchFamily="34" charset="-122"/>
                 <a:cs typeface="Arial" pitchFamily="34" charset="-120"/>
               </a:rPr>
-              <a:t>One order record, visible workload, reports from the same data. Benefits are expected, not measured.</a:t>
+              <a:t>One order record that customer, kitchen, shipper and manager all read.</a:t>
             </a:r>
             <a:endParaRPr lang="en-US" sz="1800" dirty="0"/>
           </a:p>
@@ -15213,7 +14842,7 @@
                 <a:ea typeface="Arial" pitchFamily="34" charset="-122"/>
                 <a:cs typeface="Arial" pitchFamily="34" charset="-120"/>
               </a:rPr>
-              <a:t>One order crosses five roles, and every branch has an owner</a:t>
+              <a:t>One lunch order crosses five roles</a:t>
             </a:r>
             <a:endParaRPr lang="en-US" sz="2600" dirty="0"/>
           </a:p>
@@ -16167,7 +15796,7 @@
                 <a:ea typeface="Arial" pitchFamily="34" charset="-122"/>
                 <a:cs typeface="Arial" pitchFamily="34" charset="-120"/>
               </a:rPr>
-              <a:t>The kitchen gates the order; cancelling is its own short activity</a:t>
+              <a:t>The kitchen confirms, offers a replacement, or rejects</a:t>
             </a:r>
             <a:endParaRPr lang="en-US" sz="2600" dirty="0"/>
           </a:p>
@@ -16444,7 +16073,7 @@
                 <a:ea typeface="Arial" pitchFamily="34" charset="-122"/>
                 <a:cs typeface="Arial" pitchFamily="34" charset="-120"/>
               </a:rPr>
-              <a:t>Cancel order is a separate activity (proposal Figure 1e): analysed only, A-08.</a:t>
+              <a:t>The customer may cancel until cooking starts: a separate activity (proposal Figure 1e).</a:t>
             </a:r>
             <a:endParaRPr lang="en-US" sz="1800" dirty="0"/>
           </a:p>
@@ -16954,7 +16583,7 @@
                 <a:ea typeface="Arial" pitchFamily="34" charset="-122"/>
                 <a:cs typeface="Arial" pitchFamily="34" charset="-120"/>
               </a:rPr>
-              <a:t>Only complaints and paid-online failures reach the refund decision</a:t>
+              <a:t>Failures are refunded in full; only a complaint needs a decision</a:t>
             </a:r>
             <a:endParaRPr lang="en-US" sz="2600" dirty="0"/>
           </a:p>
@@ -17311,7 +16940,7 @@
                 <a:ea typeface="Arial" pitchFamily="34" charset="-122"/>
                 <a:cs typeface="Arial" pitchFamily="34" charset="-120"/>
               </a:rPr>
-              <a:t>Each actor decides one thing the order cannot move without</a:t>
+              <a:t>Actors and responsibilities</a:t>
             </a:r>
             <a:endParaRPr lang="en-US" sz="2600" dirty="0"/>
           </a:p>
@@ -17326,7 +16955,7 @@
         <p:spPr>
           <a:xfrm>
             <a:off x="457200" y="1097280"/>
-            <a:ext cx="11277295" cy="685800"/>
+            <a:ext cx="11277295" cy="365760"/>
           </a:xfrm>
           <a:prstGeom prst="rect">
             <a:avLst/>
@@ -17350,7 +16979,7 @@
                 <a:ea typeface="Arial" pitchFamily="34" charset="-122"/>
                 <a:cs typeface="Arial" pitchFamily="34" charset="-120"/>
               </a:rPr>
-              <a:t>The shipper records COD collection and hands the cash to the hub; office staff reconcile it at the end of the shift.</a:t>
+              <a:t>Six roles in the business and one outside system.</a:t>
             </a:r>
             <a:endParaRPr lang="en-US" sz="1800" dirty="0"/>
           </a:p>
@@ -17371,7 +17000,7 @@
           </p:nvPr>
         </p:nvGraphicFramePr>
         <p:xfrm>
-          <a:off x="457200" y="1920240"/>
+          <a:off x="457200" y="1645920"/>
           <a:ext cx="11277295" cy="914400"/>
         </p:xfrm>
         <a:graphic>
@@ -17379,9 +17008,9 @@
             <a:tbl>
               <a:tblPr/>
               <a:tblGrid>
-                <a:gridCol w="2194560"/>
-                <a:gridCol w="4754880"/>
-                <a:gridCol w="4327855"/>
+                <a:gridCol w="2651760"/>
+                <a:gridCol w="5852160"/>
+                <a:gridCol w="2773375"/>
               </a:tblGrid>
               <a:tr h="411480">
                 <a:tc>
@@ -17469,7 +17098,7 @@
                           <a:ea typeface="Arial" pitchFamily="34" charset="-122"/>
                           <a:cs typeface="Arial" pitchFamily="34" charset="-120"/>
                         </a:rPr>
-                        <a:t>Decides or does</a:t>
+                        <a:t>Responsibility</a:t>
                       </a:r>
                       <a:endParaRPr lang="en-US" sz="1600" dirty="0">
                         <a:latin typeface="Arial" charset="0"/>
@@ -17537,7 +17166,7 @@
                           <a:ea typeface="Arial" pitchFamily="34" charset="-122"/>
                           <a:cs typeface="Arial" pitchFamily="34" charset="-120"/>
                         </a:rPr>
-                        <a:t>Without them</a:t>
+                        <a:t>Main use case</a:t>
                       </a:r>
                       <a:endParaRPr lang="en-US" sz="1600" dirty="0">
                         <a:latin typeface="Arial" charset="0"/>
@@ -17589,7 +17218,7 @@
                   </a:tcPr>
                 </a:tc>
               </a:tr>
-              <a:tr h="521208">
+              <a:tr h="548640">
                 <a:tc>
                   <a:txBody>
                     <a:bodyPr/>
@@ -17672,7 +17301,7 @@
                           <a:ea typeface="Arial" pitchFamily="34" charset="-122"/>
                           <a:cs typeface="Arial" pitchFamily="34" charset="-120"/>
                         </a:rPr>
-                        <a:t>Picks hub, items, payment</a:t>
+                        <a:t>Orders, pays, may cancel or complain</a:t>
                       </a:r>
                       <a:endParaRPr lang="en-US" sz="1600" dirty="0">
                         <a:latin typeface="Arial" charset="0"/>
@@ -17737,7 +17366,7 @@
                           <a:ea typeface="Arial" pitchFamily="34" charset="-122"/>
                           <a:cs typeface="Arial" pitchFamily="34" charset="-120"/>
                         </a:rPr>
-                        <a:t>No order exists</a:t>
+                        <a:t>UC-01</a:t>
                       </a:r>
                       <a:endParaRPr lang="en-US" sz="1600" dirty="0">
                         <a:latin typeface="Arial" charset="0"/>
@@ -17786,7 +17415,7 @@
                   </a:tcPr>
                 </a:tc>
               </a:tr>
-              <a:tr h="521208">
+              <a:tr h="548640">
                 <a:tc>
                   <a:txBody>
                     <a:bodyPr/>
@@ -17869,7 +17498,7 @@
                           <a:ea typeface="Arial" pitchFamily="34" charset="-122"/>
                           <a:cs typeface="Arial" pitchFamily="34" charset="-120"/>
                         </a:rPr>
-                        <a:t>Confirms or rejects, prepares</a:t>
+                        <a:t>Confirms, rejects or replaces; cooks</a:t>
                       </a:r>
                       <a:endParaRPr lang="en-US" sz="1600" dirty="0">
                         <a:latin typeface="Arial" charset="0"/>
@@ -17934,7 +17563,7 @@
                           <a:ea typeface="Arial" pitchFamily="34" charset="-122"/>
                           <a:cs typeface="Arial" pitchFamily="34" charset="-120"/>
                         </a:rPr>
-                        <a:t>Nothing to deliver</a:t>
+                        <a:t>UC-05</a:t>
                       </a:r>
                       <a:endParaRPr lang="en-US" sz="1600" dirty="0">
                         <a:latin typeface="Arial" charset="0"/>
@@ -17983,7 +17612,7 @@
                   </a:tcPr>
                 </a:tc>
               </a:tr>
-              <a:tr h="521208">
+              <a:tr h="548640">
                 <a:tc>
                   <a:txBody>
                     <a:bodyPr/>
@@ -18066,7 +17695,7 @@
                           <a:ea typeface="Arial" pitchFamily="34" charset="-122"/>
                           <a:cs typeface="Arial" pitchFamily="34" charset="-120"/>
                         </a:rPr>
-                        <a:t>Delivers, records COD collection</a:t>
+                        <a:t>Delivers, records cash per order</a:t>
                       </a:r>
                       <a:endParaRPr lang="en-US" sz="1600" dirty="0">
                         <a:latin typeface="Arial" charset="0"/>
@@ -18131,7 +17760,7 @@
                           <a:ea typeface="Arial" pitchFamily="34" charset="-122"/>
                           <a:cs typeface="Arial" pitchFamily="34" charset="-120"/>
                         </a:rPr>
-                        <a:t>Cash and order stay open</a:t>
+                        <a:t>UC-02</a:t>
                       </a:r>
                       <a:endParaRPr lang="en-US" sz="1600" dirty="0">
                         <a:latin typeface="Arial" charset="0"/>
@@ -18180,7 +17809,204 @@
                   </a:tcPr>
                 </a:tc>
               </a:tr>
-              <a:tr h="521208">
+              <a:tr h="548640">
+                <a:tc>
+                  <a:txBody>
+                    <a:bodyPr/>
+                    <a:lstStyle/>
+                    <a:p>
+                      <a:pPr algn="l" indent="0" marL="0">
+                        <a:buNone/>
+                      </a:pPr>
+                      <a:r>
+                        <a:rPr lang="en-US" sz="1600" b="1" dirty="0">
+                          <a:solidFill>
+                            <a:srgbClr val="004387"/>
+                          </a:solidFill>
+                          <a:latin typeface="Arial" pitchFamily="34" charset="0"/>
+                          <a:ea typeface="Arial" pitchFamily="34" charset="-122"/>
+                          <a:cs typeface="Arial" pitchFamily="34" charset="-120"/>
+                        </a:rPr>
+                        <a:t>Office staff</a:t>
+                      </a:r>
+                      <a:endParaRPr lang="en-US" sz="1600" dirty="0">
+                        <a:latin typeface="Arial" charset="0"/>
+                        <a:ea typeface="Arial" charset="0"/>
+                        <a:cs typeface="Arial" charset="0"/>
+                      </a:endParaRPr>
+                    </a:p>
+                  </a:txBody>
+                  <a:tcPr marL="91440" marR="91440" marT="36576" marB="36576" anchor="ctr">
+                    <a:lnL w="9525" cap="flat" cmpd="sng" algn="ctr">
+                      <a:solidFill>
+                        <a:srgbClr val="C9D3DC"/>
+                      </a:solidFill>
+                      <a:prstDash val="solid"/>
+                      <a:round/>
+                      <a:headEnd type="none" w="med" len="med"/>
+                      <a:tailEnd type="none" w="med" len="med"/>
+                    </a:lnL>
+                    <a:lnR w="9525" cap="flat" cmpd="sng" algn="ctr">
+                      <a:solidFill>
+                        <a:srgbClr val="C9D3DC"/>
+                      </a:solidFill>
+                      <a:prstDash val="solid"/>
+                      <a:round/>
+                      <a:headEnd type="none" w="med" len="med"/>
+                      <a:tailEnd type="none" w="med" len="med"/>
+                    </a:lnR>
+                    <a:lnT w="9525" cap="flat" cmpd="sng" algn="ctr">
+                      <a:solidFill>
+                        <a:srgbClr val="C9D3DC"/>
+                      </a:solidFill>
+                      <a:prstDash val="solid"/>
+                      <a:round/>
+                      <a:headEnd type="none" w="med" len="med"/>
+                      <a:tailEnd type="none" w="med" len="med"/>
+                    </a:lnT>
+                    <a:lnB w="9525" cap="flat" cmpd="sng" algn="ctr">
+                      <a:solidFill>
+                        <a:srgbClr val="C9D3DC"/>
+                      </a:solidFill>
+                      <a:prstDash val="solid"/>
+                      <a:round/>
+                      <a:headEnd type="none" w="med" len="med"/>
+                      <a:tailEnd type="none" w="med" len="med"/>
+                    </a:lnB>
+                  </a:tcPr>
+                </a:tc>
+                <a:tc>
+                  <a:txBody>
+                    <a:bodyPr/>
+                    <a:lstStyle/>
+                    <a:p>
+                      <a:pPr algn="l" indent="0" marL="0">
+                        <a:buNone/>
+                      </a:pPr>
+                      <a:r>
+                        <a:rPr lang="en-US" sz="1600" dirty="0">
+                          <a:solidFill>
+                            <a:srgbClr val="1F2937"/>
+                          </a:solidFill>
+                          <a:latin typeface="Arial" pitchFamily="34" charset="0"/>
+                          <a:ea typeface="Arial" pitchFamily="34" charset="-122"/>
+                          <a:cs typeface="Arial" pitchFamily="34" charset="-120"/>
+                        </a:rPr>
+                        <a:t>Reconciles cash, decides complaints</a:t>
+                      </a:r>
+                      <a:endParaRPr lang="en-US" sz="1600" dirty="0">
+                        <a:latin typeface="Arial" charset="0"/>
+                        <a:ea typeface="Arial" charset="0"/>
+                        <a:cs typeface="Arial" charset="0"/>
+                      </a:endParaRPr>
+                    </a:p>
+                  </a:txBody>
+                  <a:tcPr marL="91440" marR="91440" marT="36576" marB="36576" anchor="ctr">
+                    <a:lnL w="9525" cap="flat" cmpd="sng" algn="ctr">
+                      <a:solidFill>
+                        <a:srgbClr val="C9D3DC"/>
+                      </a:solidFill>
+                      <a:prstDash val="solid"/>
+                      <a:round/>
+                      <a:headEnd type="none" w="med" len="med"/>
+                      <a:tailEnd type="none" w="med" len="med"/>
+                    </a:lnL>
+                    <a:lnR w="9525" cap="flat" cmpd="sng" algn="ctr">
+                      <a:solidFill>
+                        <a:srgbClr val="C9D3DC"/>
+                      </a:solidFill>
+                      <a:prstDash val="solid"/>
+                      <a:round/>
+                      <a:headEnd type="none" w="med" len="med"/>
+                      <a:tailEnd type="none" w="med" len="med"/>
+                    </a:lnR>
+                    <a:lnT w="9525" cap="flat" cmpd="sng" algn="ctr">
+                      <a:solidFill>
+                        <a:srgbClr val="C9D3DC"/>
+                      </a:solidFill>
+                      <a:prstDash val="solid"/>
+                      <a:round/>
+                      <a:headEnd type="none" w="med" len="med"/>
+                      <a:tailEnd type="none" w="med" len="med"/>
+                    </a:lnT>
+                    <a:lnB w="9525" cap="flat" cmpd="sng" algn="ctr">
+                      <a:solidFill>
+                        <a:srgbClr val="C9D3DC"/>
+                      </a:solidFill>
+                      <a:prstDash val="solid"/>
+                      <a:round/>
+                      <a:headEnd type="none" w="med" len="med"/>
+                      <a:tailEnd type="none" w="med" len="med"/>
+                    </a:lnB>
+                  </a:tcPr>
+                </a:tc>
+                <a:tc>
+                  <a:txBody>
+                    <a:bodyPr/>
+                    <a:lstStyle/>
+                    <a:p>
+                      <a:pPr algn="l" indent="0" marL="0">
+                        <a:buNone/>
+                      </a:pPr>
+                      <a:r>
+                        <a:rPr lang="en-US" sz="1600" dirty="0">
+                          <a:solidFill>
+                            <a:srgbClr val="1F2937"/>
+                          </a:solidFill>
+                          <a:latin typeface="Arial" pitchFamily="34" charset="0"/>
+                          <a:ea typeface="Arial" pitchFamily="34" charset="-122"/>
+                          <a:cs typeface="Arial" pitchFamily="34" charset="-120"/>
+                        </a:rPr>
+                        <a:t>in process</a:t>
+                      </a:r>
+                      <a:endParaRPr lang="en-US" sz="1600" dirty="0">
+                        <a:latin typeface="Arial" charset="0"/>
+                        <a:ea typeface="Arial" charset="0"/>
+                        <a:cs typeface="Arial" charset="0"/>
+                      </a:endParaRPr>
+                    </a:p>
+                  </a:txBody>
+                  <a:tcPr marL="91440" marR="91440" marT="36576" marB="36576" anchor="ctr">
+                    <a:lnL w="9525" cap="flat" cmpd="sng" algn="ctr">
+                      <a:solidFill>
+                        <a:srgbClr val="C9D3DC"/>
+                      </a:solidFill>
+                      <a:prstDash val="solid"/>
+                      <a:round/>
+                      <a:headEnd type="none" w="med" len="med"/>
+                      <a:tailEnd type="none" w="med" len="med"/>
+                    </a:lnL>
+                    <a:lnR w="9525" cap="flat" cmpd="sng" algn="ctr">
+                      <a:solidFill>
+                        <a:srgbClr val="C9D3DC"/>
+                      </a:solidFill>
+                      <a:prstDash val="solid"/>
+                      <a:round/>
+                      <a:headEnd type="none" w="med" len="med"/>
+                      <a:tailEnd type="none" w="med" len="med"/>
+                    </a:lnR>
+                    <a:lnT w="9525" cap="flat" cmpd="sng" algn="ctr">
+                      <a:solidFill>
+                        <a:srgbClr val="C9D3DC"/>
+                      </a:solidFill>
+                      <a:prstDash val="solid"/>
+                      <a:round/>
+                      <a:headEnd type="none" w="med" len="med"/>
+                      <a:tailEnd type="none" w="med" len="med"/>
+                    </a:lnT>
+                    <a:lnB w="9525" cap="flat" cmpd="sng" algn="ctr">
+                      <a:solidFill>
+                        <a:srgbClr val="C9D3DC"/>
+                      </a:solidFill>
+                      <a:prstDash val="solid"/>
+                      <a:round/>
+                      <a:headEnd type="none" w="med" len="med"/>
+                      <a:tailEnd type="none" w="med" len="med"/>
+                    </a:lnB>
+                  </a:tcPr>
+                </a:tc>
+              </a:tr>
+              <a:tr h="548640">
                 <a:tc>
                   <a:txBody>
                     <a:bodyPr/>
@@ -18263,7 +18089,7 @@
                           <a:ea typeface="Arial" pitchFamily="34" charset="-122"/>
                           <a:cs typeface="Arial" pitchFamily="34" charset="-120"/>
                         </a:rPr>
-                        <a:t>Sets hubs and capacity</a:t>
+                        <a:t>Keeps hubs, capacity and menus</a:t>
                       </a:r>
                       <a:endParaRPr lang="en-US" sz="1600" dirty="0">
                         <a:latin typeface="Arial" charset="0"/>
@@ -18328,7 +18154,7 @@
                           <a:ea typeface="Arial" pitchFamily="34" charset="-122"/>
                           <a:cs typeface="Arial" pitchFamily="34" charset="-120"/>
                         </a:rPr>
-                        <a:t>Busy rule has no limit</a:t>
+                        <a:t>UC-03, UC-06</a:t>
                       </a:r>
                       <a:endParaRPr lang="en-US" sz="1600" dirty="0">
                         <a:latin typeface="Arial" charset="0"/>
@@ -18377,7 +18203,7 @@
                   </a:tcPr>
                 </a:tc>
               </a:tr>
-              <a:tr h="521208">
+              <a:tr h="548640">
                 <a:tc>
                   <a:txBody>
                     <a:bodyPr/>
@@ -18460,7 +18286,7 @@
                           <a:ea typeface="Arial" pitchFamily="34" charset="-122"/>
                           <a:cs typeface="Arial" pitchFamily="34" charset="-120"/>
                         </a:rPr>
-                        <a:t>Reads reports</a:t>
+                        <a:t>Reads sales, workload, delivery</a:t>
                       </a:r>
                       <a:endParaRPr lang="en-US" sz="1600" dirty="0">
                         <a:latin typeface="Arial" charset="0"/>
@@ -18525,7 +18351,7 @@
                           <a:ea typeface="Arial" pitchFamily="34" charset="-122"/>
                           <a:cs typeface="Arial" pitchFamily="34" charset="-120"/>
                         </a:rPr>
-                        <a:t>Hubs cannot be compared</a:t>
+                        <a:t>UC-04</a:t>
                       </a:r>
                       <a:endParaRPr lang="en-US" sz="1600" dirty="0">
                         <a:latin typeface="Arial" charset="0"/>
@@ -18574,7 +18400,7 @@
                   </a:tcPr>
                 </a:tc>
               </a:tr>
-              <a:tr h="521208">
+              <a:tr h="548640">
                 <a:tc>
                   <a:txBody>
                     <a:bodyPr/>
@@ -18592,7 +18418,7 @@
                           <a:ea typeface="Arial" pitchFamily="34" charset="-122"/>
                           <a:cs typeface="Arial" pitchFamily="34" charset="-120"/>
                         </a:rPr>
-                        <a:t>Office staff</a:t>
+                        <a:t>Payment provider</a:t>
                       </a:r>
                       <a:endParaRPr lang="en-US" sz="1600" dirty="0">
                         <a:latin typeface="Arial" charset="0"/>
@@ -18657,7 +18483,7 @@
                           <a:ea typeface="Arial" pitchFamily="34" charset="-122"/>
                           <a:cs typeface="Arial" pitchFamily="34" charset="-120"/>
                         </a:rPr>
-                        <a:t>Reconciles cash, decides refunds</a:t>
+                        <a:t>Online result (our stub)</a:t>
                       </a:r>
                       <a:endParaRPr lang="en-US" sz="1600" dirty="0">
                         <a:latin typeface="Arial" charset="0"/>
@@ -18722,204 +18548,7 @@
                           <a:ea typeface="Arial" pitchFamily="34" charset="-122"/>
                           <a:cs typeface="Arial" pitchFamily="34" charset="-120"/>
                         </a:rPr>
-                        <a:t>Cash and complaints unchecked</a:t>
-                      </a:r>
-                      <a:endParaRPr lang="en-US" sz="1600" dirty="0">
-                        <a:latin typeface="Arial" charset="0"/>
-                        <a:ea typeface="Arial" charset="0"/>
-                        <a:cs typeface="Arial" charset="0"/>
-                      </a:endParaRPr>
-                    </a:p>
-                  </a:txBody>
-                  <a:tcPr marL="91440" marR="91440" marT="36576" marB="36576" anchor="ctr">
-                    <a:lnL w="9525" cap="flat" cmpd="sng" algn="ctr">
-                      <a:solidFill>
-                        <a:srgbClr val="C9D3DC"/>
-                      </a:solidFill>
-                      <a:prstDash val="solid"/>
-                      <a:round/>
-                      <a:headEnd type="none" w="med" len="med"/>
-                      <a:tailEnd type="none" w="med" len="med"/>
-                    </a:lnL>
-                    <a:lnR w="9525" cap="flat" cmpd="sng" algn="ctr">
-                      <a:solidFill>
-                        <a:srgbClr val="C9D3DC"/>
-                      </a:solidFill>
-                      <a:prstDash val="solid"/>
-                      <a:round/>
-                      <a:headEnd type="none" w="med" len="med"/>
-                      <a:tailEnd type="none" w="med" len="med"/>
-                    </a:lnR>
-                    <a:lnT w="9525" cap="flat" cmpd="sng" algn="ctr">
-                      <a:solidFill>
-                        <a:srgbClr val="C9D3DC"/>
-                      </a:solidFill>
-                      <a:prstDash val="solid"/>
-                      <a:round/>
-                      <a:headEnd type="none" w="med" len="med"/>
-                      <a:tailEnd type="none" w="med" len="med"/>
-                    </a:lnT>
-                    <a:lnB w="9525" cap="flat" cmpd="sng" algn="ctr">
-                      <a:solidFill>
-                        <a:srgbClr val="C9D3DC"/>
-                      </a:solidFill>
-                      <a:prstDash val="solid"/>
-                      <a:round/>
-                      <a:headEnd type="none" w="med" len="med"/>
-                      <a:tailEnd type="none" w="med" len="med"/>
-                    </a:lnB>
-                  </a:tcPr>
-                </a:tc>
-              </a:tr>
-              <a:tr h="521208">
-                <a:tc>
-                  <a:txBody>
-                    <a:bodyPr/>
-                    <a:lstStyle/>
-                    <a:p>
-                      <a:pPr algn="l" indent="0" marL="0">
-                        <a:buNone/>
-                      </a:pPr>
-                      <a:r>
-                        <a:rPr lang="en-US" sz="1600" b="1" dirty="0">
-                          <a:solidFill>
-                            <a:srgbClr val="004387"/>
-                          </a:solidFill>
-                          <a:latin typeface="Arial" pitchFamily="34" charset="0"/>
-                          <a:ea typeface="Arial" pitchFamily="34" charset="-122"/>
-                          <a:cs typeface="Arial" pitchFamily="34" charset="-120"/>
-                        </a:rPr>
-                        <a:t>Payment stub</a:t>
-                      </a:r>
-                      <a:endParaRPr lang="en-US" sz="1600" dirty="0">
-                        <a:latin typeface="Arial" charset="0"/>
-                        <a:ea typeface="Arial" charset="0"/>
-                        <a:cs typeface="Arial" charset="0"/>
-                      </a:endParaRPr>
-                    </a:p>
-                  </a:txBody>
-                  <a:tcPr marL="91440" marR="91440" marT="36576" marB="36576" anchor="ctr">
-                    <a:lnL w="9525" cap="flat" cmpd="sng" algn="ctr">
-                      <a:solidFill>
-                        <a:srgbClr val="C9D3DC"/>
-                      </a:solidFill>
-                      <a:prstDash val="solid"/>
-                      <a:round/>
-                      <a:headEnd type="none" w="med" len="med"/>
-                      <a:tailEnd type="none" w="med" len="med"/>
-                    </a:lnL>
-                    <a:lnR w="9525" cap="flat" cmpd="sng" algn="ctr">
-                      <a:solidFill>
-                        <a:srgbClr val="C9D3DC"/>
-                      </a:solidFill>
-                      <a:prstDash val="solid"/>
-                      <a:round/>
-                      <a:headEnd type="none" w="med" len="med"/>
-                      <a:tailEnd type="none" w="med" len="med"/>
-                    </a:lnR>
-                    <a:lnT w="9525" cap="flat" cmpd="sng" algn="ctr">
-                      <a:solidFill>
-                        <a:srgbClr val="C9D3DC"/>
-                      </a:solidFill>
-                      <a:prstDash val="solid"/>
-                      <a:round/>
-                      <a:headEnd type="none" w="med" len="med"/>
-                      <a:tailEnd type="none" w="med" len="med"/>
-                    </a:lnT>
-                    <a:lnB w="9525" cap="flat" cmpd="sng" algn="ctr">
-                      <a:solidFill>
-                        <a:srgbClr val="C9D3DC"/>
-                      </a:solidFill>
-                      <a:prstDash val="solid"/>
-                      <a:round/>
-                      <a:headEnd type="none" w="med" len="med"/>
-                      <a:tailEnd type="none" w="med" len="med"/>
-                    </a:lnB>
-                  </a:tcPr>
-                </a:tc>
-                <a:tc>
-                  <a:txBody>
-                    <a:bodyPr/>
-                    <a:lstStyle/>
-                    <a:p>
-                      <a:pPr algn="l" indent="0" marL="0">
-                        <a:buNone/>
-                      </a:pPr>
-                      <a:r>
-                        <a:rPr lang="en-US" sz="1600" dirty="0">
-                          <a:solidFill>
-                            <a:srgbClr val="1F2937"/>
-                          </a:solidFill>
-                          <a:latin typeface="Arial" pitchFamily="34" charset="0"/>
-                          <a:ea typeface="Arial" pitchFamily="34" charset="-122"/>
-                          <a:cs typeface="Arial" pitchFamily="34" charset="-120"/>
-                        </a:rPr>
-                        <a:t>Returns the online result</a:t>
-                      </a:r>
-                      <a:endParaRPr lang="en-US" sz="1600" dirty="0">
-                        <a:latin typeface="Arial" charset="0"/>
-                        <a:ea typeface="Arial" charset="0"/>
-                        <a:cs typeface="Arial" charset="0"/>
-                      </a:endParaRPr>
-                    </a:p>
-                  </a:txBody>
-                  <a:tcPr marL="91440" marR="91440" marT="36576" marB="36576" anchor="ctr">
-                    <a:lnL w="9525" cap="flat" cmpd="sng" algn="ctr">
-                      <a:solidFill>
-                        <a:srgbClr val="C9D3DC"/>
-                      </a:solidFill>
-                      <a:prstDash val="solid"/>
-                      <a:round/>
-                      <a:headEnd type="none" w="med" len="med"/>
-                      <a:tailEnd type="none" w="med" len="med"/>
-                    </a:lnL>
-                    <a:lnR w="9525" cap="flat" cmpd="sng" algn="ctr">
-                      <a:solidFill>
-                        <a:srgbClr val="C9D3DC"/>
-                      </a:solidFill>
-                      <a:prstDash val="solid"/>
-                      <a:round/>
-                      <a:headEnd type="none" w="med" len="med"/>
-                      <a:tailEnd type="none" w="med" len="med"/>
-                    </a:lnR>
-                    <a:lnT w="9525" cap="flat" cmpd="sng" algn="ctr">
-                      <a:solidFill>
-                        <a:srgbClr val="C9D3DC"/>
-                      </a:solidFill>
-                      <a:prstDash val="solid"/>
-                      <a:round/>
-                      <a:headEnd type="none" w="med" len="med"/>
-                      <a:tailEnd type="none" w="med" len="med"/>
-                    </a:lnT>
-                    <a:lnB w="9525" cap="flat" cmpd="sng" algn="ctr">
-                      <a:solidFill>
-                        <a:srgbClr val="C9D3DC"/>
-                      </a:solidFill>
-                      <a:prstDash val="solid"/>
-                      <a:round/>
-                      <a:headEnd type="none" w="med" len="med"/>
-                      <a:tailEnd type="none" w="med" len="med"/>
-                    </a:lnB>
-                  </a:tcPr>
-                </a:tc>
-                <a:tc>
-                  <a:txBody>
-                    <a:bodyPr/>
-                    <a:lstStyle/>
-                    <a:p>
-                      <a:pPr algn="l" indent="0" marL="0">
-                        <a:buNone/>
-                      </a:pPr>
-                      <a:r>
-                        <a:rPr lang="en-US" sz="1600" dirty="0">
-                          <a:solidFill>
-                            <a:srgbClr val="1F2937"/>
-                          </a:solidFill>
-                          <a:latin typeface="Arial" pitchFamily="34" charset="0"/>
-                          <a:ea typeface="Arial" pitchFamily="34" charset="-122"/>
-                          <a:cs typeface="Arial" pitchFamily="34" charset="-120"/>
-                        </a:rPr>
-                        <a:t>Online path untestable</a:t>
+                        <a:t>UC-01</a:t>
                       </a:r>
                       <a:endParaRPr lang="en-US" sz="1600" dirty="0">
                         <a:latin typeface="Arial" charset="0"/>
@@ -19080,48 +18709,9 @@
                 <a:ea typeface="Arial" pitchFamily="34" charset="-122"/>
                 <a:cs typeface="Arial" pitchFamily="34" charset="-120"/>
               </a:rPr>
-              <a:t>Four use cases cover all four required groups, two per student</a:t>
+              <a:t>Six main use cases, two per student, cover all four groups</a:t>
             </a:r>
             <a:endParaRPr lang="en-US" sz="2600" dirty="0"/>
-          </a:p>
-        </p:txBody>
-      </p:sp>
-      <p:sp>
-        <p:nvSpPr>
-          <p:cNvPr id="3" name="Framing sentence"/>
-          <p:cNvSpPr txBox="1"/>
-          <p:nvPr/>
-        </p:nvSpPr>
-        <p:spPr>
-          <a:xfrm>
-            <a:off x="457200" y="1097280"/>
-            <a:ext cx="11277295" cy="365760"/>
-          </a:xfrm>
-          <a:prstGeom prst="rect">
-            <a:avLst/>
-          </a:prstGeom>
-          <a:noFill/>
-          <a:ln/>
-        </p:spPr>
-        <p:txBody>
-          <a:bodyPr wrap="square" lIns="0" tIns="0" rIns="0" bIns="0" rtlCol="0" anchor="ctr"/>
-          <a:lstStyle/>
-          <a:p>
-            <a:pPr algn="l" indent="0" marL="0">
-              <a:buNone/>
-            </a:pPr>
-            <a:r>
-              <a:rPr lang="en-US" sz="1800" dirty="0">
-                <a:solidFill>
-                  <a:srgbClr val="5B6472"/>
-                </a:solidFill>
-                <a:latin typeface="Arial" pitchFamily="34" charset="0"/>
-                <a:ea typeface="Arial" pitchFamily="34" charset="-122"/>
-                <a:cs typeface="Arial" pitchFamily="34" charset="-120"/>
-              </a:rPr>
-              <a:t>Each student owns two use cases and their state machines; five scope levels below.</a:t>
-            </a:r>
-            <a:endParaRPr lang="en-US" sz="1800" dirty="0"/>
           </a:p>
         </p:txBody>
       </p:sp>
@@ -19140,7 +18730,7 @@
           </p:nvPr>
         </p:nvGraphicFramePr>
         <p:xfrm>
-          <a:off x="457200" y="1600200"/>
+          <a:off x="457200" y="1188720"/>
           <a:ext cx="11277295" cy="914400"/>
         </p:xfrm>
         <a:graphic>
@@ -19149,13 +18739,13 @@
               <a:tblPr/>
               <a:tblGrid>
                 <a:gridCol w="914400"/>
-                <a:gridCol w="3566160"/>
-                <a:gridCol w="1554480"/>
-                <a:gridCol w="2011680"/>
-                <a:gridCol w="1005840"/>
-                <a:gridCol w="2224735"/>
+                <a:gridCol w="3840480"/>
+                <a:gridCol w="1645920"/>
+                <a:gridCol w="1920240"/>
+                <a:gridCol w="1097280"/>
+                <a:gridCol w="1858975"/>
               </a:tblGrid>
-              <a:tr h="411480">
+              <a:tr h="393192">
                 <a:tc>
                   <a:txBody>
                     <a:bodyPr/>
@@ -19565,7 +19155,7 @@
                   </a:tcPr>
                 </a:tc>
               </a:tr>
-              <a:tr h="411480">
+              <a:tr h="393192">
                 <a:tc>
                   <a:txBody>
                     <a:bodyPr/>
@@ -19957,7 +19547,7 @@
                   </a:tcPr>
                 </a:tc>
               </a:tr>
-              <a:tr h="411480">
+              <a:tr h="393192">
                 <a:tc>
                   <a:txBody>
                     <a:bodyPr/>
@@ -20235,7 +19825,7 @@
                           <a:ea typeface="Arial" pitchFamily="34" charset="-122"/>
                           <a:cs typeface="Arial" pitchFamily="34" charset="-120"/>
                         </a:rPr>
-                        <a:t>Quan</a:t>
+                        <a:t>Quan L.</a:t>
                       </a:r>
                       <a:endParaRPr lang="en-US" sz="1600" dirty="0">
                         <a:latin typeface="Arial" charset="0"/>
@@ -20349,7 +19939,7 @@
                   </a:tcPr>
                 </a:tc>
               </a:tr>
-              <a:tr h="411480">
+              <a:tr h="393192">
                 <a:tc>
                   <a:txBody>
                     <a:bodyPr/>
@@ -20741,7 +20331,7 @@
                   </a:tcPr>
                 </a:tc>
               </a:tr>
-              <a:tr h="411480">
+              <a:tr h="393192">
                 <a:tc>
                   <a:txBody>
                     <a:bodyPr/>
@@ -21019,7 +20609,7 @@
                           <a:ea typeface="Arial" pitchFamily="34" charset="-122"/>
                           <a:cs typeface="Arial" pitchFamily="34" charset="-120"/>
                         </a:rPr>
-                        <a:t>Quan</a:t>
+                        <a:t>Quan L.</a:t>
                       </a:r>
                       <a:endParaRPr lang="en-US" sz="1600" dirty="0">
                         <a:latin typeface="Arial" charset="0"/>
@@ -21133,20 +20723,877 @@
                   </a:tcPr>
                 </a:tc>
               </a:tr>
+              <a:tr h="393192">
+                <a:tc>
+                  <a:txBody>
+                    <a:bodyPr/>
+                    <a:lstStyle/>
+                    <a:p>
+                      <a:pPr algn="l" indent="0" marL="0">
+                        <a:buNone/>
+                      </a:pPr>
+                      <a:r>
+                        <a:rPr lang="en-US" sz="1600" b="1" dirty="0">
+                          <a:solidFill>
+                            <a:srgbClr val="004387"/>
+                          </a:solidFill>
+                          <a:latin typeface="Arial" pitchFamily="34" charset="0"/>
+                          <a:ea typeface="Arial" pitchFamily="34" charset="-122"/>
+                          <a:cs typeface="Arial" pitchFamily="34" charset="-120"/>
+                        </a:rPr>
+                        <a:t>UC-05</a:t>
+                      </a:r>
+                      <a:endParaRPr lang="en-US" sz="1600" dirty="0">
+                        <a:latin typeface="Arial" charset="0"/>
+                        <a:ea typeface="Arial" charset="0"/>
+                        <a:cs typeface="Arial" charset="0"/>
+                      </a:endParaRPr>
+                    </a:p>
+                  </a:txBody>
+                  <a:tcPr marL="91440" marR="91440" marT="36576" marB="36576" anchor="ctr">
+                    <a:lnL w="9525" cap="flat" cmpd="sng" algn="ctr">
+                      <a:solidFill>
+                        <a:srgbClr val="C9D3DC"/>
+                      </a:solidFill>
+                      <a:prstDash val="solid"/>
+                      <a:round/>
+                      <a:headEnd type="none" w="med" len="med"/>
+                      <a:tailEnd type="none" w="med" len="med"/>
+                    </a:lnL>
+                    <a:lnR w="9525" cap="flat" cmpd="sng" algn="ctr">
+                      <a:solidFill>
+                        <a:srgbClr val="C9D3DC"/>
+                      </a:solidFill>
+                      <a:prstDash val="solid"/>
+                      <a:round/>
+                      <a:headEnd type="none" w="med" len="med"/>
+                      <a:tailEnd type="none" w="med" len="med"/>
+                    </a:lnR>
+                    <a:lnT w="9525" cap="flat" cmpd="sng" algn="ctr">
+                      <a:solidFill>
+                        <a:srgbClr val="C9D3DC"/>
+                      </a:solidFill>
+                      <a:prstDash val="solid"/>
+                      <a:round/>
+                      <a:headEnd type="none" w="med" len="med"/>
+                      <a:tailEnd type="none" w="med" len="med"/>
+                    </a:lnT>
+                    <a:lnB w="9525" cap="flat" cmpd="sng" algn="ctr">
+                      <a:solidFill>
+                        <a:srgbClr val="C9D3DC"/>
+                      </a:solidFill>
+                      <a:prstDash val="solid"/>
+                      <a:round/>
+                      <a:headEnd type="none" w="med" len="med"/>
+                      <a:tailEnd type="none" w="med" len="med"/>
+                    </a:lnB>
+                  </a:tcPr>
+                </a:tc>
+                <a:tc>
+                  <a:txBody>
+                    <a:bodyPr/>
+                    <a:lstStyle/>
+                    <a:p>
+                      <a:pPr algn="l" indent="0" marL="0">
+                        <a:buNone/>
+                      </a:pPr>
+                      <a:r>
+                        <a:rPr lang="en-US" sz="1600" dirty="0">
+                          <a:solidFill>
+                            <a:srgbClr val="1F2937"/>
+                          </a:solidFill>
+                          <a:latin typeface="Arial" pitchFamily="34" charset="0"/>
+                          <a:ea typeface="Arial" pitchFamily="34" charset="-122"/>
+                          <a:cs typeface="Arial" pitchFamily="34" charset="-120"/>
+                        </a:rPr>
+                        <a:t>Confirm or reject an order (#7)</a:t>
+                      </a:r>
+                      <a:endParaRPr lang="en-US" sz="1600" dirty="0">
+                        <a:latin typeface="Arial" charset="0"/>
+                        <a:ea typeface="Arial" charset="0"/>
+                        <a:cs typeface="Arial" charset="0"/>
+                      </a:endParaRPr>
+                    </a:p>
+                  </a:txBody>
+                  <a:tcPr marL="91440" marR="91440" marT="36576" marB="36576" anchor="ctr">
+                    <a:lnL w="9525" cap="flat" cmpd="sng" algn="ctr">
+                      <a:solidFill>
+                        <a:srgbClr val="C9D3DC"/>
+                      </a:solidFill>
+                      <a:prstDash val="solid"/>
+                      <a:round/>
+                      <a:headEnd type="none" w="med" len="med"/>
+                      <a:tailEnd type="none" w="med" len="med"/>
+                    </a:lnL>
+                    <a:lnR w="9525" cap="flat" cmpd="sng" algn="ctr">
+                      <a:solidFill>
+                        <a:srgbClr val="C9D3DC"/>
+                      </a:solidFill>
+                      <a:prstDash val="solid"/>
+                      <a:round/>
+                      <a:headEnd type="none" w="med" len="med"/>
+                      <a:tailEnd type="none" w="med" len="med"/>
+                    </a:lnR>
+                    <a:lnT w="9525" cap="flat" cmpd="sng" algn="ctr">
+                      <a:solidFill>
+                        <a:srgbClr val="C9D3DC"/>
+                      </a:solidFill>
+                      <a:prstDash val="solid"/>
+                      <a:round/>
+                      <a:headEnd type="none" w="med" len="med"/>
+                      <a:tailEnd type="none" w="med" len="med"/>
+                    </a:lnT>
+                    <a:lnB w="9525" cap="flat" cmpd="sng" algn="ctr">
+                      <a:solidFill>
+                        <a:srgbClr val="C9D3DC"/>
+                      </a:solidFill>
+                      <a:prstDash val="solid"/>
+                      <a:round/>
+                      <a:headEnd type="none" w="med" len="med"/>
+                      <a:tailEnd type="none" w="med" len="med"/>
+                    </a:lnB>
+                  </a:tcPr>
+                </a:tc>
+                <a:tc>
+                  <a:txBody>
+                    <a:bodyPr/>
+                    <a:lstStyle/>
+                    <a:p>
+                      <a:pPr algn="l" indent="0" marL="0">
+                        <a:buNone/>
+                      </a:pPr>
+                      <a:r>
+                        <a:rPr lang="en-US" sz="1600" dirty="0">
+                          <a:solidFill>
+                            <a:srgbClr val="1F2937"/>
+                          </a:solidFill>
+                          <a:latin typeface="Arial" pitchFamily="34" charset="0"/>
+                          <a:ea typeface="Arial" pitchFamily="34" charset="-122"/>
+                          <a:cs typeface="Arial" pitchFamily="34" charset="-120"/>
+                        </a:rPr>
+                        <a:t>Kitchen staff</a:t>
+                      </a:r>
+                      <a:endParaRPr lang="en-US" sz="1600" dirty="0">
+                        <a:latin typeface="Arial" charset="0"/>
+                        <a:ea typeface="Arial" charset="0"/>
+                        <a:cs typeface="Arial" charset="0"/>
+                      </a:endParaRPr>
+                    </a:p>
+                  </a:txBody>
+                  <a:tcPr marL="91440" marR="91440" marT="36576" marB="36576" anchor="ctr">
+                    <a:lnL w="9525" cap="flat" cmpd="sng" algn="ctr">
+                      <a:solidFill>
+                        <a:srgbClr val="C9D3DC"/>
+                      </a:solidFill>
+                      <a:prstDash val="solid"/>
+                      <a:round/>
+                      <a:headEnd type="none" w="med" len="med"/>
+                      <a:tailEnd type="none" w="med" len="med"/>
+                    </a:lnL>
+                    <a:lnR w="9525" cap="flat" cmpd="sng" algn="ctr">
+                      <a:solidFill>
+                        <a:srgbClr val="C9D3DC"/>
+                      </a:solidFill>
+                      <a:prstDash val="solid"/>
+                      <a:round/>
+                      <a:headEnd type="none" w="med" len="med"/>
+                      <a:tailEnd type="none" w="med" len="med"/>
+                    </a:lnR>
+                    <a:lnT w="9525" cap="flat" cmpd="sng" algn="ctr">
+                      <a:solidFill>
+                        <a:srgbClr val="C9D3DC"/>
+                      </a:solidFill>
+                      <a:prstDash val="solid"/>
+                      <a:round/>
+                      <a:headEnd type="none" w="med" len="med"/>
+                      <a:tailEnd type="none" w="med" len="med"/>
+                    </a:lnT>
+                    <a:lnB w="9525" cap="flat" cmpd="sng" algn="ctr">
+                      <a:solidFill>
+                        <a:srgbClr val="C9D3DC"/>
+                      </a:solidFill>
+                      <a:prstDash val="solid"/>
+                      <a:round/>
+                      <a:headEnd type="none" w="med" len="med"/>
+                      <a:tailEnd type="none" w="med" len="med"/>
+                    </a:lnB>
+                  </a:tcPr>
+                </a:tc>
+                <a:tc>
+                  <a:txBody>
+                    <a:bodyPr/>
+                    <a:lstStyle/>
+                    <a:p>
+                      <a:pPr algn="l" indent="0" marL="0">
+                        <a:buNone/>
+                      </a:pPr>
+                      <a:r>
+                        <a:rPr lang="en-US" sz="1600" dirty="0">
+                          <a:solidFill>
+                            <a:srgbClr val="1F2937"/>
+                          </a:solidFill>
+                          <a:latin typeface="Arial" pitchFamily="34" charset="0"/>
+                          <a:ea typeface="Arial" pitchFamily="34" charset="-122"/>
+                          <a:cs typeface="Arial" pitchFamily="34" charset="-120"/>
+                        </a:rPr>
+                        <a:t>(b) fulfilment</a:t>
+                      </a:r>
+                      <a:endParaRPr lang="en-US" sz="1600" dirty="0">
+                        <a:latin typeface="Arial" charset="0"/>
+                        <a:ea typeface="Arial" charset="0"/>
+                        <a:cs typeface="Arial" charset="0"/>
+                      </a:endParaRPr>
+                    </a:p>
+                  </a:txBody>
+                  <a:tcPr marL="91440" marR="91440" marT="36576" marB="36576" anchor="ctr">
+                    <a:lnL w="9525" cap="flat" cmpd="sng" algn="ctr">
+                      <a:solidFill>
+                        <a:srgbClr val="C9D3DC"/>
+                      </a:solidFill>
+                      <a:prstDash val="solid"/>
+                      <a:round/>
+                      <a:headEnd type="none" w="med" len="med"/>
+                      <a:tailEnd type="none" w="med" len="med"/>
+                    </a:lnL>
+                    <a:lnR w="9525" cap="flat" cmpd="sng" algn="ctr">
+                      <a:solidFill>
+                        <a:srgbClr val="C9D3DC"/>
+                      </a:solidFill>
+                      <a:prstDash val="solid"/>
+                      <a:round/>
+                      <a:headEnd type="none" w="med" len="med"/>
+                      <a:tailEnd type="none" w="med" len="med"/>
+                    </a:lnR>
+                    <a:lnT w="9525" cap="flat" cmpd="sng" algn="ctr">
+                      <a:solidFill>
+                        <a:srgbClr val="C9D3DC"/>
+                      </a:solidFill>
+                      <a:prstDash val="solid"/>
+                      <a:round/>
+                      <a:headEnd type="none" w="med" len="med"/>
+                      <a:tailEnd type="none" w="med" len="med"/>
+                    </a:lnT>
+                    <a:lnB w="9525" cap="flat" cmpd="sng" algn="ctr">
+                      <a:solidFill>
+                        <a:srgbClr val="C9D3DC"/>
+                      </a:solidFill>
+                      <a:prstDash val="solid"/>
+                      <a:round/>
+                      <a:headEnd type="none" w="med" len="med"/>
+                      <a:tailEnd type="none" w="med" len="med"/>
+                    </a:lnB>
+                  </a:tcPr>
+                </a:tc>
+                <a:tc>
+                  <a:txBody>
+                    <a:bodyPr/>
+                    <a:lstStyle/>
+                    <a:p>
+                      <a:pPr algn="l" indent="0" marL="0">
+                        <a:buNone/>
+                      </a:pPr>
+                      <a:r>
+                        <a:rPr lang="en-US" sz="1600" dirty="0">
+                          <a:solidFill>
+                            <a:srgbClr val="1F2937"/>
+                          </a:solidFill>
+                          <a:latin typeface="Arial" pitchFamily="34" charset="0"/>
+                          <a:ea typeface="Arial" pitchFamily="34" charset="-122"/>
+                          <a:cs typeface="Arial" pitchFamily="34" charset="-120"/>
+                        </a:rPr>
+                        <a:t>Quan</a:t>
+                      </a:r>
+                      <a:endParaRPr lang="en-US" sz="1600" dirty="0">
+                        <a:latin typeface="Arial" charset="0"/>
+                        <a:ea typeface="Arial" charset="0"/>
+                        <a:cs typeface="Arial" charset="0"/>
+                      </a:endParaRPr>
+                    </a:p>
+                  </a:txBody>
+                  <a:tcPr marL="91440" marR="91440" marT="36576" marB="36576" anchor="ctr">
+                    <a:lnL w="9525" cap="flat" cmpd="sng" algn="ctr">
+                      <a:solidFill>
+                        <a:srgbClr val="C9D3DC"/>
+                      </a:solidFill>
+                      <a:prstDash val="solid"/>
+                      <a:round/>
+                      <a:headEnd type="none" w="med" len="med"/>
+                      <a:tailEnd type="none" w="med" len="med"/>
+                    </a:lnL>
+                    <a:lnR w="9525" cap="flat" cmpd="sng" algn="ctr">
+                      <a:solidFill>
+                        <a:srgbClr val="C9D3DC"/>
+                      </a:solidFill>
+                      <a:prstDash val="solid"/>
+                      <a:round/>
+                      <a:headEnd type="none" w="med" len="med"/>
+                      <a:tailEnd type="none" w="med" len="med"/>
+                    </a:lnR>
+                    <a:lnT w="9525" cap="flat" cmpd="sng" algn="ctr">
+                      <a:solidFill>
+                        <a:srgbClr val="C9D3DC"/>
+                      </a:solidFill>
+                      <a:prstDash val="solid"/>
+                      <a:round/>
+                      <a:headEnd type="none" w="med" len="med"/>
+                      <a:tailEnd type="none" w="med" len="med"/>
+                    </a:lnT>
+                    <a:lnB w="9525" cap="flat" cmpd="sng" algn="ctr">
+                      <a:solidFill>
+                        <a:srgbClr val="C9D3DC"/>
+                      </a:solidFill>
+                      <a:prstDash val="solid"/>
+                      <a:round/>
+                      <a:headEnd type="none" w="med" len="med"/>
+                      <a:tailEnd type="none" w="med" len="med"/>
+                    </a:lnB>
+                  </a:tcPr>
+                </a:tc>
+                <a:tc>
+                  <a:txBody>
+                    <a:bodyPr/>
+                    <a:lstStyle/>
+                    <a:p>
+                      <a:pPr algn="l" indent="0" marL="0">
+                        <a:buNone/>
+                      </a:pPr>
+                      <a:r>
+                        <a:rPr lang="en-US" sz="1600" dirty="0">
+                          <a:solidFill>
+                            <a:srgbClr val="1F2937"/>
+                          </a:solidFill>
+                          <a:latin typeface="Arial" pitchFamily="34" charset="0"/>
+                          <a:ea typeface="Arial" pitchFamily="34" charset="-122"/>
+                          <a:cs typeface="Arial" pitchFamily="34" charset="-120"/>
+                        </a:rPr>
+                        <a:t>uses Order</a:t>
+                      </a:r>
+                      <a:endParaRPr lang="en-US" sz="1600" dirty="0">
+                        <a:latin typeface="Arial" charset="0"/>
+                        <a:ea typeface="Arial" charset="0"/>
+                        <a:cs typeface="Arial" charset="0"/>
+                      </a:endParaRPr>
+                    </a:p>
+                  </a:txBody>
+                  <a:tcPr marL="91440" marR="91440" marT="36576" marB="36576" anchor="ctr">
+                    <a:lnL w="9525" cap="flat" cmpd="sng" algn="ctr">
+                      <a:solidFill>
+                        <a:srgbClr val="C9D3DC"/>
+                      </a:solidFill>
+                      <a:prstDash val="solid"/>
+                      <a:round/>
+                      <a:headEnd type="none" w="med" len="med"/>
+                      <a:tailEnd type="none" w="med" len="med"/>
+                    </a:lnL>
+                    <a:lnR w="9525" cap="flat" cmpd="sng" algn="ctr">
+                      <a:solidFill>
+                        <a:srgbClr val="C9D3DC"/>
+                      </a:solidFill>
+                      <a:prstDash val="solid"/>
+                      <a:round/>
+                      <a:headEnd type="none" w="med" len="med"/>
+                      <a:tailEnd type="none" w="med" len="med"/>
+                    </a:lnR>
+                    <a:lnT w="9525" cap="flat" cmpd="sng" algn="ctr">
+                      <a:solidFill>
+                        <a:srgbClr val="C9D3DC"/>
+                      </a:solidFill>
+                      <a:prstDash val="solid"/>
+                      <a:round/>
+                      <a:headEnd type="none" w="med" len="med"/>
+                      <a:tailEnd type="none" w="med" len="med"/>
+                    </a:lnT>
+                    <a:lnB w="9525" cap="flat" cmpd="sng" algn="ctr">
+                      <a:solidFill>
+                        <a:srgbClr val="C9D3DC"/>
+                      </a:solidFill>
+                      <a:prstDash val="solid"/>
+                      <a:round/>
+                      <a:headEnd type="none" w="med" len="med"/>
+                      <a:tailEnd type="none" w="med" len="med"/>
+                    </a:lnB>
+                  </a:tcPr>
+                </a:tc>
+              </a:tr>
+              <a:tr h="393192">
+                <a:tc>
+                  <a:txBody>
+                    <a:bodyPr/>
+                    <a:lstStyle/>
+                    <a:p>
+                      <a:pPr algn="l" indent="0" marL="0">
+                        <a:buNone/>
+                      </a:pPr>
+                      <a:r>
+                        <a:rPr lang="en-US" sz="1600" b="1" dirty="0">
+                          <a:solidFill>
+                            <a:srgbClr val="004387"/>
+                          </a:solidFill>
+                          <a:latin typeface="Arial" pitchFamily="34" charset="0"/>
+                          <a:ea typeface="Arial" pitchFamily="34" charset="-122"/>
+                          <a:cs typeface="Arial" pitchFamily="34" charset="-120"/>
+                        </a:rPr>
+                        <a:t>UC-06</a:t>
+                      </a:r>
+                      <a:endParaRPr lang="en-US" sz="1600" dirty="0">
+                        <a:latin typeface="Arial" charset="0"/>
+                        <a:ea typeface="Arial" charset="0"/>
+                        <a:cs typeface="Arial" charset="0"/>
+                      </a:endParaRPr>
+                    </a:p>
+                  </a:txBody>
+                  <a:tcPr marL="91440" marR="91440" marT="36576" marB="36576" anchor="ctr">
+                    <a:lnL w="9525" cap="flat" cmpd="sng" algn="ctr">
+                      <a:solidFill>
+                        <a:srgbClr val="C9D3DC"/>
+                      </a:solidFill>
+                      <a:prstDash val="solid"/>
+                      <a:round/>
+                      <a:headEnd type="none" w="med" len="med"/>
+                      <a:tailEnd type="none" w="med" len="med"/>
+                    </a:lnL>
+                    <a:lnR w="9525" cap="flat" cmpd="sng" algn="ctr">
+                      <a:solidFill>
+                        <a:srgbClr val="C9D3DC"/>
+                      </a:solidFill>
+                      <a:prstDash val="solid"/>
+                      <a:round/>
+                      <a:headEnd type="none" w="med" len="med"/>
+                      <a:tailEnd type="none" w="med" len="med"/>
+                    </a:lnR>
+                    <a:lnT w="9525" cap="flat" cmpd="sng" algn="ctr">
+                      <a:solidFill>
+                        <a:srgbClr val="C9D3DC"/>
+                      </a:solidFill>
+                      <a:prstDash val="solid"/>
+                      <a:round/>
+                      <a:headEnd type="none" w="med" len="med"/>
+                      <a:tailEnd type="none" w="med" len="med"/>
+                    </a:lnT>
+                    <a:lnB w="9525" cap="flat" cmpd="sng" algn="ctr">
+                      <a:solidFill>
+                        <a:srgbClr val="C9D3DC"/>
+                      </a:solidFill>
+                      <a:prstDash val="solid"/>
+                      <a:round/>
+                      <a:headEnd type="none" w="med" len="med"/>
+                      <a:tailEnd type="none" w="med" len="med"/>
+                    </a:lnB>
+                  </a:tcPr>
+                </a:tc>
+                <a:tc>
+                  <a:txBody>
+                    <a:bodyPr/>
+                    <a:lstStyle/>
+                    <a:p>
+                      <a:pPr algn="l" indent="0" marL="0">
+                        <a:buNone/>
+                      </a:pPr>
+                      <a:r>
+                        <a:rPr lang="en-US" sz="1600" dirty="0">
+                          <a:solidFill>
+                            <a:srgbClr val="1F2937"/>
+                          </a:solidFill>
+                          <a:latin typeface="Arial" pitchFamily="34" charset="0"/>
+                          <a:ea typeface="Arial" pitchFamily="34" charset="-122"/>
+                          <a:cs typeface="Arial" pitchFamily="34" charset="-120"/>
+                        </a:rPr>
+                        <a:t>Manage brands, menu items (#14)</a:t>
+                      </a:r>
+                      <a:endParaRPr lang="en-US" sz="1600" dirty="0">
+                        <a:latin typeface="Arial" charset="0"/>
+                        <a:ea typeface="Arial" charset="0"/>
+                        <a:cs typeface="Arial" charset="0"/>
+                      </a:endParaRPr>
+                    </a:p>
+                  </a:txBody>
+                  <a:tcPr marL="91440" marR="91440" marT="36576" marB="36576" anchor="ctr">
+                    <a:lnL w="9525" cap="flat" cmpd="sng" algn="ctr">
+                      <a:solidFill>
+                        <a:srgbClr val="C9D3DC"/>
+                      </a:solidFill>
+                      <a:prstDash val="solid"/>
+                      <a:round/>
+                      <a:headEnd type="none" w="med" len="med"/>
+                      <a:tailEnd type="none" w="med" len="med"/>
+                    </a:lnL>
+                    <a:lnR w="9525" cap="flat" cmpd="sng" algn="ctr">
+                      <a:solidFill>
+                        <a:srgbClr val="C9D3DC"/>
+                      </a:solidFill>
+                      <a:prstDash val="solid"/>
+                      <a:round/>
+                      <a:headEnd type="none" w="med" len="med"/>
+                      <a:tailEnd type="none" w="med" len="med"/>
+                    </a:lnR>
+                    <a:lnT w="9525" cap="flat" cmpd="sng" algn="ctr">
+                      <a:solidFill>
+                        <a:srgbClr val="C9D3DC"/>
+                      </a:solidFill>
+                      <a:prstDash val="solid"/>
+                      <a:round/>
+                      <a:headEnd type="none" w="med" len="med"/>
+                      <a:tailEnd type="none" w="med" len="med"/>
+                    </a:lnT>
+                    <a:lnB w="9525" cap="flat" cmpd="sng" algn="ctr">
+                      <a:solidFill>
+                        <a:srgbClr val="C9D3DC"/>
+                      </a:solidFill>
+                      <a:prstDash val="solid"/>
+                      <a:round/>
+                      <a:headEnd type="none" w="med" len="med"/>
+                      <a:tailEnd type="none" w="med" len="med"/>
+                    </a:lnB>
+                  </a:tcPr>
+                </a:tc>
+                <a:tc>
+                  <a:txBody>
+                    <a:bodyPr/>
+                    <a:lstStyle/>
+                    <a:p>
+                      <a:pPr algn="l" indent="0" marL="0">
+                        <a:buNone/>
+                      </a:pPr>
+                      <a:r>
+                        <a:rPr lang="en-US" sz="1600" dirty="0">
+                          <a:solidFill>
+                            <a:srgbClr val="1F2937"/>
+                          </a:solidFill>
+                          <a:latin typeface="Arial" pitchFamily="34" charset="0"/>
+                          <a:ea typeface="Arial" pitchFamily="34" charset="-122"/>
+                          <a:cs typeface="Arial" pitchFamily="34" charset="-120"/>
+                        </a:rPr>
+                        <a:t>Admin</a:t>
+                      </a:r>
+                      <a:endParaRPr lang="en-US" sz="1600" dirty="0">
+                        <a:latin typeface="Arial" charset="0"/>
+                        <a:ea typeface="Arial" charset="0"/>
+                        <a:cs typeface="Arial" charset="0"/>
+                      </a:endParaRPr>
+                    </a:p>
+                  </a:txBody>
+                  <a:tcPr marL="91440" marR="91440" marT="36576" marB="36576" anchor="ctr">
+                    <a:lnL w="9525" cap="flat" cmpd="sng" algn="ctr">
+                      <a:solidFill>
+                        <a:srgbClr val="C9D3DC"/>
+                      </a:solidFill>
+                      <a:prstDash val="solid"/>
+                      <a:round/>
+                      <a:headEnd type="none" w="med" len="med"/>
+                      <a:tailEnd type="none" w="med" len="med"/>
+                    </a:lnL>
+                    <a:lnR w="9525" cap="flat" cmpd="sng" algn="ctr">
+                      <a:solidFill>
+                        <a:srgbClr val="C9D3DC"/>
+                      </a:solidFill>
+                      <a:prstDash val="solid"/>
+                      <a:round/>
+                      <a:headEnd type="none" w="med" len="med"/>
+                      <a:tailEnd type="none" w="med" len="med"/>
+                    </a:lnR>
+                    <a:lnT w="9525" cap="flat" cmpd="sng" algn="ctr">
+                      <a:solidFill>
+                        <a:srgbClr val="C9D3DC"/>
+                      </a:solidFill>
+                      <a:prstDash val="solid"/>
+                      <a:round/>
+                      <a:headEnd type="none" w="med" len="med"/>
+                      <a:tailEnd type="none" w="med" len="med"/>
+                    </a:lnT>
+                    <a:lnB w="9525" cap="flat" cmpd="sng" algn="ctr">
+                      <a:solidFill>
+                        <a:srgbClr val="C9D3DC"/>
+                      </a:solidFill>
+                      <a:prstDash val="solid"/>
+                      <a:round/>
+                      <a:headEnd type="none" w="med" len="med"/>
+                      <a:tailEnd type="none" w="med" len="med"/>
+                    </a:lnB>
+                  </a:tcPr>
+                </a:tc>
+                <a:tc>
+                  <a:txBody>
+                    <a:bodyPr/>
+                    <a:lstStyle/>
+                    <a:p>
+                      <a:pPr algn="l" indent="0" marL="0">
+                        <a:buNone/>
+                      </a:pPr>
+                      <a:r>
+                        <a:rPr lang="en-US" sz="1600" dirty="0">
+                          <a:solidFill>
+                            <a:srgbClr val="1F2937"/>
+                          </a:solidFill>
+                          <a:latin typeface="Arial" pitchFamily="34" charset="0"/>
+                          <a:ea typeface="Arial" pitchFamily="34" charset="-122"/>
+                          <a:cs typeface="Arial" pitchFamily="34" charset="-120"/>
+                        </a:rPr>
+                        <a:t>(c) full CRUD</a:t>
+                      </a:r>
+                      <a:endParaRPr lang="en-US" sz="1600" dirty="0">
+                        <a:latin typeface="Arial" charset="0"/>
+                        <a:ea typeface="Arial" charset="0"/>
+                        <a:cs typeface="Arial" charset="0"/>
+                      </a:endParaRPr>
+                    </a:p>
+                  </a:txBody>
+                  <a:tcPr marL="91440" marR="91440" marT="36576" marB="36576" anchor="ctr">
+                    <a:lnL w="9525" cap="flat" cmpd="sng" algn="ctr">
+                      <a:solidFill>
+                        <a:srgbClr val="C9D3DC"/>
+                      </a:solidFill>
+                      <a:prstDash val="solid"/>
+                      <a:round/>
+                      <a:headEnd type="none" w="med" len="med"/>
+                      <a:tailEnd type="none" w="med" len="med"/>
+                    </a:lnL>
+                    <a:lnR w="9525" cap="flat" cmpd="sng" algn="ctr">
+                      <a:solidFill>
+                        <a:srgbClr val="C9D3DC"/>
+                      </a:solidFill>
+                      <a:prstDash val="solid"/>
+                      <a:round/>
+                      <a:headEnd type="none" w="med" len="med"/>
+                      <a:tailEnd type="none" w="med" len="med"/>
+                    </a:lnR>
+                    <a:lnT w="9525" cap="flat" cmpd="sng" algn="ctr">
+                      <a:solidFill>
+                        <a:srgbClr val="C9D3DC"/>
+                      </a:solidFill>
+                      <a:prstDash val="solid"/>
+                      <a:round/>
+                      <a:headEnd type="none" w="med" len="med"/>
+                      <a:tailEnd type="none" w="med" len="med"/>
+                    </a:lnT>
+                    <a:lnB w="9525" cap="flat" cmpd="sng" algn="ctr">
+                      <a:solidFill>
+                        <a:srgbClr val="C9D3DC"/>
+                      </a:solidFill>
+                      <a:prstDash val="solid"/>
+                      <a:round/>
+                      <a:headEnd type="none" w="med" len="med"/>
+                      <a:tailEnd type="none" w="med" len="med"/>
+                    </a:lnB>
+                  </a:tcPr>
+                </a:tc>
+                <a:tc>
+                  <a:txBody>
+                    <a:bodyPr/>
+                    <a:lstStyle/>
+                    <a:p>
+                      <a:pPr algn="l" indent="0" marL="0">
+                        <a:buNone/>
+                      </a:pPr>
+                      <a:r>
+                        <a:rPr lang="en-US" sz="1600" dirty="0">
+                          <a:solidFill>
+                            <a:srgbClr val="1F2937"/>
+                          </a:solidFill>
+                          <a:latin typeface="Arial" pitchFamily="34" charset="0"/>
+                          <a:ea typeface="Arial" pitchFamily="34" charset="-122"/>
+                          <a:cs typeface="Arial" pitchFamily="34" charset="-120"/>
+                        </a:rPr>
+                        <a:t>Quan</a:t>
+                      </a:r>
+                      <a:endParaRPr lang="en-US" sz="1600" dirty="0">
+                        <a:latin typeface="Arial" charset="0"/>
+                        <a:ea typeface="Arial" charset="0"/>
+                        <a:cs typeface="Arial" charset="0"/>
+                      </a:endParaRPr>
+                    </a:p>
+                  </a:txBody>
+                  <a:tcPr marL="91440" marR="91440" marT="36576" marB="36576" anchor="ctr">
+                    <a:lnL w="9525" cap="flat" cmpd="sng" algn="ctr">
+                      <a:solidFill>
+                        <a:srgbClr val="C9D3DC"/>
+                      </a:solidFill>
+                      <a:prstDash val="solid"/>
+                      <a:round/>
+                      <a:headEnd type="none" w="med" len="med"/>
+                      <a:tailEnd type="none" w="med" len="med"/>
+                    </a:lnL>
+                    <a:lnR w="9525" cap="flat" cmpd="sng" algn="ctr">
+                      <a:solidFill>
+                        <a:srgbClr val="C9D3DC"/>
+                      </a:solidFill>
+                      <a:prstDash val="solid"/>
+                      <a:round/>
+                      <a:headEnd type="none" w="med" len="med"/>
+                      <a:tailEnd type="none" w="med" len="med"/>
+                    </a:lnR>
+                    <a:lnT w="9525" cap="flat" cmpd="sng" algn="ctr">
+                      <a:solidFill>
+                        <a:srgbClr val="C9D3DC"/>
+                      </a:solidFill>
+                      <a:prstDash val="solid"/>
+                      <a:round/>
+                      <a:headEnd type="none" w="med" len="med"/>
+                      <a:tailEnd type="none" w="med" len="med"/>
+                    </a:lnT>
+                    <a:lnB w="9525" cap="flat" cmpd="sng" algn="ctr">
+                      <a:solidFill>
+                        <a:srgbClr val="C9D3DC"/>
+                      </a:solidFill>
+                      <a:prstDash val="solid"/>
+                      <a:round/>
+                      <a:headEnd type="none" w="med" len="med"/>
+                      <a:tailEnd type="none" w="med" len="med"/>
+                    </a:lnB>
+                  </a:tcPr>
+                </a:tc>
+                <a:tc>
+                  <a:txBody>
+                    <a:bodyPr/>
+                    <a:lstStyle/>
+                    <a:p>
+                      <a:pPr algn="l" indent="0" marL="0">
+                        <a:buNone/>
+                      </a:pPr>
+                      <a:r>
+                        <a:rPr lang="en-US" sz="1600" dirty="0">
+                          <a:solidFill>
+                            <a:srgbClr val="1F2937"/>
+                          </a:solidFill>
+                          <a:latin typeface="Arial" pitchFamily="34" charset="0"/>
+                          <a:ea typeface="Arial" pitchFamily="34" charset="-122"/>
+                          <a:cs typeface="Arial" pitchFamily="34" charset="-120"/>
+                        </a:rPr>
+                        <a:t>MenuItem</a:t>
+                      </a:r>
+                      <a:endParaRPr lang="en-US" sz="1600" dirty="0">
+                        <a:latin typeface="Arial" charset="0"/>
+                        <a:ea typeface="Arial" charset="0"/>
+                        <a:cs typeface="Arial" charset="0"/>
+                      </a:endParaRPr>
+                    </a:p>
+                  </a:txBody>
+                  <a:tcPr marL="91440" marR="91440" marT="36576" marB="36576" anchor="ctr">
+                    <a:lnL w="9525" cap="flat" cmpd="sng" algn="ctr">
+                      <a:solidFill>
+                        <a:srgbClr val="C9D3DC"/>
+                      </a:solidFill>
+                      <a:prstDash val="solid"/>
+                      <a:round/>
+                      <a:headEnd type="none" w="med" len="med"/>
+                      <a:tailEnd type="none" w="med" len="med"/>
+                    </a:lnL>
+                    <a:lnR w="9525" cap="flat" cmpd="sng" algn="ctr">
+                      <a:solidFill>
+                        <a:srgbClr val="C9D3DC"/>
+                      </a:solidFill>
+                      <a:prstDash val="solid"/>
+                      <a:round/>
+                      <a:headEnd type="none" w="med" len="med"/>
+                      <a:tailEnd type="none" w="med" len="med"/>
+                    </a:lnR>
+                    <a:lnT w="9525" cap="flat" cmpd="sng" algn="ctr">
+                      <a:solidFill>
+                        <a:srgbClr val="C9D3DC"/>
+                      </a:solidFill>
+                      <a:prstDash val="solid"/>
+                      <a:round/>
+                      <a:headEnd type="none" w="med" len="med"/>
+                      <a:tailEnd type="none" w="med" len="med"/>
+                    </a:lnT>
+                    <a:lnB w="9525" cap="flat" cmpd="sng" algn="ctr">
+                      <a:solidFill>
+                        <a:srgbClr val="C9D3DC"/>
+                      </a:solidFill>
+                      <a:prstDash val="solid"/>
+                      <a:round/>
+                      <a:headEnd type="none" w="med" len="med"/>
+                      <a:tailEnd type="none" w="med" len="med"/>
+                    </a:lnB>
+                  </a:tcPr>
+                </a:tc>
+              </a:tr>
             </a:tbl>
           </a:graphicData>
         </a:graphic>
       </p:graphicFrame>
       <p:sp>
         <p:nvSpPr>
-          <p:cNvPr id="5" name="Card"/>
+          <p:cNvPr id="4" name="Card"/>
           <p:cNvSpPr/>
           <p:nvPr/>
         </p:nvSpPr>
         <p:spPr>
           <a:xfrm>
-            <a:off x="457200" y="3931920"/>
-            <a:ext cx="11277295" cy="411480"/>
+            <a:off x="457200" y="4160520"/>
+            <a:ext cx="11277295" cy="457200"/>
+          </a:xfrm>
+          <a:prstGeom prst="rect">
+            <a:avLst/>
+          </a:prstGeom>
+          <a:solidFill>
+            <a:srgbClr val="FBE9E7"/>
+          </a:solidFill>
+          <a:ln/>
+        </p:spPr>
+      </p:sp>
+      <p:sp>
+        <p:nvSpPr>
+          <p:cNvPr id="5" name="Text 2"/>
+          <p:cNvSpPr txBox="1"/>
+          <p:nvPr/>
+        </p:nvSpPr>
+        <p:spPr>
+          <a:xfrm>
+            <a:off x="585216" y="4160520"/>
+            <a:ext cx="11021263" cy="457200"/>
+          </a:xfrm>
+          <a:prstGeom prst="rect">
+            <a:avLst/>
+          </a:prstGeom>
+          <a:noFill/>
+          <a:ln/>
+        </p:spPr>
+        <p:txBody>
+          <a:bodyPr wrap="square" lIns="0" tIns="0" rIns="0" bIns="0" rtlCol="0" anchor="ctr"/>
+          <a:lstStyle/>
+          <a:p>
+            <a:pPr algn="l" indent="0" marL="0">
+              <a:buNone/>
+            </a:pPr>
+            <a:r>
+              <a:rPr lang="en-US" sz="1800" b="1" dirty="0">
+                <a:solidFill>
+                  <a:srgbClr val="C95B55"/>
+                </a:solidFill>
+                <a:latin typeface="Arial" pitchFamily="34" charset="0"/>
+                <a:ea typeface="Arial" pitchFamily="34" charset="-122"/>
+                <a:cs typeface="Arial" pitchFamily="34" charset="-120"/>
+              </a:rPr>
+              <a:t>Built today (Iteration 1)   </a:t>
+            </a:r>
+            <a:pPr algn="l" indent="0" marL="0">
+              <a:buNone/>
+            </a:pPr>
+            <a:r>
+              <a:rPr lang="en-US" sz="1800" dirty="0">
+                <a:solidFill>
+                  <a:srgbClr val="1F2937"/>
+                </a:solidFill>
+                <a:latin typeface="Arial" pitchFamily="34" charset="0"/>
+                <a:ea typeface="Arial" pitchFamily="34" charset="-122"/>
+                <a:cs typeface="Arial" pitchFamily="34" charset="-120"/>
+              </a:rPr>
+              <a:t>UC-01 subset: one persisted COD order</a:t>
+            </a:r>
+            <a:endParaRPr lang="en-US" sz="1800" dirty="0"/>
+          </a:p>
+        </p:txBody>
+      </p:sp>
+      <p:sp>
+        <p:nvSpPr>
+          <p:cNvPr id="6" name="Card"/>
+          <p:cNvSpPr/>
+          <p:nvPr/>
+        </p:nvSpPr>
+        <p:spPr>
+          <a:xfrm>
+            <a:off x="457200" y="4690872"/>
+            <a:ext cx="11277295" cy="457200"/>
           </a:xfrm>
           <a:prstGeom prst="rect">
             <a:avLst/>
@@ -21159,14 +21606,14 @@
       </p:sp>
       <p:sp>
         <p:nvSpPr>
-          <p:cNvPr id="6" name="Text 3"/>
+          <p:cNvPr id="7" name="Text 4"/>
           <p:cNvSpPr txBox="1"/>
           <p:nvPr/>
         </p:nvSpPr>
         <p:spPr>
           <a:xfrm>
-            <a:off x="585216" y="3931920"/>
-            <a:ext cx="11021263" cy="411480"/>
+            <a:off x="585216" y="4690872"/>
+            <a:ext cx="11021263" cy="457200"/>
           </a:xfrm>
           <a:prstGeom prst="rect">
             <a:avLst/>
@@ -21190,7 +21637,7 @@
                 <a:ea typeface="Arial" pitchFamily="34" charset="-122"/>
                 <a:cs typeface="Arial" pitchFamily="34" charset="-120"/>
               </a:rPr>
-              <a:t>1 Built   </a:t>
+              <a:t>Planned build for Part 2   </a:t>
             </a:r>
             <a:pPr algn="l" indent="0" marL="0">
               <a:buNone/>
@@ -21204,7 +21651,7 @@
                 <a:ea typeface="Arial" pitchFamily="34" charset="-122"/>
                 <a:cs typeface="Arial" pitchFamily="34" charset="-120"/>
               </a:rPr>
-              <a:t>UC-01 to UC-04 in one application</a:t>
+              <a:t>UC-01 to UC-06 in one application</a:t>
             </a:r>
             <a:endParaRPr lang="en-US" sz="1800" dirty="0"/>
           </a:p>
@@ -21212,14 +21659,14 @@
       </p:sp>
       <p:sp>
         <p:nvSpPr>
-          <p:cNvPr id="7" name="Card"/>
+          <p:cNvPr id="8" name="Card"/>
           <p:cNvSpPr/>
           <p:nvPr/>
         </p:nvSpPr>
         <p:spPr>
           <a:xfrm>
-            <a:off x="457200" y="4389120"/>
-            <a:ext cx="11277295" cy="411480"/>
+            <a:off x="457200" y="5221224"/>
+            <a:ext cx="11277295" cy="457200"/>
           </a:xfrm>
           <a:prstGeom prst="rect">
             <a:avLst/>
@@ -21232,14 +21679,14 @@
       </p:sp>
       <p:sp>
         <p:nvSpPr>
-          <p:cNvPr id="8" name="Text 5"/>
+          <p:cNvPr id="9" name="Text 6"/>
           <p:cNvSpPr txBox="1"/>
           <p:nvPr/>
         </p:nvSpPr>
         <p:spPr>
           <a:xfrm>
-            <a:off x="585216" y="4389120"/>
-            <a:ext cx="11021263" cy="411480"/>
+            <a:off x="585216" y="5221224"/>
+            <a:ext cx="11021263" cy="457200"/>
           </a:xfrm>
           <a:prstGeom prst="rect">
             <a:avLst/>
@@ -21263,7 +21710,7 @@
                 <a:ea typeface="Arial" pitchFamily="34" charset="-122"/>
                 <a:cs typeface="Arial" pitchFamily="34" charset="-120"/>
               </a:rPr>
-              <a:t>2 Minimum support   </a:t>
+              <a:t>Analysed only   </a:t>
             </a:r>
             <a:pPr algn="l" indent="0" marL="0">
               <a:buNone/>
@@ -21277,7 +21724,7 @@
                 <a:ea typeface="Arial" pitchFamily="34" charset="-122"/>
                 <a:cs typeface="Arial" pitchFamily="34" charset="-120"/>
               </a:rPr>
-              <a:t>Kitchen board; login, seeded users</a:t>
+              <a:t>Cancel, vouchers, accounts, order tracking</a:t>
             </a:r>
             <a:endParaRPr lang="en-US" sz="1800" dirty="0"/>
           </a:p>
@@ -21285,160 +21732,14 @@
       </p:sp>
       <p:sp>
         <p:nvSpPr>
-          <p:cNvPr id="9" name="Card"/>
+          <p:cNvPr id="10" name="Card"/>
           <p:cNvSpPr/>
           <p:nvPr/>
         </p:nvSpPr>
         <p:spPr>
           <a:xfrm>
-            <a:off x="457200" y="4846320"/>
-            <a:ext cx="11277295" cy="411480"/>
-          </a:xfrm>
-          <a:prstGeom prst="rect">
-            <a:avLst/>
-          </a:prstGeom>
-          <a:solidFill>
-            <a:srgbClr val="E3ECF3"/>
-          </a:solidFill>
-          <a:ln/>
-        </p:spPr>
-      </p:sp>
-      <p:sp>
-        <p:nvSpPr>
-          <p:cNvPr id="10" name="Text 7"/>
-          <p:cNvSpPr txBox="1"/>
-          <p:nvPr/>
-        </p:nvSpPr>
-        <p:spPr>
-          <a:xfrm>
-            <a:off x="585216" y="4846320"/>
-            <a:ext cx="11021263" cy="411480"/>
-          </a:xfrm>
-          <a:prstGeom prst="rect">
-            <a:avLst/>
-          </a:prstGeom>
-          <a:noFill/>
-          <a:ln/>
-        </p:spPr>
-        <p:txBody>
-          <a:bodyPr wrap="square" lIns="0" tIns="0" rIns="0" bIns="0" rtlCol="0" anchor="ctr"/>
-          <a:lstStyle/>
-          <a:p>
-            <a:pPr algn="l" indent="0" marL="0">
-              <a:buNone/>
-            </a:pPr>
-            <a:r>
-              <a:rPr lang="en-US" sz="1800" b="1" dirty="0">
-                <a:solidFill>
-                  <a:srgbClr val="004387"/>
-                </a:solidFill>
-                <a:latin typeface="Arial" pitchFamily="34" charset="0"/>
-                <a:ea typeface="Arial" pitchFamily="34" charset="-122"/>
-                <a:cs typeface="Arial" pitchFamily="34" charset="-120"/>
-              </a:rPr>
-              <a:t>3 Analysed only   </a:t>
-            </a:r>
-            <a:pPr algn="l" indent="0" marL="0">
-              <a:buNone/>
-            </a:pPr>
-            <a:r>
-              <a:rPr lang="en-US" sz="1800" dirty="0">
-                <a:solidFill>
-                  <a:srgbClr val="1F2937"/>
-                </a:solidFill>
-                <a:latin typeface="Arial" pitchFamily="34" charset="0"/>
-                <a:ea typeface="Arial" pitchFamily="34" charset="-122"/>
-                <a:cs typeface="Arial" pitchFamily="34" charset="-120"/>
-              </a:rPr>
-              <a:t>Supporting use cases incl. cancel (A-08, L1)</a:t>
-            </a:r>
-            <a:endParaRPr lang="en-US" sz="1800" dirty="0"/>
-          </a:p>
-        </p:txBody>
-      </p:sp>
-      <p:sp>
-        <p:nvSpPr>
-          <p:cNvPr id="11" name="Card"/>
-          <p:cNvSpPr/>
-          <p:nvPr/>
-        </p:nvSpPr>
-        <p:spPr>
-          <a:xfrm>
-            <a:off x="457200" y="5303520"/>
-            <a:ext cx="11277295" cy="411480"/>
-          </a:xfrm>
-          <a:prstGeom prst="rect">
-            <a:avLst/>
-          </a:prstGeom>
-          <a:solidFill>
-            <a:srgbClr val="E3ECF3"/>
-          </a:solidFill>
-          <a:ln/>
-        </p:spPr>
-      </p:sp>
-      <p:sp>
-        <p:nvSpPr>
-          <p:cNvPr id="12" name="Text 9"/>
-          <p:cNvSpPr txBox="1"/>
-          <p:nvPr/>
-        </p:nvSpPr>
-        <p:spPr>
-          <a:xfrm>
-            <a:off x="585216" y="5303520"/>
-            <a:ext cx="11021263" cy="411480"/>
-          </a:xfrm>
-          <a:prstGeom prst="rect">
-            <a:avLst/>
-          </a:prstGeom>
-          <a:noFill/>
-          <a:ln/>
-        </p:spPr>
-        <p:txBody>
-          <a:bodyPr wrap="square" lIns="0" tIns="0" rIns="0" bIns="0" rtlCol="0" anchor="ctr"/>
-          <a:lstStyle/>
-          <a:p>
-            <a:pPr algn="l" indent="0" marL="0">
-              <a:buNone/>
-            </a:pPr>
-            <a:r>
-              <a:rPr lang="en-US" sz="1800" b="1" dirty="0">
-                <a:solidFill>
-                  <a:srgbClr val="004387"/>
-                </a:solidFill>
-                <a:latin typeface="Arial" pitchFamily="34" charset="0"/>
-                <a:ea typeface="Arial" pitchFamily="34" charset="-122"/>
-                <a:cs typeface="Arial" pitchFamily="34" charset="-120"/>
-              </a:rPr>
-              <a:t>4 Deferred   </a:t>
-            </a:r>
-            <a:pPr algn="l" indent="0" marL="0">
-              <a:buNone/>
-            </a:pPr>
-            <a:r>
-              <a:rPr lang="en-US" sz="1800" dirty="0">
-                <a:solidFill>
-                  <a:srgbClr val="1F2937"/>
-                </a:solidFill>
-                <a:latin typeface="Arial" pitchFamily="34" charset="0"/>
-                <a:ea typeface="Arial" pitchFamily="34" charset="-122"/>
-                <a:cs typeface="Arial" pitchFamily="34" charset="-120"/>
-              </a:rPr>
-              <a:t>Complaint, refund, rating (A-09, L3)</a:t>
-            </a:r>
-            <a:endParaRPr lang="en-US" sz="1800" dirty="0"/>
-          </a:p>
-        </p:txBody>
-      </p:sp>
-      <p:sp>
-        <p:nvSpPr>
-          <p:cNvPr id="13" name="Card"/>
-          <p:cNvSpPr/>
-          <p:nvPr/>
-        </p:nvSpPr>
-        <p:spPr>
-          <a:xfrm>
-            <a:off x="457200" y="5760720"/>
-            <a:ext cx="11277295" cy="411480"/>
+            <a:off x="457200" y="5751576"/>
+            <a:ext cx="11277295" cy="457200"/>
           </a:xfrm>
           <a:prstGeom prst="rect">
             <a:avLst/>
@@ -21451,14 +21752,14 @@
       </p:sp>
       <p:sp>
         <p:nvSpPr>
-          <p:cNvPr id="14" name="Text 11"/>
+          <p:cNvPr id="11" name="Text 8"/>
           <p:cNvSpPr txBox="1"/>
           <p:nvPr/>
         </p:nvSpPr>
         <p:spPr>
           <a:xfrm>
-            <a:off x="585216" y="5760720"/>
-            <a:ext cx="11021263" cy="411480"/>
+            <a:off x="585216" y="5751576"/>
+            <a:ext cx="11021263" cy="457200"/>
           </a:xfrm>
           <a:prstGeom prst="rect">
             <a:avLst/>
@@ -21482,7 +21783,7 @@
                 <a:ea typeface="Arial" pitchFamily="34" charset="-122"/>
                 <a:cs typeface="Arial" pitchFamily="34" charset="-120"/>
               </a:rPr>
-              <a:t>5 Future   </a:t>
+              <a:t>Deferred   </a:t>
             </a:r>
             <a:pPr algn="l" indent="0" marL="0">
               <a:buNone/>
@@ -21496,7 +21797,7 @@
                 <a:ea typeface="Arial" pitchFamily="34" charset="-122"/>
                 <a:cs typeface="Arial" pitchFamily="34" charset="-120"/>
               </a:rPr>
-              <a:t>Loyalty, subscriptions, group orders</a:t>
+              <a:t>Complaint, refund payout, rating</a:t>
             </a:r>
             <a:endParaRPr lang="en-US" sz="1800" dirty="0"/>
           </a:p>

</xml_diff>

<commit_message>
Update Part 1 package: second machine passed (Mac), refund owed vs payout, CRUD scenario by person, shorter script
Co-Authored-By: Claude Opus 5.5 <noreply@anthropic.com>
</commit_message>
<xml_diff>
--- a/docs/part1/Team02_Proposal_Slides_for_SaigonBite.pptx
+++ b/docs/part1/Team02_Proposal_Slides_for_SaigonBite.pptx
@@ -516,8 +516,8 @@
           <a:p>
             <a:r>
               <a:rPr lang="en-US" dirty="0"/>
-              <a:t>Speaker: Dat · Dat 1 of 6 (with slide 2) · Time: 0:00-0:20 (43 words)
-Good morning. We are Team 02. I am Dat, and with me are Quan L. and Quan. Our project is SaigonBite, a delivery platform for cloud kitchens. I want to start with one lunch order, because that one order explains the whole project.
+              <a:t>Speaker: Dat · Dat 1 of 6 (with slide 2) · Time: 0:00-0:19 (41 words)
+Good morning. We are Team 02. I am Dat, and with me are Quan L. and Quan. Our project is SaigonBite, a delivery platform for cloud kitchens. Let me start with one lunch order, because that order explains the whole project.
 Cue: Click: slide 2.</a:t>
             </a:r>
             <a:endParaRPr lang="en-US" dirty="0"/>
@@ -606,8 +606,8 @@
           <a:p>
             <a:r>
               <a:rPr lang="en-US" dirty="0"/>
-              <a:t>Speaker: Quan · Quan 1 of 2 · Time: 5:00-5:38 (83 words)
-Thank you. The case is incomplete on purpose: capacity limits, fees and payment rules will come from the client later. So we work in short iterations. Each one analyses, designs, builds and tests a thin slice, and then we review it together. We take the riskiest rules first: capacity in Iteration 2, payment in Iteration 3. The stack is plain on purpose: Python and Flask, three layers, hand-written SQL on SQLite, and pytest, so every layer stays visible in the Part 2 report.
+              <a:t>Speaker: Quan · Quan 1 of 2 · Time: 4:42-5:15 (71 words)
+Thank you. The case is incomplete on purpose: capacity limits, fees and payment rules come from the client later. So we work in short iterations. Each one analyses, designs, builds and tests a thin slice, and then we review it together. The riskiest rules come first: capacity in Iteration 2, payment in Iteration 3. The stack is plain on purpose: Python and Flask, three layers, hand-written SQL on SQLite, and pytest.
 Cue: Click: slide 11.</a:t>
             </a:r>
             <a:endParaRPr lang="en-US" dirty="0"/>
@@ -696,8 +696,8 @@
           <a:p>
             <a:r>
               <a:rPr lang="en-US" dirty="0"/>
-              <a:t>Speaker: Quan · Quan 2 of 2 · Time: 5:38-6:15 (81 words)
-Here is the roadmap: six iterations. Iteration 2 builds hubs, capacity and the kitchen board. Iteration 3 completes ordering, delivery and the menu. Iteration 4 adds reports and the full demo. Iteration 5 freezes features three days before the Part 2 deadline and keeps one buffer day. Iteration 6 is only for feedback and Part 3, so nothing in Part 2 depends on it. The red marks are the points where we decide. Back to Dat for what we actually delivered.
+              <a:t>Speaker: Quan · Quan 2 of 2 · Time: 5:15-5:52 (80 words)
+Here is the roadmap. Iteration 2 builds hubs, capacity and the kitchen board, which starts my part: the kitchen's confirm or reject. Iteration 3 completes ordering and delivery, and I build the menu management. Iteration 4 adds reports and the full demo. Iteration 5 freezes features before the Part 2 deadline and keeps one buffer day. Iteration 6 is only for feedback and Part 3. The red marks are where we decide. Back to Dat for what we actually delivered.
 Cue: Point at the red diamonds. Hand-over: "Back to Dat for what we actually delivered."</a:t>
             </a:r>
             <a:endParaRPr lang="en-US" dirty="0"/>
@@ -786,8 +786,8 @@
           <a:p>
             <a:r>
               <a:rPr lang="en-US" dirty="0"/>
-              <a:t>Speaker: Dat · Dat 5 of 6 (with slide 13) · Time: 6:15-6:32 (37 words)
-Thank you. Iteration 1 had six days and two people. Each day follows one of the textbook's core processes, from planning to testing. The goal was narrow on purpose: one cash order, at one hub, saved correctly.
+              <a:t>Speaker: Dat · Dat 5 of 6 (with slide 13) · Time: 5:52-6:05 (29 words)
+Thank you. Iteration 1 had six days and two people, one core process per day. The goal was narrow on purpose: one cash order, at one hub, saved correctly.
 Cue: Click: slide 13.</a:t>
             </a:r>
             <a:endParaRPr lang="en-US" dirty="0"/>
@@ -876,8 +876,8 @@
           <a:p>
             <a:r>
               <a:rPr lang="en-US" dirty="0"/>
-              <a:t>Speaker: Dat · Dat 5 of 6 · Time: 6:32-7:16 (95 words)
-Here is what really happened. We built early, on day three, with AI assistance, and we say that openly. The order is saved in one transaction, and a double click still creates one order. Eight of nine criteria are met; the run on a second laptop is still open. Then we reviewed the code ourselves and found a bug the tests had missed: a price that changed after the quote was charged without asking. All 81 tests were green. We fixed it, we now have 90 tests, and every review finding gets its own test.
+              <a:t>Speaker: Dat · Dat 5 of 6 · Time: 6:05-6:47 (91 words)
+Here is what happened. We built early, with AI assistance, and we say that openly. The order is saved in one transaction, and a double click still creates one order. All nine criteria are met; a teammate ran the app and the tests on a Mac with Docker. Then our review found a bug the tests had missed: a price that changed after the quote was charged without asking. All 81 tests were green. We fixed it, the suite now has 93 tests, and every review finding gets its own test.
 Cue: Point at the saved order, then at the Lesson line. Click: slide 14.</a:t>
             </a:r>
             <a:endParaRPr lang="en-US" dirty="0"/>
@@ -966,8 +966,8 @@
           <a:p>
             <a:r>
               <a:rPr lang="en-US" dirty="0"/>
-              <a:t>Speaker: Dat · Dat 6 of 6 (with slide 15) · Time: 7:16-7:51 (75 words)
-Two risks matter most. First, the client may change a rule after we have coded it, so every rule lives in configuration and in the Assumption Log. Second, at the lunch peak two orders can race for the last slot, so the check and the insert run in one transaction, with a boundary test. The other risks, scope, integration and a new member getting started, each have an owner and a warning sign we watch.
+              <a:t>Speaker: Dat · Dat 6 of 6 (with slide 15) · Time: 6:47-7:18 (68 words)
+Two risks matter most. First, the client may change a rule after we code it, so every rule lives in configuration and in the Assumption Log. Second, at the lunch peak two orders can race for the last slot, so in Iteration 2 the check and the insert will run in one transaction, with a boundary test. The other risks each have an owner and a warning sign.
 Cue: Point at R-02 and R-03. Click: slide 15.</a:t>
             </a:r>
             <a:endParaRPr lang="en-US" dirty="0"/>
@@ -1056,8 +1056,8 @@
           <a:p>
             <a:r>
               <a:rPr lang="en-US" dirty="0"/>
-              <a:t>Speaker: Dat · Dat 6 of 6 · Time: 7:51-8:24 (71 words)
-To close, here is what we need. Five client questions, each with our default, so we can keep building while we wait. And five questions for you as our lecturer. The main ones: is analysis plus seed data enough for the classes we do not build, and do you accept our third member and the two new use cases? With your answers by the thirty-first, Iteration 2 starts tomorrow. Thank you.
+              <a:t>Speaker: Dat · Dat 6 of 6 · Time: 7:18-7:50 (69 words)
+To close, here is what we need. Five client questions, each with our default, so we can keep building while we wait. And five questions for you as our lecturer, mainly: is analysis plus seed data enough for the classes we do not build, and do you accept our third member and the two new use cases? With your answers by the thirty-first, Iteration 2 starts tomorrow. Thank you.
 Cue: Stop on this slide for questions.</a:t>
             </a:r>
             <a:endParaRPr lang="en-US" dirty="0"/>
@@ -1146,8 +1146,8 @@
           <a:p>
             <a:r>
               <a:rPr lang="en-US" dirty="0"/>
-              <a:t>Speaker: Dat · Dat 1 of 6 · Time: 0:20-1:05 (98 words)
-It is a quarter to twelve. Linh works in District 1 and orders pho. The District 1 hub has a board full of paper tickets; the Binh Thanh hub, ten minutes away, is half empty. Nobody can see that, so Linh waits an hour. Then the beef runs out, and someone has to phone her. Her cash reaches the hub at the end of the day, sometimes short. Different pains, one root cause: there is no shared order record. So our vision is one order record that the customer, the kitchen, the shipper and the manager all read.
+              <a:t>Speaker: Dat · Dat 1 of 6 · Time: 0:19-1:03 (96 words)
+Imagine it is a quarter to twelve. Linh works in District 1 and orders pho. The District 1 hub has a board full of paper tickets, while another hub nearby is half empty. Nobody can see that, so Linh waits an hour. Then the beef runs out, and someone has to phone her. Her cash reaches the hub at the end of the day, sometimes short. Each pain needs its own rule, but every rule needs the same thing first: one shared order record that the customer, the kitchen, the shipper and the manager all read.
 Cue: Click: slide 3.</a:t>
             </a:r>
             <a:endParaRPr lang="en-US" dirty="0"/>
@@ -1236,8 +1236,8 @@
           <a:p>
             <a:r>
               <a:rPr lang="en-US" dirty="0"/>
-              <a:t>Speaker: Dat · Dat 2 of 6 (with slide 4) · Time: 1:05-1:32 (59 words)
-Here is Linh's order as a business process. Five lanes: customer, platform, kitchen, shipper and office. Do not read the boxes yet; look at the shape. Blue is the normal path, red is where something goes wrong, and grey is in the process but not in this release. I will walk through it in four parts, A to D.
+              <a:t>Speaker: Dat · Dat 2 of 6 (with slide 4) · Time: 1:03-1:25 (47 words)
+Here is Linh's order as a business process, in five lanes: customer, platform, kitchen, shipper and office. Blue is the normal path, red is where something goes wrong, and grey is in the process but not in this release. I will walk through it in four parts.
 Cue: Point at the five lanes, then click: slide 4.</a:t>
             </a:r>
             <a:endParaRPr lang="en-US" dirty="0"/>
@@ -1326,7 +1326,7 @@
           <a:p>
             <a:r>
               <a:rPr lang="en-US" dirty="0"/>
-              <a:t>Speaker: Dat · Dat 2 of 6 · Time: 1:32-2:04 (69 words)
+              <a:t>Speaker: Dat · Dat 2 of 6 · Time: 1:25-1:57 (69 words)
 Part A. Linh picks the District 1 hub, and the platform checks its workload first. If the hub is busy, she is offered a quieter hub before any order exists. Then she sees the full price: food, delivery fee and voucher. She pays cash on delivery, or online through our payment stub; if that fails, she retries or switches to cash. Only then is the order created, as PLACED.
 Cue: Point at "Hub busy?", then at "Create order". Click: slide 5.</a:t>
             </a:r>
@@ -1416,8 +1416,8 @@
           <a:p>
             <a:r>
               <a:rPr lang="en-US" dirty="0"/>
-              <a:t>Speaker: Dat · Dat 3 of 6 · Time: 2:04-2:38 (74 words)
-Part B, the kitchen. The kitchen confirms or rejects. If the beef has run out, the kitchen does not simply cancel: it offers a replacement, and Linh decides. If she says no, the order is rejected. Cash is voided, and an online payment is refunded in full, with no approval needed. Linh can also cancel on her own, but only until cooking starts. That is a separate short activity, Part E in the proposal.
+              <a:t>Speaker: Dat · Dat 3 of 6 · Time: 1:57-2:32 (75 words)
+Part B, the kitchen. The kitchen confirms or rejects. If the beef has run out, the kitchen offers a replacement and Linh decides. If she says no, the order is rejected: cash is voided, and an online payment is owed back in full, with no approval. In this release we record that refund; paying it out comes later. Linh can also cancel herself, but only until cooking starts. That is Part E in the proposal.
 Cue: Point at "Offer item replacement", then at the Part E strip. Click: slide 6.</a:t>
             </a:r>
             <a:endParaRPr lang="en-US" dirty="0"/>
@@ -1506,8 +1506,8 @@
           <a:p>
             <a:r>
               <a:rPr lang="en-US" dirty="0"/>
-              <a:t>Speaker: Dat · Dat 4 of 6 (with slide 7) · Time: 2:38-3:10 (70 words)
-Part C, delivery. The shipper picks up the food and delivers it. This is the point we care about most: delivered is not the same as paid. For a cash order, the shipper records the cash at the door, for that one order. At the end of the shift, office staff check the cash against those records. If the delivery fails, the shipper reports it and brings the food back.
+              <a:t>Speaker: Dat · Dat 4 of 6 (with slide 7) · Time: 2:32-3:02 (65 words)
+Part C, delivery. The shipper picks up and delivers. The point we care about most: delivered is not the same as paid. For a cash order, the shipper records the cash at the door, for that one order. At the end of the shift, office staff check the cash against those records. If the delivery fails, the shipper reports it and brings the food back.
 Cue: Point at "Collect cash", then at "Reconcile". Click: slide 7.</a:t>
             </a:r>
             <a:endParaRPr lang="en-US" dirty="0"/>
@@ -1596,8 +1596,8 @@
           <a:p>
             <a:r>
               <a:rPr lang="en-US" dirty="0"/>
-              <a:t>Speaker: Dat · Dat 4 of 6 · Time: 3:10-3:46 (77 words)
-Part D. Linh gets a receipt, and she can rate the order or complain. A failed delivery settles itself: cash is voided, and online money goes back in full. A complaint is the only case where a person has to decide. Office staff approve a refund, or they deny it and tell Linh why. The reports sit on the side and read the same records. That is the process. Quan L. will show who owns which part.
+              <a:t>Speaker: Dat · Dat 4 of 6 · Time: 3:02-3:35 (72 words)
+Part D. Linh gets a receipt, and she can rate the order or complain. A failed delivery works like a rejection: cash is voided, and online money is owed back in full. A complaint is the only case where a person decides. Office staff approve a refund, or deny it and tell Linh why. Reports sit on the side and read the same records. Quan L. will show who owns which part.
 Cue: Point at "Refund approved?". Hand-over: "Quan L. will show who owns which part."</a:t>
             </a:r>
             <a:endParaRPr lang="en-US" dirty="0"/>
@@ -1686,8 +1686,8 @@
           <a:p>
             <a:r>
               <a:rPr lang="en-US" dirty="0"/>
-              <a:t>Speaker: Quan L. · Quan L. 1 of 2 · Time: 3:46-4:22 (77 words)
-Thank you, Dat. Six people and one outside system touch Linh's order. The customer orders and pays. Kitchen staff confirm, reject or replace, and then cook. The shipper delivers and records the cash. Office staff reconcile that cash and handle complaints. The admin keeps hubs, capacity and menus correct, and the manager reads the reports. The outside system is the payment provider. We simulate it with our own stub, so we can test both success and failure.
+              <a:t>Speaker: Quan L. · Quan L. 1 of 2 · Time: 3:35-4:05 (66 words)
+Thank you, Dat. Six roles and one outside system touch Linh's order. The customer orders and pays. Kitchen staff confirm, reject or replace, then cook. The shipper delivers and records the cash. Office staff reconcile that cash and handle complaints. The admin keeps hubs, capacity and menus correct, and the manager reads the reports. The outside system is the payment provider, which our own stub simulates.
 Cue: Click: slide 9.</a:t>
             </a:r>
             <a:endParaRPr lang="en-US" dirty="0"/>
@@ -1776,8 +1776,8 @@
           <a:p>
             <a:r>
               <a:rPr lang="en-US" dirty="0"/>
-              <a:t>Speaker: Quan L. · Quan L. 2 of 2 · Time: 4:22-5:00 (83 words)
-From these actors we chose six main use cases, two per student, and they cover all four required groups. Dat owns placing an order and managing hubs. I own delivery and the reports. Quan owns the kitchen decision and the menu. To be clear about status: all six are planned for Part 2. Today one is partly built, placing a cash order. Cancelling, vouchers and accounts are analysed only. Complaints, refund payouts and ratings are deferred. Quan will explain how we build it.
+              <a:t>Speaker: Quan L. · Quan L. 2 of 2 · Time: 4:05-4:42 (81 words)
+From these actors we chose six main use cases, two per student, covering all four required groups. Dat owns placing an order and managing hubs. I own delivery and the reports. Quan owns the kitchen decision and the menu. To be clear about status: all six are planned for Part 2. Today one is partly built: placing a cash order. Cancelling and voucher administration are analysed only; complaints, refund payouts and ratings are deferred. Quan will explain how we build it.
 Cue: Point at the status line. Hand-over: "Quan will explain how we build it."</a:t>
             </a:r>
             <a:endParaRPr lang="en-US" dirty="0"/>
@@ -8779,7 +8779,7 @@
                 <a:ea typeface="Arial" pitchFamily="34" charset="-122"/>
                 <a:cs typeface="Arial" pitchFamily="34" charset="-120"/>
               </a:rPr>
-              <a:t>Iteration 1: a COD order saved end to end; 8 of 9 criteria met</a:t>
+              <a:t>Iteration 1: a COD order saved end to end; 9 of 9 criteria met</a:t>
             </a:r>
             <a:endParaRPr lang="en-US" sz="2600" dirty="0"/>
           </a:p>
@@ -9205,7 +9205,7 @@
                           <a:ea typeface="Arial" pitchFamily="34" charset="-122"/>
                           <a:cs typeface="Arial" pitchFamily="34" charset="-120"/>
                         </a:rPr>
-                        <a:t>8 of 9 (AC-1 partial)</a:t>
+                        <a:t>9 of 9</a:t>
                       </a:r>
                       <a:endParaRPr lang="en-US" sz="1600" dirty="0">
                         <a:latin typeface="Arial" charset="0"/>
@@ -9402,7 +9402,7 @@
                           <a:ea typeface="Arial" pitchFamily="34" charset="-122"/>
                           <a:cs typeface="Arial" pitchFamily="34" charset="-120"/>
                         </a:rPr>
-                        <a:t>90 passed, 0 failed</a:t>
+                        <a:t>93 passed, 0 failed</a:t>
                       </a:r>
                       <a:endParaRPr lang="en-US" sz="1600" dirty="0">
                         <a:latin typeface="Arial" charset="0"/>
@@ -9469,7 +9469,7 @@
                           <a:ea typeface="Arial" pitchFamily="34" charset="-122"/>
                           <a:cs typeface="Arial" pitchFamily="34" charset="-120"/>
                         </a:rPr>
-                        <a:t>Clean machine</a:t>
+                        <a:t>Second machine</a:t>
                       </a:r>
                       <a:endParaRPr lang="en-US" sz="1600" dirty="0">
                         <a:latin typeface="Arial" charset="0"/>
@@ -9599,7 +9599,7 @@
                           <a:ea typeface="Arial" pitchFamily="34" charset="-122"/>
                           <a:cs typeface="Arial" pitchFamily="34" charset="-120"/>
                         </a:rPr>
-                        <a:t>Docker passes; laptop by 25/10</a:t>
+                        <a:t>Mac (Docker): app and tests pass</a:t>
                       </a:r>
                       <a:endParaRPr lang="en-US" sz="1600" dirty="0">
                         <a:latin typeface="Arial" charset="0"/>
@@ -9796,7 +9796,7 @@
                           <a:ea typeface="Arial" pitchFamily="34" charset="-122"/>
                           <a:cs typeface="Arial" pitchFamily="34" charset="-120"/>
                         </a:rPr>
-                        <a:t>20/10: 2 defects found, both fixed</a:t>
+                        <a:t>20/10: 3 defects found, all fixed</a:t>
                       </a:r>
                       <a:endParaRPr lang="en-US" sz="1600" dirty="0">
                         <a:latin typeface="Arial" charset="0"/>
@@ -10471,7 +10471,7 @@
                 <a:ea typeface="Arial" pitchFamily="34" charset="-122"/>
                 <a:cs typeface="Arial" pitchFamily="34" charset="-120"/>
               </a:rPr>
-              <a:t>Green tests are not proof: the review found a price bug all 81 tests missed. Each finding now gets a test.</a:t>
+              <a:t>Green tests are not proof: review found a bug 81 tests missed. Every finding now gets a test.</a:t>
             </a:r>
             <a:endParaRPr lang="en-US" sz="1800" dirty="0"/>
           </a:p>
@@ -16583,7 +16583,7 @@
                 <a:ea typeface="Arial" pitchFamily="34" charset="-122"/>
                 <a:cs typeface="Arial" pitchFamily="34" charset="-120"/>
               </a:rPr>
-              <a:t>Failures are refunded in full; only a complaint needs a decision</a:t>
+              <a:t>A failure means a full refund owed; only a complaint needs a decision</a:t>
             </a:r>
             <a:endParaRPr lang="en-US" sz="2600" dirty="0"/>
           </a:p>
@@ -21724,7 +21724,7 @@
                 <a:ea typeface="Arial" pitchFamily="34" charset="-122"/>
                 <a:cs typeface="Arial" pitchFamily="34" charset="-120"/>
               </a:rPr>
-              <a:t>Cancel, vouchers, accounts, order tracking</a:t>
+              <a:t>Cancel, voucher admin, accounts, order tracking</a:t>
             </a:r>
             <a:endParaRPr lang="en-US" sz="1800" dirty="0"/>
           </a:p>

</xml_diff>

<commit_message>
Sync Part 1 package with the final submitted version (third member ID, video and Drive links)
Co-Authored-By: Claude Opus 5.5 <noreply@anthropic.com>
</commit_message>
<xml_diff>
--- a/docs/part1/Team02_Proposal_Slides_for_SaigonBite.pptx
+++ b/docs/part1/Team02_Proposal_Slides_for_SaigonBite.pptx
@@ -517,7 +517,7 @@
             <a:r>
               <a:rPr lang="en-US" dirty="0"/>
               <a:t>Speaker: Dat · Dat 1 of 6 (with slide 2) · Time: 0:00-0:19 (41 words)
-Good morning. We are Team 02. I am Dat, and with me are Quan L. and Quan. Our project is SaigonBite, a delivery platform for cloud kitchens. Let me start with one lunch order, because that order explains the whole project.
+Good morning. We are Team 02. I am Dat, and with me are Quan L. and Quan N.. Our project is SaigonBite, a delivery platform for cloud kitchens. Let me start with one lunch order, because that order explains the whole project.
 Cue: Click: slide 2.</a:t>
             </a:r>
             <a:endParaRPr lang="en-US" dirty="0"/>
@@ -606,7 +606,7 @@
           <a:p>
             <a:r>
               <a:rPr lang="en-US" dirty="0"/>
-              <a:t>Speaker: Quan · Quan 1 of 2 · Time: 4:42-5:15 (71 words)
+              <a:t>Speaker: Quan N. · Quan N. 1 of 2 · Time: 4:42-5:15 (71 words)
 Thank you. The case is incomplete on purpose: capacity limits, fees and payment rules come from the client later. So we work in short iterations. Each one analyses, designs, builds and tests a thin slice, and then we review it together. The riskiest rules come first: capacity in Iteration 2, payment in Iteration 3. The stack is plain on purpose: Python and Flask, three layers, hand-written SQL on SQLite, and pytest.
 Cue: Click: slide 11.</a:t>
             </a:r>
@@ -696,7 +696,7 @@
           <a:p>
             <a:r>
               <a:rPr lang="en-US" dirty="0"/>
-              <a:t>Speaker: Quan · Quan 2 of 2 · Time: 5:15-5:52 (80 words)
+              <a:t>Speaker: Quan N. · Quan N. 2 of 2 · Time: 5:15-5:52 (80 words)
 Here is the roadmap. Iteration 2 builds hubs, capacity and the kitchen board, which starts my part: the kitchen's confirm or reject. Iteration 3 completes ordering and delivery, and I build the menu management. Iteration 4 adds reports and the full demo. Iteration 5 freezes features before the Part 2 deadline and keeps one buffer day. Iteration 6 is only for feedback and Part 3. The red marks are where we decide. Back to Dat for what we actually delivered.
 Cue: Point at the red diamonds. Hand-over: "Back to Dat for what we actually delivered."</a:t>
             </a:r>
@@ -876,8 +876,8 @@
           <a:p>
             <a:r>
               <a:rPr lang="en-US" dirty="0"/>
-              <a:t>Speaker: Dat · Dat 5 of 6 · Time: 6:05-6:47 (91 words)
-Here is what happened. We built early, with AI assistance, and we say that openly. The order is saved in one transaction, and a double click still creates one order. All nine criteria are met; a teammate ran the app and the tests on a Mac with Docker. Then our review found a bug the tests had missed: a price that changed after the quote was charged without asking. All 81 tests were green. We fixed it, the suite now has 93 tests, and every review finding gets its own test.
+              <a:t>Speaker: Dat · Dat 5 of 6 · Time: 6:05-6:49 (96 words)
+Here is what happened. We built early, with AI assistance, and we say that openly. The order is saved in one transaction, and a double click still creates one order. All nine criteria are met; a teammate ran the app and the tests on a Mac with Docker. Then our review found a bug the tests had missed: a price that changed after the quote was charged without asking. All 81 tests were green. We fixed it, the suite grew from 81 to 93 tests by 20 October, and every review finding gets its own test.
 Cue: Point at the saved order, then at the Lesson line. Click: slide 14.</a:t>
             </a:r>
             <a:endParaRPr lang="en-US" dirty="0"/>
@@ -966,7 +966,7 @@
           <a:p>
             <a:r>
               <a:rPr lang="en-US" dirty="0"/>
-              <a:t>Speaker: Dat · Dat 6 of 6 (with slide 15) · Time: 6:47-7:18 (68 words)
+              <a:t>Speaker: Dat · Dat 6 of 6 (with slide 15) · Time: 6:49-7:20 (68 words)
 Two risks matter most. First, the client may change a rule after we code it, so every rule lives in configuration and in the Assumption Log. Second, at the lunch peak two orders can race for the last slot, so in Iteration 2 the check and the insert will run in one transaction, with a boundary test. The other risks each have an owner and a warning sign.
 Cue: Point at R-02 and R-03. Click: slide 15.</a:t>
             </a:r>
@@ -1056,7 +1056,7 @@
           <a:p>
             <a:r>
               <a:rPr lang="en-US" dirty="0"/>
-              <a:t>Speaker: Dat · Dat 6 of 6 · Time: 7:18-7:50 (69 words)
+              <a:t>Speaker: Dat · Dat 6 of 6 · Time: 7:20-7:52 (69 words)
 To close, here is what we need. Five client questions, each with our default, so we can keep building while we wait. And five questions for you as our lecturer, mainly: is analysis plus seed data enough for the classes we do not build, and do you accept our third member and the two new use cases? With your answers by the thirty-first, Iteration 2 starts tomorrow. Thank you.
 Cue: Stop on this slide for questions.</a:t>
             </a:r>
@@ -1236,8 +1236,8 @@
           <a:p>
             <a:r>
               <a:rPr lang="en-US" dirty="0"/>
-              <a:t>Speaker: Dat · Dat 2 of 6 (with slide 4) · Time: 1:03-1:25 (47 words)
-Here is Linh's order as a business process, in five lanes: customer, platform, kitchen, shipper and office. Blue is the normal path, red is where something goes wrong, and grey is in the process but not in this release. I will walk through it in four parts.
+              <a:t>Speaker: Dat · Dat 2 of 6 (with slide 4) · Time: 1:03-1:24 (44 words)
+This is the map of Linh's order, not a slide to read: five lanes, customer, platform, kitchen, shipper and office. Blue is the normal path, red is where something goes wrong, grey is not in this release. The next slides zoom into four parts.
 Cue: Point at the five lanes, then click: slide 4.</a:t>
             </a:r>
             <a:endParaRPr lang="en-US" dirty="0"/>
@@ -1777,8 +1777,8 @@
             <a:r>
               <a:rPr lang="en-US" dirty="0"/>
               <a:t>Speaker: Quan L. · Quan L. 2 of 2 · Time: 4:05-4:42 (81 words)
-From these actors we chose six main use cases, two per student, covering all four required groups. Dat owns placing an order and managing hubs. I own delivery and the reports. Quan owns the kitchen decision and the menu. To be clear about status: all six are planned for Part 2. Today one is partly built: placing a cash order. Cancelling and voucher administration are analysed only; complaints, refund payouts and ratings are deferred. Quan will explain how we build it.
-Cue: Point at the status line. Hand-over: "Quan will explain how we build it."</a:t>
+From these actors we chose six main use cases, two per student, covering all four required groups. Dat owns placing an order and managing hubs. I own delivery and the reports. Quan N. owns the kitchen decision and the menu. To be clear about status: all six are planned for Part 2. Today one is partly built: placing a cash order. Cancelling and voucher administration are analysed only; complaints, refund payouts and ratings are deferred. Quan N. will explain how we build it.
+Cue: Point at the status line. Hand-over: "Quan N. will explain how we build it."</a:t>
             </a:r>
             <a:endParaRPr lang="en-US" dirty="0"/>
           </a:p>
@@ -3004,7 +3004,7 @@
                 <a:ea typeface="Arial" pitchFamily="34" charset="-122"/>
                 <a:cs typeface="Arial" pitchFamily="34" charset="-120"/>
               </a:rPr>
-              <a:t>Quan · ⟦ACTUAL m3_id: student ID⟧</a:t>
+              <a:t>Nguyen Minh Quan · 523K0050</a:t>
             </a:r>
             <a:endParaRPr lang="en-US" sz="1800" dirty="0"/>
           </a:p>
@@ -3060,7 +3060,7 @@
                 <a:ea typeface="Arial" pitchFamily="34" charset="-122"/>
                 <a:cs typeface="Arial" pitchFamily="34" charset="-120"/>
               </a:rPr>
-              <a:t>Team02  ·  Presented live on 26 October 2026</a:t>
+              <a:t>Team02  ·  Part 1 proposal, 26 October 2026</a:t>
             </a:r>
             <a:endParaRPr lang="en-US" sz="1800" dirty="0"/>
           </a:p>
@@ -4081,7 +4081,7 @@
                 <a:ea typeface="Arial" pitchFamily="34" charset="-122"/>
                 <a:cs typeface="Arial" pitchFamily="34" charset="-120"/>
               </a:rPr>
-              <a:t>Lecturer asked to confirm Python</a:t>
+              <a:t>Team choice; pending lecturer confirmation (L4)</a:t>
             </a:r>
             <a:endParaRPr lang="en-US" sz="1800" dirty="0"/>
           </a:p>
@@ -10398,7 +10398,7 @@
                 <a:ea typeface="Arial" pitchFamily="34" charset="-122"/>
                 <a:cs typeface="Arial" pitchFamily="34" charset="-120"/>
               </a:rPr>
-              <a:t>Built early on 19/10 with AI assistance; reviewed and fixed by the team on 20/10/2026.</a:t>
+              <a:t>Built: UC-01 subset only; the other five use cases are planned for Part 2. AI use: Appendix A.</a:t>
             </a:r>
             <a:endParaRPr lang="en-US" sz="1800" dirty="0"/>
           </a:p>
@@ -21001,7 +21001,7 @@
                           <a:ea typeface="Arial" pitchFamily="34" charset="-122"/>
                           <a:cs typeface="Arial" pitchFamily="34" charset="-120"/>
                         </a:rPr>
-                        <a:t>Quan</a:t>
+                        <a:t>Quan N.</a:t>
                       </a:r>
                       <a:endParaRPr lang="en-US" sz="1600" dirty="0">
                         <a:latin typeface="Arial" charset="0"/>
@@ -21393,7 +21393,7 @@
                           <a:ea typeface="Arial" pitchFamily="34" charset="-122"/>
                           <a:cs typeface="Arial" pitchFamily="34" charset="-120"/>
                         </a:rPr>
-                        <a:t>Quan</a:t>
+                        <a:t>Quan N.</a:t>
                       </a:r>
                       <a:endParaRPr lang="en-US" sz="1600" dirty="0">
                         <a:latin typeface="Arial" charset="0"/>
@@ -21710,7 +21710,7 @@
                 <a:ea typeface="Arial" pitchFamily="34" charset="-122"/>
                 <a:cs typeface="Arial" pitchFamily="34" charset="-120"/>
               </a:rPr>
-              <a:t>Analysed only   </a:t>
+              <a:t>Analysed only (pending L1)   </a:t>
             </a:r>
             <a:pPr algn="l" indent="0" marL="0">
               <a:buNone/>
@@ -21783,7 +21783,7 @@
                 <a:ea typeface="Arial" pitchFamily="34" charset="-122"/>
                 <a:cs typeface="Arial" pitchFamily="34" charset="-120"/>
               </a:rPr>
-              <a:t>Deferred   </a:t>
+              <a:t>Deferred (pending L3)   </a:t>
             </a:r>
             <a:pPr algn="l" indent="0" marL="0">
               <a:buNone/>

</xml_diff>